<commit_message>
Añade la diapositiva 2: el mismo caso a tres IA, tres veces
Tabla nativa con celdas por estado (correcto, discutible, error, sin
dato), tarjeta del caso, franja y notas del orador. Se inserta con
insertar_diapositiva.py sin tocar las otras nueve diapositivas, y queda
registrada en build_deck.py. DESIGN.md: tokens de celdas de tabla.

Co-Authored-By: Claude Opus 5.5 <noreply@anthropic.com>
Claude-Session: https://claude.ai/code/session_01JapwXnFbMzAQGkpArhuK67
</commit_message>
<xml_diff>
--- a/examples/sefh-71-ia-tdm/salida/ponencia-ia-tdm-montero.pptx
+++ b/examples/sefh-71-ia-tdm/salida/ponencia-ia-tdm-montero.pptx
@@ -9,6 +9,7 @@
   </p:notesMasterIdLst>
   <p:sldIdLst>
     <p:sldId id="256" r:id="rId5"/>
+    <p:sldId id="265" r:id="rId19"/>
     <p:sldId id="257" r:id="rId8"/>
     <p:sldId id="258" r:id="rId7"/>
     <p:sldId id="259" r:id="rId6"/>
@@ -875,6 +876,76 @@
 </p:notes>
 </file>
 
+<file path=ppt/notesSlides/notesSlide6.xml><?xml version="1.0" encoding="utf-8"?>
+<p:notes xmlns:a="http://schemas.openxmlformats.org/drawingml/2006/main" xmlns:p="http://schemas.openxmlformats.org/presentationml/2006/main" xmlns:r="http://schemas.openxmlformats.org/officeDocument/2006/relationships">
+  <p:cSld>
+    <p:spTree>
+      <p:nvGrpSpPr>
+        <p:cNvPr id="1" name=""/>
+        <p:cNvGrpSpPr/>
+        <p:nvPr/>
+      </p:nvGrpSpPr>
+      <p:grpSpPr>
+        <a:xfrm>
+          <a:off x="0" y="0"/>
+          <a:ext cx="0" cy="0"/>
+          <a:chOff x="0" y="0"/>
+          <a:chExt cx="0" cy="0"/>
+        </a:xfrm>
+      </p:grpSpPr>
+      <p:sp>
+        <p:nvSpPr>
+          <p:cNvPr id="2" name="Slide Image Placeholder 1"/>
+          <p:cNvSpPr>
+            <a:spLocks noGrp="1"/>
+          </p:cNvSpPr>
+          <p:nvPr>
+            <p:ph type="sldImg" idx="2"/>
+          </p:nvPr>
+        </p:nvSpPr>
+        <p:spPr/>
+      </p:sp>
+      <p:sp>
+        <p:nvSpPr>
+          <p:cNvPr id="3" name="Notes Placeholder 2"/>
+          <p:cNvSpPr>
+            <a:spLocks noGrp="1"/>
+          </p:cNvSpPr>
+          <p:nvPr>
+            <p:ph type="body" idx="3" sz="quarter"/>
+          </p:nvPr>
+        </p:nvSpPr>
+        <p:spPr/>
+        <p:txBody>
+          <a:bodyPr/>
+          <a:lstStyle/>
+          <a:p>
+            <a:r>
+              <a:t>Pregunta a mano alzada. La dosis coincidió en todas; cambiaron el AUC, la decisión sobre la dosis de las 20:00, la siguiente extracción y la fuente. Nueve consultas no son un estudio: ¿me pasa solo a mí? → diapositiva siguiente.</a:t>
+            </a:r>
+          </a:p>
+        </p:txBody>
+      </p:sp>
+      <p:sp>
+        <p:nvSpPr>
+          <p:cNvPr id="4" name="Slide Number Placeholder 3"/>
+          <p:cNvSpPr>
+            <a:spLocks noGrp="1"/>
+          </p:cNvSpPr>
+          <p:nvPr>
+            <p:ph type="sldNum" idx="5" sz="quarter"/>
+          </p:nvPr>
+        </p:nvSpPr>
+        <p:spPr/>
+      </p:sp>
+    </p:spTree>
+  </p:cSld>
+  <p:clrMapOvr>
+    <a:masterClrMapping/>
+  </p:clrMapOvr>
+</p:notes>
+</file>
+
 <file path=ppt/slideLayouts/slideLayout1.xml><?xml version="1.0" encoding="utf-8"?>
 <p:sldLayout xmlns:a="http://schemas.openxmlformats.org/drawingml/2006/main" xmlns:r="http://schemas.openxmlformats.org/officeDocument/2006/relationships" xmlns:p="http://schemas.openxmlformats.org/presentationml/2006/main" preserve="1" userDrawn="1">
   <p:cSld name="Title Slide">
@@ -1449,6 +1520,3114 @@
         <p14:creationId xmlns:p14="http://schemas.microsoft.com/office/powerpoint/2010/main" val="4112376270"/>
       </p:ext>
     </p:extLst>
+  </p:cSld>
+  <p:clrMapOvr>
+    <a:masterClrMapping/>
+  </p:clrMapOvr>
+</p:sld>
+</file>
+
+<file path=ppt/slides/slide10.xml><?xml version="1.0" encoding="utf-8"?>
+<p:sld xmlns:a="http://schemas.openxmlformats.org/drawingml/2006/main" xmlns:p="http://schemas.openxmlformats.org/presentationml/2006/main" xmlns:r="http://schemas.openxmlformats.org/officeDocument/2006/relationships">
+  <p:cSld>
+    <p:spTree>
+      <p:nvGrpSpPr>
+        <p:cNvPr id="1" name=""/>
+        <p:cNvGrpSpPr/>
+        <p:nvPr/>
+      </p:nvGrpSpPr>
+      <p:grpSpPr/>
+      <p:sp>
+        <p:nvSpPr>
+          <p:cNvPr id="2" name="Titular"/>
+          <p:cNvSpPr txBox="1"/>
+          <p:nvPr/>
+        </p:nvSpPr>
+        <p:spPr>
+          <a:xfrm>
+            <a:off x="508000" y="749300"/>
+            <a:ext cx="11176000" cy="635000"/>
+          </a:xfrm>
+          <a:prstGeom prst="rect">
+            <a:avLst/>
+          </a:prstGeom>
+          <a:noFill/>
+        </p:spPr>
+        <p:txBody>
+          <a:bodyPr wrap="square" lIns="0" tIns="0" rIns="0" bIns="0" anchor="ctr">
+            <a:noAutofit/>
+          </a:bodyPr>
+          <a:lstStyle/>
+          <a:p>
+            <a:pPr algn="l"/>
+            <a:r>
+              <a:rPr sz="3600" b="1" i="0" lang="es-ES">
+                <a:solidFill>
+                  <a:srgbClr val="263445"/>
+                </a:solidFill>
+              </a:rPr>
+              <a:t>Misma pregunta, misma dosis… decisiones distintas.</a:t>
+            </a:r>
+          </a:p>
+        </p:txBody>
+      </p:sp>
+      <p:sp>
+        <p:nvSpPr>
+          <p:cNvPr id="3" name="Tarjeta caso"/>
+          <p:cNvSpPr/>
+          <p:nvPr/>
+        </p:nvSpPr>
+        <p:spPr>
+          <a:xfrm>
+            <a:off x="508000" y="1778000"/>
+            <a:ext cx="3623818" cy="3771900"/>
+          </a:xfrm>
+          <a:prstGeom prst="roundRect">
+            <a:avLst>
+              <a:gd name="adj" fmla="val 2803"/>
+            </a:avLst>
+          </a:prstGeom>
+          <a:solidFill>
+            <a:srgbClr val="F3F6F9"/>
+          </a:solidFill>
+          <a:ln>
+            <a:noFill/>
+          </a:ln>
+        </p:spPr>
+        <p:txBody>
+          <a:bodyPr rtlCol="0" anchor="ctr"/>
+          <a:lstStyle/>
+          <a:p>
+            <a:pPr algn="ctr"/>
+          </a:p>
+        </p:txBody>
+      </p:sp>
+      <p:sp>
+        <p:nvSpPr>
+          <p:cNvPr id="4" name="Texto caso"/>
+          <p:cNvSpPr txBox="1"/>
+          <p:nvPr/>
+        </p:nvSpPr>
+        <p:spPr>
+          <a:xfrm>
+            <a:off x="711200" y="1981200"/>
+            <a:ext cx="3217418" cy="3111500"/>
+          </a:xfrm>
+          <a:prstGeom prst="rect">
+            <a:avLst/>
+          </a:prstGeom>
+          <a:noFill/>
+        </p:spPr>
+        <p:txBody>
+          <a:bodyPr wrap="square" lIns="0" tIns="0" rIns="0" bIns="0" anchor="t">
+            <a:noAutofit/>
+          </a:bodyPr>
+          <a:lstStyle/>
+          <a:p>
+            <a:pPr algn="l">
+              <a:lnSpc>
+                <a:spcPct val="95000"/>
+              </a:lnSpc>
+              <a:spcAft>
+                <a:spcPts val="600"/>
+              </a:spcAft>
+            </a:pPr>
+            <a:r>
+              <a:rPr sz="2400" b="1" i="0" lang="es-ES">
+                <a:solidFill>
+                  <a:srgbClr val="263445"/>
+                </a:solidFill>
+              </a:rPr>
+              <a:t>El caso</a:t>
+            </a:r>
+          </a:p>
+          <a:p>
+            <a:pPr algn="l">
+              <a:lnSpc>
+                <a:spcPct val="95000"/>
+              </a:lnSpc>
+              <a:spcAft>
+                <a:spcPts val="600"/>
+              </a:spcAft>
+            </a:pPr>
+            <a:r>
+              <a:rPr sz="2000" b="0" i="0" lang="es-ES">
+                <a:solidFill>
+                  <a:srgbClr val="263445"/>
+                </a:solidFill>
+              </a:rPr>
+              <a:t>Varón, 68 años, 82 kg · bacteriemia por SARM</a:t>
+            </a:r>
+          </a:p>
+          <a:p>
+            <a:pPr algn="l">
+              <a:lnSpc>
+                <a:spcPct val="95000"/>
+              </a:lnSpc>
+              <a:spcAft>
+                <a:spcPts val="600"/>
+              </a:spcAft>
+            </a:pPr>
+            <a:r>
+              <a:rPr sz="2000" b="0" i="0" lang="es-ES">
+                <a:solidFill>
+                  <a:srgbClr val="263445"/>
+                </a:solidFill>
+              </a:rPr>
+              <a:t>Creatinina 1,2 mg/dL estable</a:t>
+            </a:r>
+          </a:p>
+          <a:p>
+            <a:pPr algn="l">
+              <a:lnSpc>
+                <a:spcPct val="95000"/>
+              </a:lnSpc>
+              <a:spcAft>
+                <a:spcPts val="600"/>
+              </a:spcAft>
+            </a:pPr>
+            <a:r>
+              <a:rPr sz="2000" b="0" i="0" lang="es-ES">
+                <a:solidFill>
+                  <a:srgbClr val="263445"/>
+                </a:solidFill>
+              </a:rPr>
+              <a:t>1000 mg/12 h · pico 34,0 y valle 21,2 mg/L</a:t>
+            </a:r>
+          </a:p>
+          <a:p>
+            <a:pPr algn="l">
+              <a:lnSpc>
+                <a:spcPct val="95000"/>
+              </a:lnSpc>
+            </a:pPr>
+            <a:r>
+              <a:rPr sz="2000" b="1" i="0" lang="es-ES">
+                <a:solidFill>
+                  <a:srgbClr val="2B7D3D"/>
+                </a:solidFill>
+              </a:rPr>
+              <a:t>Respuesta de referencia: </a:t>
+            </a:r>
+            <a:r>
+              <a:rPr sz="2000" b="0" i="0" lang="es-ES">
+                <a:solidFill>
+                  <a:srgbClr val="263445"/>
+                </a:solidFill>
+              </a:rPr>
+              <a:t>AUC</a:t>
+            </a:r>
+            <a:r>
+              <a:rPr sz="2000" b="0" i="0" lang="es-ES" baseline="-25000">
+                <a:solidFill>
+                  <a:srgbClr val="263445"/>
+                </a:solidFill>
+              </a:rPr>
+              <a:t>24</a:t>
+            </a:r>
+            <a:r>
+              <a:rPr sz="2000" b="0" i="0" lang="es-ES">
+                <a:solidFill>
+                  <a:srgbClr val="263445"/>
+                </a:solidFill>
+              </a:rPr>
+              <a:t> actual ≈ 667 → 750 mg/12 h (AUC</a:t>
+            </a:r>
+            <a:r>
+              <a:rPr sz="2000" b="0" i="0" lang="es-ES" baseline="-25000">
+                <a:solidFill>
+                  <a:srgbClr val="263445"/>
+                </a:solidFill>
+              </a:rPr>
+              <a:t>24</a:t>
+            </a:r>
+            <a:r>
+              <a:rPr sz="2000" b="0" i="0" lang="es-ES">
+                <a:solidFill>
+                  <a:srgbClr val="263445"/>
+                </a:solidFill>
+              </a:rPr>
+              <a:t> ≈ 500)</a:t>
+            </a:r>
+          </a:p>
+        </p:txBody>
+      </p:sp>
+      <p:sp>
+        <p:nvSpPr>
+          <p:cNvPr id="5" name="Nota caso"/>
+          <p:cNvSpPr txBox="1"/>
+          <p:nvPr/>
+        </p:nvSpPr>
+        <p:spPr>
+          <a:xfrm>
+            <a:off x="711200" y="5156200"/>
+            <a:ext cx="3217418" cy="190500"/>
+          </a:xfrm>
+          <a:prstGeom prst="rect">
+            <a:avLst/>
+          </a:prstGeom>
+          <a:noFill/>
+        </p:spPr>
+        <p:txBody>
+          <a:bodyPr wrap="square" lIns="0" tIns="0" rIns="0" bIns="0" anchor="t">
+            <a:noAutofit/>
+          </a:bodyPr>
+          <a:lstStyle/>
+          <a:p>
+            <a:pPr algn="l"/>
+            <a:r>
+              <a:rPr sz="1600" b="0" i="1" lang="es-ES">
+                <a:solidFill>
+                  <a:srgbClr val="5E6B78"/>
+                </a:solidFill>
+              </a:rPr>
+              <a:t>3 IA × 3 chats nuevos · mismo texto</a:t>
+            </a:r>
+          </a:p>
+        </p:txBody>
+      </p:sp>
+      <p:graphicFrame>
+        <p:nvGraphicFramePr>
+          <p:cNvPr id="6" name="Tabla respuestas"/>
+          <p:cNvGraphicFramePr>
+            <a:graphicFrameLocks noGrp="1"/>
+          </p:cNvGraphicFramePr>
+          <p:nvPr/>
+        </p:nvGraphicFramePr>
+        <p:xfrm>
+          <a:off x="4284218" y="1778000"/>
+          <a:ext cx="7397750" cy="3771900"/>
+        </p:xfrm>
+        <a:graphic>
+          <a:graphicData uri="http://schemas.openxmlformats.org/drawingml/2006/table">
+            <a:tbl>
+              <a:tblPr firstRow="1">
+                <a:tableStyleId>{5C22544A-7EE6-4342-B048-85BDC9FD1C3A}</a:tableStyleId>
+              </a:tblPr>
+              <a:tblGrid>
+                <a:gridCol w="889000"/>
+                <a:gridCol w="711200"/>
+                <a:gridCol w="1206500"/>
+                <a:gridCol w="1270000"/>
+                <a:gridCol w="1365250"/>
+                <a:gridCol w="1955800"/>
+              </a:tblGrid>
+              <a:tr h="546100">
+                <a:tc>
+                  <a:txBody>
+                    <a:bodyPr wrap="square"/>
+                    <a:lstStyle/>
+                    <a:p>
+                      <a:pPr algn="l"/>
+                      <a:r>
+                        <a:rPr sz="1600" b="1" i="0" lang="es-ES">
+                          <a:solidFill>
+                            <a:srgbClr val="FFFFFF"/>
+                          </a:solidFill>
+                        </a:rPr>
+                        <a:t>IA</a:t>
+                      </a:r>
+                    </a:p>
+                  </a:txBody>
+                  <a:tcPr anchor="ctr" marL="38100" marR="38100" marT="25400" marB="25400">
+                    <a:lnL w="19050" cap="flat" cmpd="sng" algn="ctr">
+                      <a:solidFill>
+                        <a:srgbClr val="FFFFFF"/>
+                      </a:solidFill>
+                      <a:prstDash val="solid"/>
+                    </a:lnL>
+                    <a:lnR w="19050" cap="flat" cmpd="sng" algn="ctr">
+                      <a:solidFill>
+                        <a:srgbClr val="FFFFFF"/>
+                      </a:solidFill>
+                      <a:prstDash val="solid"/>
+                    </a:lnR>
+                    <a:lnT w="19050" cap="flat" cmpd="sng" algn="ctr">
+                      <a:solidFill>
+                        <a:srgbClr val="FFFFFF"/>
+                      </a:solidFill>
+                      <a:prstDash val="solid"/>
+                    </a:lnT>
+                    <a:lnB w="19050" cap="flat" cmpd="sng" algn="ctr">
+                      <a:solidFill>
+                        <a:srgbClr val="FFFFFF"/>
+                      </a:solidFill>
+                      <a:prstDash val="solid"/>
+                    </a:lnB>
+                    <a:solidFill>
+                      <a:srgbClr val="263445"/>
+                    </a:solidFill>
+                  </a:tcPr>
+                </a:tc>
+                <a:tc>
+                  <a:txBody>
+                    <a:bodyPr wrap="square"/>
+                    <a:lstStyle/>
+                    <a:p>
+                      <a:pPr algn="ctr"/>
+                      <a:r>
+                        <a:rPr sz="1600" b="1" i="0" lang="es-ES">
+                          <a:solidFill>
+                            <a:srgbClr val="FFFFFF"/>
+                          </a:solidFill>
+                        </a:rPr>
+                        <a:t>Prueba</a:t>
+                      </a:r>
+                    </a:p>
+                  </a:txBody>
+                  <a:tcPr anchor="ctr" marL="38100" marR="38100" marT="25400" marB="25400">
+                    <a:lnL w="19050" cap="flat" cmpd="sng" algn="ctr">
+                      <a:solidFill>
+                        <a:srgbClr val="FFFFFF"/>
+                      </a:solidFill>
+                      <a:prstDash val="solid"/>
+                    </a:lnL>
+                    <a:lnR w="19050" cap="flat" cmpd="sng" algn="ctr">
+                      <a:solidFill>
+                        <a:srgbClr val="FFFFFF"/>
+                      </a:solidFill>
+                      <a:prstDash val="solid"/>
+                    </a:lnR>
+                    <a:lnT w="19050" cap="flat" cmpd="sng" algn="ctr">
+                      <a:solidFill>
+                        <a:srgbClr val="FFFFFF"/>
+                      </a:solidFill>
+                      <a:prstDash val="solid"/>
+                    </a:lnT>
+                    <a:lnB w="19050" cap="flat" cmpd="sng" algn="ctr">
+                      <a:solidFill>
+                        <a:srgbClr val="FFFFFF"/>
+                      </a:solidFill>
+                      <a:prstDash val="solid"/>
+                    </a:lnB>
+                    <a:solidFill>
+                      <a:srgbClr val="263445"/>
+                    </a:solidFill>
+                  </a:tcPr>
+                </a:tc>
+                <a:tc>
+                  <a:txBody>
+                    <a:bodyPr wrap="square"/>
+                    <a:lstStyle/>
+                    <a:p>
+                      <a:pPr algn="ctr"/>
+                      <a:r>
+                        <a:rPr sz="1600" b="1" i="0" lang="es-ES">
+                          <a:solidFill>
+                            <a:srgbClr val="FFFFFF"/>
+                          </a:solidFill>
+                        </a:rPr>
+                        <a:t>AUC</a:t>
+                      </a:r>
+                      <a:r>
+                        <a:rPr sz="1600" b="1" i="0" lang="es-ES" baseline="-25000">
+                          <a:solidFill>
+                            <a:srgbClr val="FFFFFF"/>
+                          </a:solidFill>
+                        </a:rPr>
+                        <a:t>24</a:t>
+                      </a:r>
+                      <a:r>
+                        <a:rPr sz="1600" b="1" i="0" lang="es-ES">
+                          <a:solidFill>
+                            <a:srgbClr val="FFFFFF"/>
+                          </a:solidFill>
+                        </a:rPr>
+                        <a:t> actual (ref. 667)</a:t>
+                      </a:r>
+                    </a:p>
+                  </a:txBody>
+                  <a:tcPr anchor="ctr" marL="38100" marR="38100" marT="25400" marB="25400">
+                    <a:lnL w="19050" cap="flat" cmpd="sng" algn="ctr">
+                      <a:solidFill>
+                        <a:srgbClr val="FFFFFF"/>
+                      </a:solidFill>
+                      <a:prstDash val="solid"/>
+                    </a:lnL>
+                    <a:lnR w="19050" cap="flat" cmpd="sng" algn="ctr">
+                      <a:solidFill>
+                        <a:srgbClr val="FFFFFF"/>
+                      </a:solidFill>
+                      <a:prstDash val="solid"/>
+                    </a:lnR>
+                    <a:lnT w="19050" cap="flat" cmpd="sng" algn="ctr">
+                      <a:solidFill>
+                        <a:srgbClr val="FFFFFF"/>
+                      </a:solidFill>
+                      <a:prstDash val="solid"/>
+                    </a:lnT>
+                    <a:lnB w="19050" cap="flat" cmpd="sng" algn="ctr">
+                      <a:solidFill>
+                        <a:srgbClr val="FFFFFF"/>
+                      </a:solidFill>
+                      <a:prstDash val="solid"/>
+                    </a:lnB>
+                    <a:solidFill>
+                      <a:srgbClr val="263445"/>
+                    </a:solidFill>
+                  </a:tcPr>
+                </a:tc>
+                <a:tc>
+                  <a:txBody>
+                    <a:bodyPr wrap="square"/>
+                    <a:lstStyle/>
+                    <a:p>
+                      <a:pPr algn="ctr"/>
+                      <a:r>
+                        <a:rPr sz="1600" b="1" i="0" lang="es-ES">
+                          <a:solidFill>
+                            <a:srgbClr val="FFFFFF"/>
+                          </a:solidFill>
+                        </a:rPr>
+                        <a:t>Dosis de las 20:00</a:t>
+                      </a:r>
+                    </a:p>
+                  </a:txBody>
+                  <a:tcPr anchor="ctr" marL="38100" marR="38100" marT="25400" marB="25400">
+                    <a:lnL w="19050" cap="flat" cmpd="sng" algn="ctr">
+                      <a:solidFill>
+                        <a:srgbClr val="FFFFFF"/>
+                      </a:solidFill>
+                      <a:prstDash val="solid"/>
+                    </a:lnL>
+                    <a:lnR w="19050" cap="flat" cmpd="sng" algn="ctr">
+                      <a:solidFill>
+                        <a:srgbClr val="FFFFFF"/>
+                      </a:solidFill>
+                      <a:prstDash val="solid"/>
+                    </a:lnR>
+                    <a:lnT w="19050" cap="flat" cmpd="sng" algn="ctr">
+                      <a:solidFill>
+                        <a:srgbClr val="FFFFFF"/>
+                      </a:solidFill>
+                      <a:prstDash val="solid"/>
+                    </a:lnT>
+                    <a:lnB w="19050" cap="flat" cmpd="sng" algn="ctr">
+                      <a:solidFill>
+                        <a:srgbClr val="FFFFFF"/>
+                      </a:solidFill>
+                      <a:prstDash val="solid"/>
+                    </a:lnB>
+                    <a:solidFill>
+                      <a:srgbClr val="263445"/>
+                    </a:solidFill>
+                  </a:tcPr>
+                </a:tc>
+                <a:tc>
+                  <a:txBody>
+                    <a:bodyPr wrap="square"/>
+                    <a:lstStyle/>
+                    <a:p>
+                      <a:pPr algn="ctr"/>
+                      <a:r>
+                        <a:rPr sz="1600" b="1" i="0" lang="es-ES">
+                          <a:solidFill>
+                            <a:srgbClr val="FFFFFF"/>
+                          </a:solidFill>
+                        </a:rPr>
+                        <a:t>Siguiente extracción</a:t>
+                      </a:r>
+                    </a:p>
+                  </a:txBody>
+                  <a:tcPr anchor="ctr" marL="38100" marR="38100" marT="25400" marB="25400">
+                    <a:lnL w="19050" cap="flat" cmpd="sng" algn="ctr">
+                      <a:solidFill>
+                        <a:srgbClr val="FFFFFF"/>
+                      </a:solidFill>
+                      <a:prstDash val="solid"/>
+                    </a:lnL>
+                    <a:lnR w="19050" cap="flat" cmpd="sng" algn="ctr">
+                      <a:solidFill>
+                        <a:srgbClr val="FFFFFF"/>
+                      </a:solidFill>
+                      <a:prstDash val="solid"/>
+                    </a:lnR>
+                    <a:lnT w="19050" cap="flat" cmpd="sng" algn="ctr">
+                      <a:solidFill>
+                        <a:srgbClr val="FFFFFF"/>
+                      </a:solidFill>
+                      <a:prstDash val="solid"/>
+                    </a:lnT>
+                    <a:lnB w="19050" cap="flat" cmpd="sng" algn="ctr">
+                      <a:solidFill>
+                        <a:srgbClr val="FFFFFF"/>
+                      </a:solidFill>
+                      <a:prstDash val="solid"/>
+                    </a:lnB>
+                    <a:solidFill>
+                      <a:srgbClr val="263445"/>
+                    </a:solidFill>
+                  </a:tcPr>
+                </a:tc>
+                <a:tc>
+                  <a:txBody>
+                    <a:bodyPr wrap="square"/>
+                    <a:lstStyle/>
+                    <a:p>
+                      <a:pPr algn="ctr"/>
+                      <a:r>
+                        <a:rPr sz="1600" b="1" i="0" lang="es-ES">
+                          <a:solidFill>
+                            <a:srgbClr val="FFFFFF"/>
+                          </a:solidFill>
+                        </a:rPr>
+                        <a:t>Fuente citada</a:t>
+                      </a:r>
+                    </a:p>
+                  </a:txBody>
+                  <a:tcPr anchor="ctr" marL="38100" marR="38100" marT="25400" marB="25400">
+                    <a:lnL w="19050" cap="flat" cmpd="sng" algn="ctr">
+                      <a:solidFill>
+                        <a:srgbClr val="FFFFFF"/>
+                      </a:solidFill>
+                      <a:prstDash val="solid"/>
+                    </a:lnL>
+                    <a:lnR w="19050" cap="flat" cmpd="sng" algn="ctr">
+                      <a:solidFill>
+                        <a:srgbClr val="FFFFFF"/>
+                      </a:solidFill>
+                      <a:prstDash val="solid"/>
+                    </a:lnR>
+                    <a:lnT w="19050" cap="flat" cmpd="sng" algn="ctr">
+                      <a:solidFill>
+                        <a:srgbClr val="FFFFFF"/>
+                      </a:solidFill>
+                      <a:prstDash val="solid"/>
+                    </a:lnT>
+                    <a:lnB w="19050" cap="flat" cmpd="sng" algn="ctr">
+                      <a:solidFill>
+                        <a:srgbClr val="FFFFFF"/>
+                      </a:solidFill>
+                      <a:prstDash val="solid"/>
+                    </a:lnB>
+                    <a:solidFill>
+                      <a:srgbClr val="263445"/>
+                    </a:solidFill>
+                  </a:tcPr>
+                </a:tc>
+              </a:tr>
+              <a:tr h="546100">
+                <a:tc rowSpan="3">
+                  <a:txBody>
+                    <a:bodyPr wrap="square"/>
+                    <a:lstStyle/>
+                    <a:p>
+                      <a:pPr algn="l"/>
+                      <a:r>
+                        <a:rPr sz="1600" b="1" i="0" lang="es-ES">
+                          <a:solidFill>
+                            <a:srgbClr val="263445"/>
+                          </a:solidFill>
+                        </a:rPr>
+                        <a:t>Gemini</a:t>
+                      </a:r>
+                    </a:p>
+                  </a:txBody>
+                  <a:tcPr anchor="ctr" marL="38100" marR="38100" marT="25400" marB="25400">
+                    <a:lnL w="19050" cap="flat" cmpd="sng" algn="ctr">
+                      <a:solidFill>
+                        <a:srgbClr val="FFFFFF"/>
+                      </a:solidFill>
+                      <a:prstDash val="solid"/>
+                    </a:lnL>
+                    <a:lnR w="19050" cap="flat" cmpd="sng" algn="ctr">
+                      <a:solidFill>
+                        <a:srgbClr val="FFFFFF"/>
+                      </a:solidFill>
+                      <a:prstDash val="solid"/>
+                    </a:lnR>
+                    <a:lnT w="19050" cap="flat" cmpd="sng" algn="ctr">
+                      <a:solidFill>
+                        <a:srgbClr val="FFFFFF"/>
+                      </a:solidFill>
+                      <a:prstDash val="solid"/>
+                    </a:lnT>
+                    <a:lnB w="19050" cap="flat" cmpd="sng" algn="ctr">
+                      <a:solidFill>
+                        <a:srgbClr val="FFFFFF"/>
+                      </a:solidFill>
+                      <a:prstDash val="solid"/>
+                    </a:lnB>
+                    <a:solidFill>
+                      <a:srgbClr val="FFFFFF"/>
+                    </a:solidFill>
+                  </a:tcPr>
+                </a:tc>
+                <a:tc>
+                  <a:txBody>
+                    <a:bodyPr wrap="square"/>
+                    <a:lstStyle/>
+                    <a:p>
+                      <a:pPr algn="ctr"/>
+                      <a:r>
+                        <a:rPr sz="1600" b="0" i="0" lang="es-ES">
+                          <a:solidFill>
+                            <a:srgbClr val="263445"/>
+                          </a:solidFill>
+                        </a:rPr>
+                        <a:t>1</a:t>
+                      </a:r>
+                    </a:p>
+                  </a:txBody>
+                  <a:tcPr anchor="ctr" marL="38100" marR="38100" marT="25400" marB="25400">
+                    <a:lnL w="19050" cap="flat" cmpd="sng" algn="ctr">
+                      <a:solidFill>
+                        <a:srgbClr val="FFFFFF"/>
+                      </a:solidFill>
+                      <a:prstDash val="solid"/>
+                    </a:lnL>
+                    <a:lnR w="19050" cap="flat" cmpd="sng" algn="ctr">
+                      <a:solidFill>
+                        <a:srgbClr val="FFFFFF"/>
+                      </a:solidFill>
+                      <a:prstDash val="solid"/>
+                    </a:lnR>
+                    <a:lnT w="19050" cap="flat" cmpd="sng" algn="ctr">
+                      <a:solidFill>
+                        <a:srgbClr val="FFFFFF"/>
+                      </a:solidFill>
+                      <a:prstDash val="solid"/>
+                    </a:lnT>
+                    <a:lnB w="19050" cap="flat" cmpd="sng" algn="ctr">
+                      <a:solidFill>
+                        <a:srgbClr val="FFFFFF"/>
+                      </a:solidFill>
+                      <a:prstDash val="solid"/>
+                    </a:lnB>
+                    <a:solidFill>
+                      <a:srgbClr val="FFFFFF"/>
+                    </a:solidFill>
+                  </a:tcPr>
+                </a:tc>
+                <a:tc>
+                  <a:txBody>
+                    <a:bodyPr wrap="square"/>
+                    <a:lstStyle/>
+                    <a:p>
+                      <a:pPr algn="ctr"/>
+                      <a:r>
+                        <a:rPr sz="1600" b="0" i="0" lang="es-ES">
+                          <a:solidFill>
+                            <a:srgbClr val="263445"/>
+                          </a:solidFill>
+                        </a:rPr>
+                        <a:t>697</a:t>
+                      </a:r>
+                    </a:p>
+                  </a:txBody>
+                  <a:tcPr anchor="ctr" marL="38100" marR="38100" marT="25400" marB="25400">
+                    <a:lnL w="19050" cap="flat" cmpd="sng" algn="ctr">
+                      <a:solidFill>
+                        <a:srgbClr val="FFFFFF"/>
+                      </a:solidFill>
+                      <a:prstDash val="solid"/>
+                    </a:lnL>
+                    <a:lnR w="19050" cap="flat" cmpd="sng" algn="ctr">
+                      <a:solidFill>
+                        <a:srgbClr val="FFFFFF"/>
+                      </a:solidFill>
+                      <a:prstDash val="solid"/>
+                    </a:lnR>
+                    <a:lnT w="19050" cap="flat" cmpd="sng" algn="ctr">
+                      <a:solidFill>
+                        <a:srgbClr val="FFFFFF"/>
+                      </a:solidFill>
+                      <a:prstDash val="solid"/>
+                    </a:lnT>
+                    <a:lnB w="19050" cap="flat" cmpd="sng" algn="ctr">
+                      <a:solidFill>
+                        <a:srgbClr val="FFFFFF"/>
+                      </a:solidFill>
+                      <a:prstDash val="solid"/>
+                    </a:lnB>
+                    <a:solidFill>
+                      <a:srgbClr val="FCE4E6"/>
+                    </a:solidFill>
+                  </a:tcPr>
+                </a:tc>
+                <a:tc>
+                  <a:txBody>
+                    <a:bodyPr wrap="square"/>
+                    <a:lstStyle/>
+                    <a:p>
+                      <a:pPr algn="l"/>
+                      <a:r>
+                        <a:rPr sz="1600" b="0" i="0" lang="es-ES">
+                          <a:solidFill>
+                            <a:srgbClr val="263445"/>
+                          </a:solidFill>
+                        </a:rPr>
+                        <a:t>Darla (750 mg)</a:t>
+                      </a:r>
+                    </a:p>
+                  </a:txBody>
+                  <a:tcPr anchor="ctr" marL="38100" marR="38100" marT="25400" marB="25400">
+                    <a:lnL w="19050" cap="flat" cmpd="sng" algn="ctr">
+                      <a:solidFill>
+                        <a:srgbClr val="FFFFFF"/>
+                      </a:solidFill>
+                      <a:prstDash val="solid"/>
+                    </a:lnL>
+                    <a:lnR w="19050" cap="flat" cmpd="sng" algn="ctr">
+                      <a:solidFill>
+                        <a:srgbClr val="FFFFFF"/>
+                      </a:solidFill>
+                      <a:prstDash val="solid"/>
+                    </a:lnR>
+                    <a:lnT w="19050" cap="flat" cmpd="sng" algn="ctr">
+                      <a:solidFill>
+                        <a:srgbClr val="FFFFFF"/>
+                      </a:solidFill>
+                      <a:prstDash val="solid"/>
+                    </a:lnT>
+                    <a:lnB w="19050" cap="flat" cmpd="sng" algn="ctr">
+                      <a:solidFill>
+                        <a:srgbClr val="FFFFFF"/>
+                      </a:solidFill>
+                      <a:prstDash val="solid"/>
+                    </a:lnB>
+                    <a:solidFill>
+                      <a:srgbClr val="E7F4E9"/>
+                    </a:solidFill>
+                  </a:tcPr>
+                </a:tc>
+                <a:tc>
+                  <a:txBody>
+                    <a:bodyPr wrap="square"/>
+                    <a:lstStyle/>
+                    <a:p>
+                      <a:pPr algn="l"/>
+                      <a:r>
+                        <a:rPr sz="1600" b="0" i="0" lang="es-ES">
+                          <a:solidFill>
+                            <a:srgbClr val="263445"/>
+                          </a:solidFill>
+                        </a:rPr>
+                        <a:t>A las 48-72 h</a:t>
+                      </a:r>
+                    </a:p>
+                  </a:txBody>
+                  <a:tcPr anchor="ctr" marL="38100" marR="38100" marT="25400" marB="25400">
+                    <a:lnL w="19050" cap="flat" cmpd="sng" algn="ctr">
+                      <a:solidFill>
+                        <a:srgbClr val="FFFFFF"/>
+                      </a:solidFill>
+                      <a:prstDash val="solid"/>
+                    </a:lnL>
+                    <a:lnR w="19050" cap="flat" cmpd="sng" algn="ctr">
+                      <a:solidFill>
+                        <a:srgbClr val="FFFFFF"/>
+                      </a:solidFill>
+                      <a:prstDash val="solid"/>
+                    </a:lnR>
+                    <a:lnT w="19050" cap="flat" cmpd="sng" algn="ctr">
+                      <a:solidFill>
+                        <a:srgbClr val="FFFFFF"/>
+                      </a:solidFill>
+                      <a:prstDash val="solid"/>
+                    </a:lnT>
+                    <a:lnB w="19050" cap="flat" cmpd="sng" algn="ctr">
+                      <a:solidFill>
+                        <a:srgbClr val="FFFFFF"/>
+                      </a:solidFill>
+                      <a:prstDash val="solid"/>
+                    </a:lnB>
+                    <a:solidFill>
+                      <a:srgbClr val="E7F4E9"/>
+                    </a:solidFill>
+                  </a:tcPr>
+                </a:tc>
+                <a:tc>
+                  <a:txBody>
+                    <a:bodyPr wrap="square"/>
+                    <a:lstStyle/>
+                    <a:p>
+                      <a:pPr algn="l"/>
+                      <a:r>
+                        <a:rPr sz="1600" b="0" i="0" lang="es-ES">
+                          <a:solidFill>
+                            <a:srgbClr val="263445"/>
+                          </a:solidFill>
+                        </a:rPr>
+                        <a:t>Una guía, como si fuera un modelo</a:t>
+                      </a:r>
+                    </a:p>
+                  </a:txBody>
+                  <a:tcPr anchor="ctr" marL="38100" marR="38100" marT="25400" marB="25400">
+                    <a:lnL w="19050" cap="flat" cmpd="sng" algn="ctr">
+                      <a:solidFill>
+                        <a:srgbClr val="FFFFFF"/>
+                      </a:solidFill>
+                      <a:prstDash val="solid"/>
+                    </a:lnL>
+                    <a:lnR w="19050" cap="flat" cmpd="sng" algn="ctr">
+                      <a:solidFill>
+                        <a:srgbClr val="FFFFFF"/>
+                      </a:solidFill>
+                      <a:prstDash val="solid"/>
+                    </a:lnR>
+                    <a:lnT w="19050" cap="flat" cmpd="sng" algn="ctr">
+                      <a:solidFill>
+                        <a:srgbClr val="FFFFFF"/>
+                      </a:solidFill>
+                      <a:prstDash val="solid"/>
+                    </a:lnT>
+                    <a:lnB w="19050" cap="flat" cmpd="sng" algn="ctr">
+                      <a:solidFill>
+                        <a:srgbClr val="FFFFFF"/>
+                      </a:solidFill>
+                      <a:prstDash val="solid"/>
+                    </a:lnB>
+                    <a:solidFill>
+                      <a:srgbClr val="FCE4E6"/>
+                    </a:solidFill>
+                  </a:tcPr>
+                </a:tc>
+              </a:tr>
+              <a:tr h="304800">
+                <a:tc vMerge="1">
+                  <a:txBody>
+                    <a:bodyPr wrap="square"/>
+                    <a:lstStyle/>
+                    <a:p/>
+                  </a:txBody>
+                  <a:tcPr anchor="ctr" marL="38100" marR="38100" marT="25400" marB="25400">
+                    <a:lnL w="19050" cap="flat" cmpd="sng" algn="ctr">
+                      <a:solidFill>
+                        <a:srgbClr val="FFFFFF"/>
+                      </a:solidFill>
+                      <a:prstDash val="solid"/>
+                    </a:lnL>
+                    <a:lnR w="19050" cap="flat" cmpd="sng" algn="ctr">
+                      <a:solidFill>
+                        <a:srgbClr val="FFFFFF"/>
+                      </a:solidFill>
+                      <a:prstDash val="solid"/>
+                    </a:lnR>
+                    <a:lnT w="19050" cap="flat" cmpd="sng" algn="ctr">
+                      <a:solidFill>
+                        <a:srgbClr val="FFFFFF"/>
+                      </a:solidFill>
+                      <a:prstDash val="solid"/>
+                    </a:lnT>
+                    <a:lnB w="19050" cap="flat" cmpd="sng" algn="ctr">
+                      <a:solidFill>
+                        <a:srgbClr val="FFFFFF"/>
+                      </a:solidFill>
+                      <a:prstDash val="solid"/>
+                    </a:lnB>
+                    <a:solidFill>
+                      <a:srgbClr val="FFFFFF"/>
+                    </a:solidFill>
+                  </a:tcPr>
+                </a:tc>
+                <a:tc>
+                  <a:txBody>
+                    <a:bodyPr wrap="square"/>
+                    <a:lstStyle/>
+                    <a:p>
+                      <a:pPr algn="ctr"/>
+                      <a:r>
+                        <a:rPr sz="1600" b="0" i="0" lang="es-ES">
+                          <a:solidFill>
+                            <a:srgbClr val="263445"/>
+                          </a:solidFill>
+                        </a:rPr>
+                        <a:t>2</a:t>
+                      </a:r>
+                    </a:p>
+                  </a:txBody>
+                  <a:tcPr anchor="ctr" marL="38100" marR="38100" marT="25400" marB="25400">
+                    <a:lnL w="19050" cap="flat" cmpd="sng" algn="ctr">
+                      <a:solidFill>
+                        <a:srgbClr val="FFFFFF"/>
+                      </a:solidFill>
+                      <a:prstDash val="solid"/>
+                    </a:lnL>
+                    <a:lnR w="19050" cap="flat" cmpd="sng" algn="ctr">
+                      <a:solidFill>
+                        <a:srgbClr val="FFFFFF"/>
+                      </a:solidFill>
+                      <a:prstDash val="solid"/>
+                    </a:lnR>
+                    <a:lnT w="19050" cap="flat" cmpd="sng" algn="ctr">
+                      <a:solidFill>
+                        <a:srgbClr val="FFFFFF"/>
+                      </a:solidFill>
+                      <a:prstDash val="solid"/>
+                    </a:lnT>
+                    <a:lnB w="19050" cap="flat" cmpd="sng" algn="ctr">
+                      <a:solidFill>
+                        <a:srgbClr val="FFFFFF"/>
+                      </a:solidFill>
+                      <a:prstDash val="solid"/>
+                    </a:lnB>
+                    <a:solidFill>
+                      <a:srgbClr val="FFFFFF"/>
+                    </a:solidFill>
+                  </a:tcPr>
+                </a:tc>
+                <a:tc>
+                  <a:txBody>
+                    <a:bodyPr wrap="square"/>
+                    <a:lstStyle/>
+                    <a:p>
+                      <a:pPr algn="ctr"/>
+                      <a:r>
+                        <a:rPr sz="1600" b="0" i="0" lang="es-ES">
+                          <a:solidFill>
+                            <a:srgbClr val="263445"/>
+                          </a:solidFill>
+                        </a:rPr>
+                        <a:t>662</a:t>
+                      </a:r>
+                    </a:p>
+                  </a:txBody>
+                  <a:tcPr anchor="ctr" marL="38100" marR="38100" marT="25400" marB="25400">
+                    <a:lnL w="19050" cap="flat" cmpd="sng" algn="ctr">
+                      <a:solidFill>
+                        <a:srgbClr val="FFFFFF"/>
+                      </a:solidFill>
+                      <a:prstDash val="solid"/>
+                    </a:lnL>
+                    <a:lnR w="19050" cap="flat" cmpd="sng" algn="ctr">
+                      <a:solidFill>
+                        <a:srgbClr val="FFFFFF"/>
+                      </a:solidFill>
+                      <a:prstDash val="solid"/>
+                    </a:lnR>
+                    <a:lnT w="19050" cap="flat" cmpd="sng" algn="ctr">
+                      <a:solidFill>
+                        <a:srgbClr val="FFFFFF"/>
+                      </a:solidFill>
+                      <a:prstDash val="solid"/>
+                    </a:lnT>
+                    <a:lnB w="19050" cap="flat" cmpd="sng" algn="ctr">
+                      <a:solidFill>
+                        <a:srgbClr val="FFFFFF"/>
+                      </a:solidFill>
+                      <a:prstDash val="solid"/>
+                    </a:lnB>
+                    <a:solidFill>
+                      <a:srgbClr val="E7F4E9"/>
+                    </a:solidFill>
+                  </a:tcPr>
+                </a:tc>
+                <a:tc>
+                  <a:txBody>
+                    <a:bodyPr wrap="square"/>
+                    <a:lstStyle/>
+                    <a:p>
+                      <a:pPr algn="l"/>
+                      <a:r>
+                        <a:rPr sz="1600" b="0" i="0" lang="es-ES">
+                          <a:solidFill>
+                            <a:srgbClr val="263445"/>
+                          </a:solidFill>
+                        </a:rPr>
+                        <a:t>Omitirla</a:t>
+                      </a:r>
+                    </a:p>
+                  </a:txBody>
+                  <a:tcPr anchor="ctr" marL="38100" marR="38100" marT="25400" marB="25400">
+                    <a:lnL w="19050" cap="flat" cmpd="sng" algn="ctr">
+                      <a:solidFill>
+                        <a:srgbClr val="FFFFFF"/>
+                      </a:solidFill>
+                      <a:prstDash val="solid"/>
+                    </a:lnL>
+                    <a:lnR w="19050" cap="flat" cmpd="sng" algn="ctr">
+                      <a:solidFill>
+                        <a:srgbClr val="FFFFFF"/>
+                      </a:solidFill>
+                      <a:prstDash val="solid"/>
+                    </a:lnR>
+                    <a:lnT w="19050" cap="flat" cmpd="sng" algn="ctr">
+                      <a:solidFill>
+                        <a:srgbClr val="FFFFFF"/>
+                      </a:solidFill>
+                      <a:prstDash val="solid"/>
+                    </a:lnT>
+                    <a:lnB w="19050" cap="flat" cmpd="sng" algn="ctr">
+                      <a:solidFill>
+                        <a:srgbClr val="FFFFFF"/>
+                      </a:solidFill>
+                      <a:prstDash val="solid"/>
+                    </a:lnB>
+                    <a:solidFill>
+                      <a:srgbClr val="FCEFD1"/>
+                    </a:solidFill>
+                  </a:tcPr>
+                </a:tc>
+                <a:tc>
+                  <a:txBody>
+                    <a:bodyPr wrap="square"/>
+                    <a:lstStyle/>
+                    <a:p>
+                      <a:pPr algn="l"/>
+                      <a:r>
+                        <a:rPr sz="1600" b="0" i="0" lang="es-ES">
+                          <a:solidFill>
+                            <a:srgbClr val="263445"/>
+                          </a:solidFill>
+                        </a:rPr>
+                        <a:t>Día 5, 20:00</a:t>
+                      </a:r>
+                    </a:p>
+                  </a:txBody>
+                  <a:tcPr anchor="ctr" marL="38100" marR="38100" marT="25400" marB="25400">
+                    <a:lnL w="19050" cap="flat" cmpd="sng" algn="ctr">
+                      <a:solidFill>
+                        <a:srgbClr val="FFFFFF"/>
+                      </a:solidFill>
+                      <a:prstDash val="solid"/>
+                    </a:lnL>
+                    <a:lnR w="19050" cap="flat" cmpd="sng" algn="ctr">
+                      <a:solidFill>
+                        <a:srgbClr val="FFFFFF"/>
+                      </a:solidFill>
+                      <a:prstDash val="solid"/>
+                    </a:lnR>
+                    <a:lnT w="19050" cap="flat" cmpd="sng" algn="ctr">
+                      <a:solidFill>
+                        <a:srgbClr val="FFFFFF"/>
+                      </a:solidFill>
+                      <a:prstDash val="solid"/>
+                    </a:lnT>
+                    <a:lnB w="19050" cap="flat" cmpd="sng" algn="ctr">
+                      <a:solidFill>
+                        <a:srgbClr val="FFFFFF"/>
+                      </a:solidFill>
+                      <a:prstDash val="solid"/>
+                    </a:lnB>
+                    <a:solidFill>
+                      <a:srgbClr val="FCEFD1"/>
+                    </a:solidFill>
+                  </a:tcPr>
+                </a:tc>
+                <a:tc>
+                  <a:txBody>
+                    <a:bodyPr wrap="square"/>
+                    <a:lstStyle/>
+                    <a:p>
+                      <a:pPr algn="l"/>
+                      <a:r>
+                        <a:rPr sz="1600" b="0" i="0" lang="es-ES">
+                          <a:solidFill>
+                            <a:srgbClr val="263445"/>
+                          </a:solidFill>
+                        </a:rPr>
+                        <a:t>Ecuación mal aplicada</a:t>
+                      </a:r>
+                    </a:p>
+                  </a:txBody>
+                  <a:tcPr anchor="ctr" marL="38100" marR="38100" marT="25400" marB="25400">
+                    <a:lnL w="19050" cap="flat" cmpd="sng" algn="ctr">
+                      <a:solidFill>
+                        <a:srgbClr val="FFFFFF"/>
+                      </a:solidFill>
+                      <a:prstDash val="solid"/>
+                    </a:lnL>
+                    <a:lnR w="19050" cap="flat" cmpd="sng" algn="ctr">
+                      <a:solidFill>
+                        <a:srgbClr val="FFFFFF"/>
+                      </a:solidFill>
+                      <a:prstDash val="solid"/>
+                    </a:lnR>
+                    <a:lnT w="19050" cap="flat" cmpd="sng" algn="ctr">
+                      <a:solidFill>
+                        <a:srgbClr val="FFFFFF"/>
+                      </a:solidFill>
+                      <a:prstDash val="solid"/>
+                    </a:lnT>
+                    <a:lnB w="19050" cap="flat" cmpd="sng" algn="ctr">
+                      <a:solidFill>
+                        <a:srgbClr val="FFFFFF"/>
+                      </a:solidFill>
+                      <a:prstDash val="solid"/>
+                    </a:lnB>
+                    <a:solidFill>
+                      <a:srgbClr val="FCE4E6"/>
+                    </a:solidFill>
+                  </a:tcPr>
+                </a:tc>
+              </a:tr>
+              <a:tr h="546100">
+                <a:tc vMerge="1">
+                  <a:txBody>
+                    <a:bodyPr wrap="square"/>
+                    <a:lstStyle/>
+                    <a:p/>
+                  </a:txBody>
+                  <a:tcPr anchor="ctr" marL="38100" marR="38100" marT="25400" marB="25400">
+                    <a:lnL w="19050" cap="flat" cmpd="sng" algn="ctr">
+                      <a:solidFill>
+                        <a:srgbClr val="FFFFFF"/>
+                      </a:solidFill>
+                      <a:prstDash val="solid"/>
+                    </a:lnL>
+                    <a:lnR w="19050" cap="flat" cmpd="sng" algn="ctr">
+                      <a:solidFill>
+                        <a:srgbClr val="FFFFFF"/>
+                      </a:solidFill>
+                      <a:prstDash val="solid"/>
+                    </a:lnR>
+                    <a:lnT w="19050" cap="flat" cmpd="sng" algn="ctr">
+                      <a:solidFill>
+                        <a:srgbClr val="FFFFFF"/>
+                      </a:solidFill>
+                      <a:prstDash val="solid"/>
+                    </a:lnT>
+                    <a:lnB w="19050" cap="flat" cmpd="sng" algn="ctr">
+                      <a:solidFill>
+                        <a:srgbClr val="FFFFFF"/>
+                      </a:solidFill>
+                      <a:prstDash val="solid"/>
+                    </a:lnB>
+                    <a:solidFill>
+                      <a:srgbClr val="FFFFFF"/>
+                    </a:solidFill>
+                  </a:tcPr>
+                </a:tc>
+                <a:tc>
+                  <a:txBody>
+                    <a:bodyPr wrap="square"/>
+                    <a:lstStyle/>
+                    <a:p>
+                      <a:pPr algn="ctr"/>
+                      <a:r>
+                        <a:rPr sz="1600" b="0" i="0" lang="es-ES">
+                          <a:solidFill>
+                            <a:srgbClr val="263445"/>
+                          </a:solidFill>
+                        </a:rPr>
+                        <a:t>3</a:t>
+                      </a:r>
+                    </a:p>
+                  </a:txBody>
+                  <a:tcPr anchor="ctr" marL="38100" marR="38100" marT="25400" marB="25400">
+                    <a:lnL w="19050" cap="flat" cmpd="sng" algn="ctr">
+                      <a:solidFill>
+                        <a:srgbClr val="FFFFFF"/>
+                      </a:solidFill>
+                      <a:prstDash val="solid"/>
+                    </a:lnL>
+                    <a:lnR w="19050" cap="flat" cmpd="sng" algn="ctr">
+                      <a:solidFill>
+                        <a:srgbClr val="FFFFFF"/>
+                      </a:solidFill>
+                      <a:prstDash val="solid"/>
+                    </a:lnR>
+                    <a:lnT w="19050" cap="flat" cmpd="sng" algn="ctr">
+                      <a:solidFill>
+                        <a:srgbClr val="FFFFFF"/>
+                      </a:solidFill>
+                      <a:prstDash val="solid"/>
+                    </a:lnT>
+                    <a:lnB w="19050" cap="flat" cmpd="sng" algn="ctr">
+                      <a:solidFill>
+                        <a:srgbClr val="FFFFFF"/>
+                      </a:solidFill>
+                      <a:prstDash val="solid"/>
+                    </a:lnB>
+                    <a:solidFill>
+                      <a:srgbClr val="FFFFFF"/>
+                    </a:solidFill>
+                  </a:tcPr>
+                </a:tc>
+                <a:tc>
+                  <a:txBody>
+                    <a:bodyPr wrap="square"/>
+                    <a:lstStyle/>
+                    <a:p>
+                      <a:pPr algn="ctr"/>
+                      <a:r>
+                        <a:rPr sz="1600" b="0" i="0" lang="es-ES">
+                          <a:solidFill>
+                            <a:srgbClr val="263445"/>
+                          </a:solidFill>
+                        </a:rPr>
+                        <a:t>662</a:t>
+                      </a:r>
+                    </a:p>
+                  </a:txBody>
+                  <a:tcPr anchor="ctr" marL="38100" marR="38100" marT="25400" marB="25400">
+                    <a:lnL w="19050" cap="flat" cmpd="sng" algn="ctr">
+                      <a:solidFill>
+                        <a:srgbClr val="FFFFFF"/>
+                      </a:solidFill>
+                      <a:prstDash val="solid"/>
+                    </a:lnL>
+                    <a:lnR w="19050" cap="flat" cmpd="sng" algn="ctr">
+                      <a:solidFill>
+                        <a:srgbClr val="FFFFFF"/>
+                      </a:solidFill>
+                      <a:prstDash val="solid"/>
+                    </a:lnR>
+                    <a:lnT w="19050" cap="flat" cmpd="sng" algn="ctr">
+                      <a:solidFill>
+                        <a:srgbClr val="FFFFFF"/>
+                      </a:solidFill>
+                      <a:prstDash val="solid"/>
+                    </a:lnT>
+                    <a:lnB w="19050" cap="flat" cmpd="sng" algn="ctr">
+                      <a:solidFill>
+                        <a:srgbClr val="FFFFFF"/>
+                      </a:solidFill>
+                      <a:prstDash val="solid"/>
+                    </a:lnB>
+                    <a:solidFill>
+                      <a:srgbClr val="E7F4E9"/>
+                    </a:solidFill>
+                  </a:tcPr>
+                </a:tc>
+                <a:tc>
+                  <a:txBody>
+                    <a:bodyPr wrap="square"/>
+                    <a:lstStyle/>
+                    <a:p>
+                      <a:pPr algn="l"/>
+                      <a:r>
+                        <a:rPr sz="1600" b="0" i="0" lang="es-ES">
+                          <a:solidFill>
+                            <a:srgbClr val="263445"/>
+                          </a:solidFill>
+                        </a:rPr>
+                        <a:t>Omitirla</a:t>
+                      </a:r>
+                    </a:p>
+                  </a:txBody>
+                  <a:tcPr anchor="ctr" marL="38100" marR="38100" marT="25400" marB="25400">
+                    <a:lnL w="19050" cap="flat" cmpd="sng" algn="ctr">
+                      <a:solidFill>
+                        <a:srgbClr val="FFFFFF"/>
+                      </a:solidFill>
+                      <a:prstDash val="solid"/>
+                    </a:lnL>
+                    <a:lnR w="19050" cap="flat" cmpd="sng" algn="ctr">
+                      <a:solidFill>
+                        <a:srgbClr val="FFFFFF"/>
+                      </a:solidFill>
+                      <a:prstDash val="solid"/>
+                    </a:lnR>
+                    <a:lnT w="19050" cap="flat" cmpd="sng" algn="ctr">
+                      <a:solidFill>
+                        <a:srgbClr val="FFFFFF"/>
+                      </a:solidFill>
+                      <a:prstDash val="solid"/>
+                    </a:lnT>
+                    <a:lnB w="19050" cap="flat" cmpd="sng" algn="ctr">
+                      <a:solidFill>
+                        <a:srgbClr val="FFFFFF"/>
+                      </a:solidFill>
+                      <a:prstDash val="solid"/>
+                    </a:lnB>
+                    <a:solidFill>
+                      <a:srgbClr val="FCEFD1"/>
+                    </a:solidFill>
+                  </a:tcPr>
+                </a:tc>
+                <a:tc>
+                  <a:txBody>
+                    <a:bodyPr wrap="square"/>
+                    <a:lstStyle/>
+                    <a:p>
+                      <a:pPr algn="l"/>
+                      <a:r>
+                        <a:rPr sz="1600" b="0" i="0" lang="es-ES">
+                          <a:solidFill>
+                            <a:srgbClr val="263445"/>
+                          </a:solidFill>
+                        </a:rPr>
+                        <a:t>Día 5, 08:00 («equilibrio»)</a:t>
+                      </a:r>
+                    </a:p>
+                  </a:txBody>
+                  <a:tcPr anchor="ctr" marL="38100" marR="38100" marT="25400" marB="25400">
+                    <a:lnL w="19050" cap="flat" cmpd="sng" algn="ctr">
+                      <a:solidFill>
+                        <a:srgbClr val="FFFFFF"/>
+                      </a:solidFill>
+                      <a:prstDash val="solid"/>
+                    </a:lnL>
+                    <a:lnR w="19050" cap="flat" cmpd="sng" algn="ctr">
+                      <a:solidFill>
+                        <a:srgbClr val="FFFFFF"/>
+                      </a:solidFill>
+                      <a:prstDash val="solid"/>
+                    </a:lnR>
+                    <a:lnT w="19050" cap="flat" cmpd="sng" algn="ctr">
+                      <a:solidFill>
+                        <a:srgbClr val="FFFFFF"/>
+                      </a:solidFill>
+                      <a:prstDash val="solid"/>
+                    </a:lnT>
+                    <a:lnB w="19050" cap="flat" cmpd="sng" algn="ctr">
+                      <a:solidFill>
+                        <a:srgbClr val="FFFFFF"/>
+                      </a:solidFill>
+                      <a:prstDash val="solid"/>
+                    </a:lnB>
+                    <a:solidFill>
+                      <a:srgbClr val="FCE4E6"/>
+                    </a:solidFill>
+                  </a:tcPr>
+                </a:tc>
+                <a:tc>
+                  <a:txBody>
+                    <a:bodyPr wrap="square"/>
+                    <a:lstStyle/>
+                    <a:p>
+                      <a:pPr algn="l"/>
+                      <a:r>
+                        <a:rPr sz="1600" b="0" i="0" lang="es-ES">
+                          <a:solidFill>
+                            <a:srgbClr val="5E6B78"/>
+                          </a:solidFill>
+                        </a:rPr>
+                        <a:t>Ninguna</a:t>
+                      </a:r>
+                    </a:p>
+                  </a:txBody>
+                  <a:tcPr anchor="ctr" marL="38100" marR="38100" marT="25400" marB="25400">
+                    <a:lnL w="19050" cap="flat" cmpd="sng" algn="ctr">
+                      <a:solidFill>
+                        <a:srgbClr val="FFFFFF"/>
+                      </a:solidFill>
+                      <a:prstDash val="solid"/>
+                    </a:lnL>
+                    <a:lnR w="19050" cap="flat" cmpd="sng" algn="ctr">
+                      <a:solidFill>
+                        <a:srgbClr val="FFFFFF"/>
+                      </a:solidFill>
+                      <a:prstDash val="solid"/>
+                    </a:lnR>
+                    <a:lnT w="19050" cap="flat" cmpd="sng" algn="ctr">
+                      <a:solidFill>
+                        <a:srgbClr val="FFFFFF"/>
+                      </a:solidFill>
+                      <a:prstDash val="solid"/>
+                    </a:lnT>
+                    <a:lnB w="19050" cap="flat" cmpd="sng" algn="ctr">
+                      <a:solidFill>
+                        <a:srgbClr val="FFFFFF"/>
+                      </a:solidFill>
+                      <a:prstDash val="solid"/>
+                    </a:lnB>
+                    <a:solidFill>
+                      <a:srgbClr val="F3F6F9"/>
+                    </a:solidFill>
+                  </a:tcPr>
+                </a:tc>
+              </a:tr>
+              <a:tr h="304800">
+                <a:tc rowSpan="3">
+                  <a:txBody>
+                    <a:bodyPr wrap="square"/>
+                    <a:lstStyle/>
+                    <a:p>
+                      <a:pPr algn="l"/>
+                      <a:r>
+                        <a:rPr sz="1600" b="1" i="0" lang="es-ES">
+                          <a:solidFill>
+                            <a:srgbClr val="263445"/>
+                          </a:solidFill>
+                        </a:rPr>
+                        <a:t>Claude</a:t>
+                      </a:r>
+                    </a:p>
+                  </a:txBody>
+                  <a:tcPr anchor="ctr" marL="38100" marR="38100" marT="25400" marB="25400">
+                    <a:lnL w="19050" cap="flat" cmpd="sng" algn="ctr">
+                      <a:solidFill>
+                        <a:srgbClr val="FFFFFF"/>
+                      </a:solidFill>
+                      <a:prstDash val="solid"/>
+                    </a:lnL>
+                    <a:lnR w="19050" cap="flat" cmpd="sng" algn="ctr">
+                      <a:solidFill>
+                        <a:srgbClr val="FFFFFF"/>
+                      </a:solidFill>
+                      <a:prstDash val="solid"/>
+                    </a:lnR>
+                    <a:lnT w="31750" cap="flat" cmpd="sng" algn="ctr">
+                      <a:solidFill>
+                        <a:srgbClr val="263445"/>
+                      </a:solidFill>
+                      <a:prstDash val="solid"/>
+                    </a:lnT>
+                    <a:lnB w="19050" cap="flat" cmpd="sng" algn="ctr">
+                      <a:solidFill>
+                        <a:srgbClr val="FFFFFF"/>
+                      </a:solidFill>
+                      <a:prstDash val="solid"/>
+                    </a:lnB>
+                    <a:solidFill>
+                      <a:srgbClr val="FFFFFF"/>
+                    </a:solidFill>
+                  </a:tcPr>
+                </a:tc>
+                <a:tc>
+                  <a:txBody>
+                    <a:bodyPr wrap="square"/>
+                    <a:lstStyle/>
+                    <a:p>
+                      <a:pPr algn="ctr"/>
+                      <a:r>
+                        <a:rPr sz="1600" b="0" i="0" lang="es-ES">
+                          <a:solidFill>
+                            <a:srgbClr val="263445"/>
+                          </a:solidFill>
+                        </a:rPr>
+                        <a:t>1</a:t>
+                      </a:r>
+                    </a:p>
+                  </a:txBody>
+                  <a:tcPr anchor="ctr" marL="38100" marR="38100" marT="25400" marB="25400">
+                    <a:lnL w="19050" cap="flat" cmpd="sng" algn="ctr">
+                      <a:solidFill>
+                        <a:srgbClr val="FFFFFF"/>
+                      </a:solidFill>
+                      <a:prstDash val="solid"/>
+                    </a:lnL>
+                    <a:lnR w="19050" cap="flat" cmpd="sng" algn="ctr">
+                      <a:solidFill>
+                        <a:srgbClr val="FFFFFF"/>
+                      </a:solidFill>
+                      <a:prstDash val="solid"/>
+                    </a:lnR>
+                    <a:lnT w="31750" cap="flat" cmpd="sng" algn="ctr">
+                      <a:solidFill>
+                        <a:srgbClr val="263445"/>
+                      </a:solidFill>
+                      <a:prstDash val="solid"/>
+                    </a:lnT>
+                    <a:lnB w="19050" cap="flat" cmpd="sng" algn="ctr">
+                      <a:solidFill>
+                        <a:srgbClr val="FFFFFF"/>
+                      </a:solidFill>
+                      <a:prstDash val="solid"/>
+                    </a:lnB>
+                    <a:solidFill>
+                      <a:srgbClr val="FFFFFF"/>
+                    </a:solidFill>
+                  </a:tcPr>
+                </a:tc>
+                <a:tc>
+                  <a:txBody>
+                    <a:bodyPr wrap="square"/>
+                    <a:lstStyle/>
+                    <a:p>
+                      <a:pPr algn="ctr"/>
+                      <a:r>
+                        <a:rPr sz="1600" b="0" i="0" lang="es-ES">
+                          <a:solidFill>
+                            <a:srgbClr val="5E6B78"/>
+                          </a:solidFill>
+                        </a:rPr>
+                        <a:t>[pendiente]</a:t>
+                      </a:r>
+                    </a:p>
+                  </a:txBody>
+                  <a:tcPr anchor="ctr" marL="38100" marR="38100" marT="25400" marB="25400">
+                    <a:lnL w="19050" cap="flat" cmpd="sng" algn="ctr">
+                      <a:solidFill>
+                        <a:srgbClr val="FFFFFF"/>
+                      </a:solidFill>
+                      <a:prstDash val="solid"/>
+                    </a:lnL>
+                    <a:lnR w="19050" cap="flat" cmpd="sng" algn="ctr">
+                      <a:solidFill>
+                        <a:srgbClr val="FFFFFF"/>
+                      </a:solidFill>
+                      <a:prstDash val="solid"/>
+                    </a:lnR>
+                    <a:lnT w="31750" cap="flat" cmpd="sng" algn="ctr">
+                      <a:solidFill>
+                        <a:srgbClr val="263445"/>
+                      </a:solidFill>
+                      <a:prstDash val="solid"/>
+                    </a:lnT>
+                    <a:lnB w="19050" cap="flat" cmpd="sng" algn="ctr">
+                      <a:solidFill>
+                        <a:srgbClr val="FFFFFF"/>
+                      </a:solidFill>
+                      <a:prstDash val="solid"/>
+                    </a:lnB>
+                    <a:solidFill>
+                      <a:srgbClr val="F3F6F9"/>
+                    </a:solidFill>
+                  </a:tcPr>
+                </a:tc>
+                <a:tc>
+                  <a:txBody>
+                    <a:bodyPr wrap="square"/>
+                    <a:lstStyle/>
+                    <a:p>
+                      <a:pPr algn="l"/>
+                      <a:r>
+                        <a:rPr sz="1600" b="0" i="0" lang="es-ES">
+                          <a:solidFill>
+                            <a:srgbClr val="5E6B78"/>
+                          </a:solidFill>
+                        </a:rPr>
+                        <a:t>[pendiente]</a:t>
+                      </a:r>
+                    </a:p>
+                  </a:txBody>
+                  <a:tcPr anchor="ctr" marL="38100" marR="38100" marT="25400" marB="25400">
+                    <a:lnL w="19050" cap="flat" cmpd="sng" algn="ctr">
+                      <a:solidFill>
+                        <a:srgbClr val="FFFFFF"/>
+                      </a:solidFill>
+                      <a:prstDash val="solid"/>
+                    </a:lnL>
+                    <a:lnR w="19050" cap="flat" cmpd="sng" algn="ctr">
+                      <a:solidFill>
+                        <a:srgbClr val="FFFFFF"/>
+                      </a:solidFill>
+                      <a:prstDash val="solid"/>
+                    </a:lnR>
+                    <a:lnT w="31750" cap="flat" cmpd="sng" algn="ctr">
+                      <a:solidFill>
+                        <a:srgbClr val="263445"/>
+                      </a:solidFill>
+                      <a:prstDash val="solid"/>
+                    </a:lnT>
+                    <a:lnB w="19050" cap="flat" cmpd="sng" algn="ctr">
+                      <a:solidFill>
+                        <a:srgbClr val="FFFFFF"/>
+                      </a:solidFill>
+                      <a:prstDash val="solid"/>
+                    </a:lnB>
+                    <a:solidFill>
+                      <a:srgbClr val="F3F6F9"/>
+                    </a:solidFill>
+                  </a:tcPr>
+                </a:tc>
+                <a:tc>
+                  <a:txBody>
+                    <a:bodyPr wrap="square"/>
+                    <a:lstStyle/>
+                    <a:p>
+                      <a:pPr algn="l"/>
+                      <a:r>
+                        <a:rPr sz="1600" b="0" i="0" lang="es-ES">
+                          <a:solidFill>
+                            <a:srgbClr val="5E6B78"/>
+                          </a:solidFill>
+                        </a:rPr>
+                        <a:t>[pendiente]</a:t>
+                      </a:r>
+                    </a:p>
+                  </a:txBody>
+                  <a:tcPr anchor="ctr" marL="38100" marR="38100" marT="25400" marB="25400">
+                    <a:lnL w="19050" cap="flat" cmpd="sng" algn="ctr">
+                      <a:solidFill>
+                        <a:srgbClr val="FFFFFF"/>
+                      </a:solidFill>
+                      <a:prstDash val="solid"/>
+                    </a:lnL>
+                    <a:lnR w="19050" cap="flat" cmpd="sng" algn="ctr">
+                      <a:solidFill>
+                        <a:srgbClr val="FFFFFF"/>
+                      </a:solidFill>
+                      <a:prstDash val="solid"/>
+                    </a:lnR>
+                    <a:lnT w="31750" cap="flat" cmpd="sng" algn="ctr">
+                      <a:solidFill>
+                        <a:srgbClr val="263445"/>
+                      </a:solidFill>
+                      <a:prstDash val="solid"/>
+                    </a:lnT>
+                    <a:lnB w="19050" cap="flat" cmpd="sng" algn="ctr">
+                      <a:solidFill>
+                        <a:srgbClr val="FFFFFF"/>
+                      </a:solidFill>
+                      <a:prstDash val="solid"/>
+                    </a:lnB>
+                    <a:solidFill>
+                      <a:srgbClr val="F3F6F9"/>
+                    </a:solidFill>
+                  </a:tcPr>
+                </a:tc>
+                <a:tc>
+                  <a:txBody>
+                    <a:bodyPr wrap="square"/>
+                    <a:lstStyle/>
+                    <a:p>
+                      <a:pPr algn="l"/>
+                      <a:r>
+                        <a:rPr sz="1600" b="0" i="0" lang="es-ES">
+                          <a:solidFill>
+                            <a:srgbClr val="5E6B78"/>
+                          </a:solidFill>
+                        </a:rPr>
+                        <a:t>[pendiente]</a:t>
+                      </a:r>
+                    </a:p>
+                  </a:txBody>
+                  <a:tcPr anchor="ctr" marL="38100" marR="38100" marT="25400" marB="25400">
+                    <a:lnL w="19050" cap="flat" cmpd="sng" algn="ctr">
+                      <a:solidFill>
+                        <a:srgbClr val="FFFFFF"/>
+                      </a:solidFill>
+                      <a:prstDash val="solid"/>
+                    </a:lnL>
+                    <a:lnR w="19050" cap="flat" cmpd="sng" algn="ctr">
+                      <a:solidFill>
+                        <a:srgbClr val="FFFFFF"/>
+                      </a:solidFill>
+                      <a:prstDash val="solid"/>
+                    </a:lnR>
+                    <a:lnT w="31750" cap="flat" cmpd="sng" algn="ctr">
+                      <a:solidFill>
+                        <a:srgbClr val="263445"/>
+                      </a:solidFill>
+                      <a:prstDash val="solid"/>
+                    </a:lnT>
+                    <a:lnB w="19050" cap="flat" cmpd="sng" algn="ctr">
+                      <a:solidFill>
+                        <a:srgbClr val="FFFFFF"/>
+                      </a:solidFill>
+                      <a:prstDash val="solid"/>
+                    </a:lnB>
+                    <a:solidFill>
+                      <a:srgbClr val="F3F6F9"/>
+                    </a:solidFill>
+                  </a:tcPr>
+                </a:tc>
+              </a:tr>
+              <a:tr h="304800">
+                <a:tc vMerge="1">
+                  <a:txBody>
+                    <a:bodyPr wrap="square"/>
+                    <a:lstStyle/>
+                    <a:p/>
+                  </a:txBody>
+                  <a:tcPr anchor="ctr" marL="38100" marR="38100" marT="25400" marB="25400">
+                    <a:lnL w="19050" cap="flat" cmpd="sng" algn="ctr">
+                      <a:solidFill>
+                        <a:srgbClr val="FFFFFF"/>
+                      </a:solidFill>
+                      <a:prstDash val="solid"/>
+                    </a:lnL>
+                    <a:lnR w="19050" cap="flat" cmpd="sng" algn="ctr">
+                      <a:solidFill>
+                        <a:srgbClr val="FFFFFF"/>
+                      </a:solidFill>
+                      <a:prstDash val="solid"/>
+                    </a:lnR>
+                    <a:lnT w="19050" cap="flat" cmpd="sng" algn="ctr">
+                      <a:solidFill>
+                        <a:srgbClr val="FFFFFF"/>
+                      </a:solidFill>
+                      <a:prstDash val="solid"/>
+                    </a:lnT>
+                    <a:lnB w="19050" cap="flat" cmpd="sng" algn="ctr">
+                      <a:solidFill>
+                        <a:srgbClr val="FFFFFF"/>
+                      </a:solidFill>
+                      <a:prstDash val="solid"/>
+                    </a:lnB>
+                    <a:solidFill>
+                      <a:srgbClr val="FFFFFF"/>
+                    </a:solidFill>
+                  </a:tcPr>
+                </a:tc>
+                <a:tc>
+                  <a:txBody>
+                    <a:bodyPr wrap="square"/>
+                    <a:lstStyle/>
+                    <a:p>
+                      <a:pPr algn="ctr"/>
+                      <a:r>
+                        <a:rPr sz="1600" b="0" i="0" lang="es-ES">
+                          <a:solidFill>
+                            <a:srgbClr val="263445"/>
+                          </a:solidFill>
+                        </a:rPr>
+                        <a:t>2</a:t>
+                      </a:r>
+                    </a:p>
+                  </a:txBody>
+                  <a:tcPr anchor="ctr" marL="38100" marR="38100" marT="25400" marB="25400">
+                    <a:lnL w="19050" cap="flat" cmpd="sng" algn="ctr">
+                      <a:solidFill>
+                        <a:srgbClr val="FFFFFF"/>
+                      </a:solidFill>
+                      <a:prstDash val="solid"/>
+                    </a:lnL>
+                    <a:lnR w="19050" cap="flat" cmpd="sng" algn="ctr">
+                      <a:solidFill>
+                        <a:srgbClr val="FFFFFF"/>
+                      </a:solidFill>
+                      <a:prstDash val="solid"/>
+                    </a:lnR>
+                    <a:lnT w="19050" cap="flat" cmpd="sng" algn="ctr">
+                      <a:solidFill>
+                        <a:srgbClr val="FFFFFF"/>
+                      </a:solidFill>
+                      <a:prstDash val="solid"/>
+                    </a:lnT>
+                    <a:lnB w="19050" cap="flat" cmpd="sng" algn="ctr">
+                      <a:solidFill>
+                        <a:srgbClr val="FFFFFF"/>
+                      </a:solidFill>
+                      <a:prstDash val="solid"/>
+                    </a:lnB>
+                    <a:solidFill>
+                      <a:srgbClr val="FFFFFF"/>
+                    </a:solidFill>
+                  </a:tcPr>
+                </a:tc>
+                <a:tc>
+                  <a:txBody>
+                    <a:bodyPr wrap="square"/>
+                    <a:lstStyle/>
+                    <a:p>
+                      <a:pPr algn="ctr"/>
+                      <a:r>
+                        <a:rPr sz="1600" b="0" i="0" lang="es-ES">
+                          <a:solidFill>
+                            <a:srgbClr val="5E6B78"/>
+                          </a:solidFill>
+                        </a:rPr>
+                        <a:t>[pendiente]</a:t>
+                      </a:r>
+                    </a:p>
+                  </a:txBody>
+                  <a:tcPr anchor="ctr" marL="38100" marR="38100" marT="25400" marB="25400">
+                    <a:lnL w="19050" cap="flat" cmpd="sng" algn="ctr">
+                      <a:solidFill>
+                        <a:srgbClr val="FFFFFF"/>
+                      </a:solidFill>
+                      <a:prstDash val="solid"/>
+                    </a:lnL>
+                    <a:lnR w="19050" cap="flat" cmpd="sng" algn="ctr">
+                      <a:solidFill>
+                        <a:srgbClr val="FFFFFF"/>
+                      </a:solidFill>
+                      <a:prstDash val="solid"/>
+                    </a:lnR>
+                    <a:lnT w="19050" cap="flat" cmpd="sng" algn="ctr">
+                      <a:solidFill>
+                        <a:srgbClr val="FFFFFF"/>
+                      </a:solidFill>
+                      <a:prstDash val="solid"/>
+                    </a:lnT>
+                    <a:lnB w="19050" cap="flat" cmpd="sng" algn="ctr">
+                      <a:solidFill>
+                        <a:srgbClr val="FFFFFF"/>
+                      </a:solidFill>
+                      <a:prstDash val="solid"/>
+                    </a:lnB>
+                    <a:solidFill>
+                      <a:srgbClr val="F3F6F9"/>
+                    </a:solidFill>
+                  </a:tcPr>
+                </a:tc>
+                <a:tc>
+                  <a:txBody>
+                    <a:bodyPr wrap="square"/>
+                    <a:lstStyle/>
+                    <a:p>
+                      <a:pPr algn="l"/>
+                      <a:r>
+                        <a:rPr sz="1600" b="0" i="0" lang="es-ES">
+                          <a:solidFill>
+                            <a:srgbClr val="5E6B78"/>
+                          </a:solidFill>
+                        </a:rPr>
+                        <a:t>[pendiente]</a:t>
+                      </a:r>
+                    </a:p>
+                  </a:txBody>
+                  <a:tcPr anchor="ctr" marL="38100" marR="38100" marT="25400" marB="25400">
+                    <a:lnL w="19050" cap="flat" cmpd="sng" algn="ctr">
+                      <a:solidFill>
+                        <a:srgbClr val="FFFFFF"/>
+                      </a:solidFill>
+                      <a:prstDash val="solid"/>
+                    </a:lnL>
+                    <a:lnR w="19050" cap="flat" cmpd="sng" algn="ctr">
+                      <a:solidFill>
+                        <a:srgbClr val="FFFFFF"/>
+                      </a:solidFill>
+                      <a:prstDash val="solid"/>
+                    </a:lnR>
+                    <a:lnT w="19050" cap="flat" cmpd="sng" algn="ctr">
+                      <a:solidFill>
+                        <a:srgbClr val="FFFFFF"/>
+                      </a:solidFill>
+                      <a:prstDash val="solid"/>
+                    </a:lnT>
+                    <a:lnB w="19050" cap="flat" cmpd="sng" algn="ctr">
+                      <a:solidFill>
+                        <a:srgbClr val="FFFFFF"/>
+                      </a:solidFill>
+                      <a:prstDash val="solid"/>
+                    </a:lnB>
+                    <a:solidFill>
+                      <a:srgbClr val="F3F6F9"/>
+                    </a:solidFill>
+                  </a:tcPr>
+                </a:tc>
+                <a:tc>
+                  <a:txBody>
+                    <a:bodyPr wrap="square"/>
+                    <a:lstStyle/>
+                    <a:p>
+                      <a:pPr algn="l"/>
+                      <a:r>
+                        <a:rPr sz="1600" b="0" i="0" lang="es-ES">
+                          <a:solidFill>
+                            <a:srgbClr val="5E6B78"/>
+                          </a:solidFill>
+                        </a:rPr>
+                        <a:t>[pendiente]</a:t>
+                      </a:r>
+                    </a:p>
+                  </a:txBody>
+                  <a:tcPr anchor="ctr" marL="38100" marR="38100" marT="25400" marB="25400">
+                    <a:lnL w="19050" cap="flat" cmpd="sng" algn="ctr">
+                      <a:solidFill>
+                        <a:srgbClr val="FFFFFF"/>
+                      </a:solidFill>
+                      <a:prstDash val="solid"/>
+                    </a:lnL>
+                    <a:lnR w="19050" cap="flat" cmpd="sng" algn="ctr">
+                      <a:solidFill>
+                        <a:srgbClr val="FFFFFF"/>
+                      </a:solidFill>
+                      <a:prstDash val="solid"/>
+                    </a:lnR>
+                    <a:lnT w="19050" cap="flat" cmpd="sng" algn="ctr">
+                      <a:solidFill>
+                        <a:srgbClr val="FFFFFF"/>
+                      </a:solidFill>
+                      <a:prstDash val="solid"/>
+                    </a:lnT>
+                    <a:lnB w="19050" cap="flat" cmpd="sng" algn="ctr">
+                      <a:solidFill>
+                        <a:srgbClr val="FFFFFF"/>
+                      </a:solidFill>
+                      <a:prstDash val="solid"/>
+                    </a:lnB>
+                    <a:solidFill>
+                      <a:srgbClr val="F3F6F9"/>
+                    </a:solidFill>
+                  </a:tcPr>
+                </a:tc>
+                <a:tc>
+                  <a:txBody>
+                    <a:bodyPr wrap="square"/>
+                    <a:lstStyle/>
+                    <a:p>
+                      <a:pPr algn="l"/>
+                      <a:r>
+                        <a:rPr sz="1600" b="0" i="0" lang="es-ES">
+                          <a:solidFill>
+                            <a:srgbClr val="5E6B78"/>
+                          </a:solidFill>
+                        </a:rPr>
+                        <a:t>[pendiente]</a:t>
+                      </a:r>
+                    </a:p>
+                  </a:txBody>
+                  <a:tcPr anchor="ctr" marL="38100" marR="38100" marT="25400" marB="25400">
+                    <a:lnL w="19050" cap="flat" cmpd="sng" algn="ctr">
+                      <a:solidFill>
+                        <a:srgbClr val="FFFFFF"/>
+                      </a:solidFill>
+                      <a:prstDash val="solid"/>
+                    </a:lnL>
+                    <a:lnR w="19050" cap="flat" cmpd="sng" algn="ctr">
+                      <a:solidFill>
+                        <a:srgbClr val="FFFFFF"/>
+                      </a:solidFill>
+                      <a:prstDash val="solid"/>
+                    </a:lnR>
+                    <a:lnT w="19050" cap="flat" cmpd="sng" algn="ctr">
+                      <a:solidFill>
+                        <a:srgbClr val="FFFFFF"/>
+                      </a:solidFill>
+                      <a:prstDash val="solid"/>
+                    </a:lnT>
+                    <a:lnB w="19050" cap="flat" cmpd="sng" algn="ctr">
+                      <a:solidFill>
+                        <a:srgbClr val="FFFFFF"/>
+                      </a:solidFill>
+                      <a:prstDash val="solid"/>
+                    </a:lnB>
+                    <a:solidFill>
+                      <a:srgbClr val="F3F6F9"/>
+                    </a:solidFill>
+                  </a:tcPr>
+                </a:tc>
+              </a:tr>
+              <a:tr h="304800">
+                <a:tc vMerge="1">
+                  <a:txBody>
+                    <a:bodyPr wrap="square"/>
+                    <a:lstStyle/>
+                    <a:p/>
+                  </a:txBody>
+                  <a:tcPr anchor="ctr" marL="38100" marR="38100" marT="25400" marB="25400">
+                    <a:lnL w="19050" cap="flat" cmpd="sng" algn="ctr">
+                      <a:solidFill>
+                        <a:srgbClr val="FFFFFF"/>
+                      </a:solidFill>
+                      <a:prstDash val="solid"/>
+                    </a:lnL>
+                    <a:lnR w="19050" cap="flat" cmpd="sng" algn="ctr">
+                      <a:solidFill>
+                        <a:srgbClr val="FFFFFF"/>
+                      </a:solidFill>
+                      <a:prstDash val="solid"/>
+                    </a:lnR>
+                    <a:lnT w="19050" cap="flat" cmpd="sng" algn="ctr">
+                      <a:solidFill>
+                        <a:srgbClr val="FFFFFF"/>
+                      </a:solidFill>
+                      <a:prstDash val="solid"/>
+                    </a:lnT>
+                    <a:lnB w="19050" cap="flat" cmpd="sng" algn="ctr">
+                      <a:solidFill>
+                        <a:srgbClr val="FFFFFF"/>
+                      </a:solidFill>
+                      <a:prstDash val="solid"/>
+                    </a:lnB>
+                    <a:solidFill>
+                      <a:srgbClr val="FFFFFF"/>
+                    </a:solidFill>
+                  </a:tcPr>
+                </a:tc>
+                <a:tc>
+                  <a:txBody>
+                    <a:bodyPr wrap="square"/>
+                    <a:lstStyle/>
+                    <a:p>
+                      <a:pPr algn="ctr"/>
+                      <a:r>
+                        <a:rPr sz="1600" b="0" i="0" lang="es-ES">
+                          <a:solidFill>
+                            <a:srgbClr val="263445"/>
+                          </a:solidFill>
+                        </a:rPr>
+                        <a:t>3</a:t>
+                      </a:r>
+                    </a:p>
+                  </a:txBody>
+                  <a:tcPr anchor="ctr" marL="38100" marR="38100" marT="25400" marB="25400">
+                    <a:lnL w="19050" cap="flat" cmpd="sng" algn="ctr">
+                      <a:solidFill>
+                        <a:srgbClr val="FFFFFF"/>
+                      </a:solidFill>
+                      <a:prstDash val="solid"/>
+                    </a:lnL>
+                    <a:lnR w="19050" cap="flat" cmpd="sng" algn="ctr">
+                      <a:solidFill>
+                        <a:srgbClr val="FFFFFF"/>
+                      </a:solidFill>
+                      <a:prstDash val="solid"/>
+                    </a:lnR>
+                    <a:lnT w="19050" cap="flat" cmpd="sng" algn="ctr">
+                      <a:solidFill>
+                        <a:srgbClr val="FFFFFF"/>
+                      </a:solidFill>
+                      <a:prstDash val="solid"/>
+                    </a:lnT>
+                    <a:lnB w="19050" cap="flat" cmpd="sng" algn="ctr">
+                      <a:solidFill>
+                        <a:srgbClr val="FFFFFF"/>
+                      </a:solidFill>
+                      <a:prstDash val="solid"/>
+                    </a:lnB>
+                    <a:solidFill>
+                      <a:srgbClr val="FFFFFF"/>
+                    </a:solidFill>
+                  </a:tcPr>
+                </a:tc>
+                <a:tc>
+                  <a:txBody>
+                    <a:bodyPr wrap="square"/>
+                    <a:lstStyle/>
+                    <a:p>
+                      <a:pPr algn="ctr"/>
+                      <a:r>
+                        <a:rPr sz="1600" b="0" i="0" lang="es-ES">
+                          <a:solidFill>
+                            <a:srgbClr val="5E6B78"/>
+                          </a:solidFill>
+                        </a:rPr>
+                        <a:t>[pendiente]</a:t>
+                      </a:r>
+                    </a:p>
+                  </a:txBody>
+                  <a:tcPr anchor="ctr" marL="38100" marR="38100" marT="25400" marB="25400">
+                    <a:lnL w="19050" cap="flat" cmpd="sng" algn="ctr">
+                      <a:solidFill>
+                        <a:srgbClr val="FFFFFF"/>
+                      </a:solidFill>
+                      <a:prstDash val="solid"/>
+                    </a:lnL>
+                    <a:lnR w="19050" cap="flat" cmpd="sng" algn="ctr">
+                      <a:solidFill>
+                        <a:srgbClr val="FFFFFF"/>
+                      </a:solidFill>
+                      <a:prstDash val="solid"/>
+                    </a:lnR>
+                    <a:lnT w="19050" cap="flat" cmpd="sng" algn="ctr">
+                      <a:solidFill>
+                        <a:srgbClr val="FFFFFF"/>
+                      </a:solidFill>
+                      <a:prstDash val="solid"/>
+                    </a:lnT>
+                    <a:lnB w="19050" cap="flat" cmpd="sng" algn="ctr">
+                      <a:solidFill>
+                        <a:srgbClr val="FFFFFF"/>
+                      </a:solidFill>
+                      <a:prstDash val="solid"/>
+                    </a:lnB>
+                    <a:solidFill>
+                      <a:srgbClr val="F3F6F9"/>
+                    </a:solidFill>
+                  </a:tcPr>
+                </a:tc>
+                <a:tc>
+                  <a:txBody>
+                    <a:bodyPr wrap="square"/>
+                    <a:lstStyle/>
+                    <a:p>
+                      <a:pPr algn="l"/>
+                      <a:r>
+                        <a:rPr sz="1600" b="0" i="0" lang="es-ES">
+                          <a:solidFill>
+                            <a:srgbClr val="5E6B78"/>
+                          </a:solidFill>
+                        </a:rPr>
+                        <a:t>[pendiente]</a:t>
+                      </a:r>
+                    </a:p>
+                  </a:txBody>
+                  <a:tcPr anchor="ctr" marL="38100" marR="38100" marT="25400" marB="25400">
+                    <a:lnL w="19050" cap="flat" cmpd="sng" algn="ctr">
+                      <a:solidFill>
+                        <a:srgbClr val="FFFFFF"/>
+                      </a:solidFill>
+                      <a:prstDash val="solid"/>
+                    </a:lnL>
+                    <a:lnR w="19050" cap="flat" cmpd="sng" algn="ctr">
+                      <a:solidFill>
+                        <a:srgbClr val="FFFFFF"/>
+                      </a:solidFill>
+                      <a:prstDash val="solid"/>
+                    </a:lnR>
+                    <a:lnT w="19050" cap="flat" cmpd="sng" algn="ctr">
+                      <a:solidFill>
+                        <a:srgbClr val="FFFFFF"/>
+                      </a:solidFill>
+                      <a:prstDash val="solid"/>
+                    </a:lnT>
+                    <a:lnB w="19050" cap="flat" cmpd="sng" algn="ctr">
+                      <a:solidFill>
+                        <a:srgbClr val="FFFFFF"/>
+                      </a:solidFill>
+                      <a:prstDash val="solid"/>
+                    </a:lnB>
+                    <a:solidFill>
+                      <a:srgbClr val="F3F6F9"/>
+                    </a:solidFill>
+                  </a:tcPr>
+                </a:tc>
+                <a:tc>
+                  <a:txBody>
+                    <a:bodyPr wrap="square"/>
+                    <a:lstStyle/>
+                    <a:p>
+                      <a:pPr algn="l"/>
+                      <a:r>
+                        <a:rPr sz="1600" b="0" i="0" lang="es-ES">
+                          <a:solidFill>
+                            <a:srgbClr val="5E6B78"/>
+                          </a:solidFill>
+                        </a:rPr>
+                        <a:t>[pendiente]</a:t>
+                      </a:r>
+                    </a:p>
+                  </a:txBody>
+                  <a:tcPr anchor="ctr" marL="38100" marR="38100" marT="25400" marB="25400">
+                    <a:lnL w="19050" cap="flat" cmpd="sng" algn="ctr">
+                      <a:solidFill>
+                        <a:srgbClr val="FFFFFF"/>
+                      </a:solidFill>
+                      <a:prstDash val="solid"/>
+                    </a:lnL>
+                    <a:lnR w="19050" cap="flat" cmpd="sng" algn="ctr">
+                      <a:solidFill>
+                        <a:srgbClr val="FFFFFF"/>
+                      </a:solidFill>
+                      <a:prstDash val="solid"/>
+                    </a:lnR>
+                    <a:lnT w="19050" cap="flat" cmpd="sng" algn="ctr">
+                      <a:solidFill>
+                        <a:srgbClr val="FFFFFF"/>
+                      </a:solidFill>
+                      <a:prstDash val="solid"/>
+                    </a:lnT>
+                    <a:lnB w="19050" cap="flat" cmpd="sng" algn="ctr">
+                      <a:solidFill>
+                        <a:srgbClr val="FFFFFF"/>
+                      </a:solidFill>
+                      <a:prstDash val="solid"/>
+                    </a:lnB>
+                    <a:solidFill>
+                      <a:srgbClr val="F3F6F9"/>
+                    </a:solidFill>
+                  </a:tcPr>
+                </a:tc>
+                <a:tc>
+                  <a:txBody>
+                    <a:bodyPr wrap="square"/>
+                    <a:lstStyle/>
+                    <a:p>
+                      <a:pPr algn="l"/>
+                      <a:r>
+                        <a:rPr sz="1600" b="0" i="0" lang="es-ES">
+                          <a:solidFill>
+                            <a:srgbClr val="5E6B78"/>
+                          </a:solidFill>
+                        </a:rPr>
+                        <a:t>[pendiente]</a:t>
+                      </a:r>
+                    </a:p>
+                  </a:txBody>
+                  <a:tcPr anchor="ctr" marL="38100" marR="38100" marT="25400" marB="25400">
+                    <a:lnL w="19050" cap="flat" cmpd="sng" algn="ctr">
+                      <a:solidFill>
+                        <a:srgbClr val="FFFFFF"/>
+                      </a:solidFill>
+                      <a:prstDash val="solid"/>
+                    </a:lnL>
+                    <a:lnR w="19050" cap="flat" cmpd="sng" algn="ctr">
+                      <a:solidFill>
+                        <a:srgbClr val="FFFFFF"/>
+                      </a:solidFill>
+                      <a:prstDash val="solid"/>
+                    </a:lnR>
+                    <a:lnT w="19050" cap="flat" cmpd="sng" algn="ctr">
+                      <a:solidFill>
+                        <a:srgbClr val="FFFFFF"/>
+                      </a:solidFill>
+                      <a:prstDash val="solid"/>
+                    </a:lnT>
+                    <a:lnB w="19050" cap="flat" cmpd="sng" algn="ctr">
+                      <a:solidFill>
+                        <a:srgbClr val="FFFFFF"/>
+                      </a:solidFill>
+                      <a:prstDash val="solid"/>
+                    </a:lnB>
+                    <a:solidFill>
+                      <a:srgbClr val="F3F6F9"/>
+                    </a:solidFill>
+                  </a:tcPr>
+                </a:tc>
+              </a:tr>
+              <a:tr h="304800">
+                <a:tc rowSpan="3">
+                  <a:txBody>
+                    <a:bodyPr wrap="square"/>
+                    <a:lstStyle/>
+                    <a:p>
+                      <a:pPr algn="l"/>
+                      <a:r>
+                        <a:rPr sz="1600" b="1" i="0" lang="es-ES">
+                          <a:solidFill>
+                            <a:srgbClr val="263445"/>
+                          </a:solidFill>
+                        </a:rPr>
+                        <a:t>ChatGPT</a:t>
+                      </a:r>
+                    </a:p>
+                  </a:txBody>
+                  <a:tcPr anchor="ctr" marL="38100" marR="38100" marT="25400" marB="25400">
+                    <a:lnL w="19050" cap="flat" cmpd="sng" algn="ctr">
+                      <a:solidFill>
+                        <a:srgbClr val="FFFFFF"/>
+                      </a:solidFill>
+                      <a:prstDash val="solid"/>
+                    </a:lnL>
+                    <a:lnR w="19050" cap="flat" cmpd="sng" algn="ctr">
+                      <a:solidFill>
+                        <a:srgbClr val="FFFFFF"/>
+                      </a:solidFill>
+                      <a:prstDash val="solid"/>
+                    </a:lnR>
+                    <a:lnT w="31750" cap="flat" cmpd="sng" algn="ctr">
+                      <a:solidFill>
+                        <a:srgbClr val="263445"/>
+                      </a:solidFill>
+                      <a:prstDash val="solid"/>
+                    </a:lnT>
+                    <a:lnB w="19050" cap="flat" cmpd="sng" algn="ctr">
+                      <a:solidFill>
+                        <a:srgbClr val="FFFFFF"/>
+                      </a:solidFill>
+                      <a:prstDash val="solid"/>
+                    </a:lnB>
+                    <a:solidFill>
+                      <a:srgbClr val="FFFFFF"/>
+                    </a:solidFill>
+                  </a:tcPr>
+                </a:tc>
+                <a:tc>
+                  <a:txBody>
+                    <a:bodyPr wrap="square"/>
+                    <a:lstStyle/>
+                    <a:p>
+                      <a:pPr algn="ctr"/>
+                      <a:r>
+                        <a:rPr sz="1600" b="0" i="0" lang="es-ES">
+                          <a:solidFill>
+                            <a:srgbClr val="263445"/>
+                          </a:solidFill>
+                        </a:rPr>
+                        <a:t>1</a:t>
+                      </a:r>
+                    </a:p>
+                  </a:txBody>
+                  <a:tcPr anchor="ctr" marL="38100" marR="38100" marT="25400" marB="25400">
+                    <a:lnL w="19050" cap="flat" cmpd="sng" algn="ctr">
+                      <a:solidFill>
+                        <a:srgbClr val="FFFFFF"/>
+                      </a:solidFill>
+                      <a:prstDash val="solid"/>
+                    </a:lnL>
+                    <a:lnR w="19050" cap="flat" cmpd="sng" algn="ctr">
+                      <a:solidFill>
+                        <a:srgbClr val="FFFFFF"/>
+                      </a:solidFill>
+                      <a:prstDash val="solid"/>
+                    </a:lnR>
+                    <a:lnT w="31750" cap="flat" cmpd="sng" algn="ctr">
+                      <a:solidFill>
+                        <a:srgbClr val="263445"/>
+                      </a:solidFill>
+                      <a:prstDash val="solid"/>
+                    </a:lnT>
+                    <a:lnB w="19050" cap="flat" cmpd="sng" algn="ctr">
+                      <a:solidFill>
+                        <a:srgbClr val="FFFFFF"/>
+                      </a:solidFill>
+                      <a:prstDash val="solid"/>
+                    </a:lnB>
+                    <a:solidFill>
+                      <a:srgbClr val="FFFFFF"/>
+                    </a:solidFill>
+                  </a:tcPr>
+                </a:tc>
+                <a:tc>
+                  <a:txBody>
+                    <a:bodyPr wrap="square"/>
+                    <a:lstStyle/>
+                    <a:p>
+                      <a:pPr algn="ctr"/>
+                      <a:r>
+                        <a:rPr sz="1600" b="0" i="0" lang="es-ES">
+                          <a:solidFill>
+                            <a:srgbClr val="5E6B78"/>
+                          </a:solidFill>
+                        </a:rPr>
+                        <a:t>[pendiente]</a:t>
+                      </a:r>
+                    </a:p>
+                  </a:txBody>
+                  <a:tcPr anchor="ctr" marL="38100" marR="38100" marT="25400" marB="25400">
+                    <a:lnL w="19050" cap="flat" cmpd="sng" algn="ctr">
+                      <a:solidFill>
+                        <a:srgbClr val="FFFFFF"/>
+                      </a:solidFill>
+                      <a:prstDash val="solid"/>
+                    </a:lnL>
+                    <a:lnR w="19050" cap="flat" cmpd="sng" algn="ctr">
+                      <a:solidFill>
+                        <a:srgbClr val="FFFFFF"/>
+                      </a:solidFill>
+                      <a:prstDash val="solid"/>
+                    </a:lnR>
+                    <a:lnT w="31750" cap="flat" cmpd="sng" algn="ctr">
+                      <a:solidFill>
+                        <a:srgbClr val="263445"/>
+                      </a:solidFill>
+                      <a:prstDash val="solid"/>
+                    </a:lnT>
+                    <a:lnB w="19050" cap="flat" cmpd="sng" algn="ctr">
+                      <a:solidFill>
+                        <a:srgbClr val="FFFFFF"/>
+                      </a:solidFill>
+                      <a:prstDash val="solid"/>
+                    </a:lnB>
+                    <a:solidFill>
+                      <a:srgbClr val="F3F6F9"/>
+                    </a:solidFill>
+                  </a:tcPr>
+                </a:tc>
+                <a:tc>
+                  <a:txBody>
+                    <a:bodyPr wrap="square"/>
+                    <a:lstStyle/>
+                    <a:p>
+                      <a:pPr algn="l"/>
+                      <a:r>
+                        <a:rPr sz="1600" b="0" i="0" lang="es-ES">
+                          <a:solidFill>
+                            <a:srgbClr val="5E6B78"/>
+                          </a:solidFill>
+                        </a:rPr>
+                        <a:t>[pendiente]</a:t>
+                      </a:r>
+                    </a:p>
+                  </a:txBody>
+                  <a:tcPr anchor="ctr" marL="38100" marR="38100" marT="25400" marB="25400">
+                    <a:lnL w="19050" cap="flat" cmpd="sng" algn="ctr">
+                      <a:solidFill>
+                        <a:srgbClr val="FFFFFF"/>
+                      </a:solidFill>
+                      <a:prstDash val="solid"/>
+                    </a:lnL>
+                    <a:lnR w="19050" cap="flat" cmpd="sng" algn="ctr">
+                      <a:solidFill>
+                        <a:srgbClr val="FFFFFF"/>
+                      </a:solidFill>
+                      <a:prstDash val="solid"/>
+                    </a:lnR>
+                    <a:lnT w="31750" cap="flat" cmpd="sng" algn="ctr">
+                      <a:solidFill>
+                        <a:srgbClr val="263445"/>
+                      </a:solidFill>
+                      <a:prstDash val="solid"/>
+                    </a:lnT>
+                    <a:lnB w="19050" cap="flat" cmpd="sng" algn="ctr">
+                      <a:solidFill>
+                        <a:srgbClr val="FFFFFF"/>
+                      </a:solidFill>
+                      <a:prstDash val="solid"/>
+                    </a:lnB>
+                    <a:solidFill>
+                      <a:srgbClr val="F3F6F9"/>
+                    </a:solidFill>
+                  </a:tcPr>
+                </a:tc>
+                <a:tc>
+                  <a:txBody>
+                    <a:bodyPr wrap="square"/>
+                    <a:lstStyle/>
+                    <a:p>
+                      <a:pPr algn="l"/>
+                      <a:r>
+                        <a:rPr sz="1600" b="0" i="0" lang="es-ES">
+                          <a:solidFill>
+                            <a:srgbClr val="5E6B78"/>
+                          </a:solidFill>
+                        </a:rPr>
+                        <a:t>[pendiente]</a:t>
+                      </a:r>
+                    </a:p>
+                  </a:txBody>
+                  <a:tcPr anchor="ctr" marL="38100" marR="38100" marT="25400" marB="25400">
+                    <a:lnL w="19050" cap="flat" cmpd="sng" algn="ctr">
+                      <a:solidFill>
+                        <a:srgbClr val="FFFFFF"/>
+                      </a:solidFill>
+                      <a:prstDash val="solid"/>
+                    </a:lnL>
+                    <a:lnR w="19050" cap="flat" cmpd="sng" algn="ctr">
+                      <a:solidFill>
+                        <a:srgbClr val="FFFFFF"/>
+                      </a:solidFill>
+                      <a:prstDash val="solid"/>
+                    </a:lnR>
+                    <a:lnT w="31750" cap="flat" cmpd="sng" algn="ctr">
+                      <a:solidFill>
+                        <a:srgbClr val="263445"/>
+                      </a:solidFill>
+                      <a:prstDash val="solid"/>
+                    </a:lnT>
+                    <a:lnB w="19050" cap="flat" cmpd="sng" algn="ctr">
+                      <a:solidFill>
+                        <a:srgbClr val="FFFFFF"/>
+                      </a:solidFill>
+                      <a:prstDash val="solid"/>
+                    </a:lnB>
+                    <a:solidFill>
+                      <a:srgbClr val="F3F6F9"/>
+                    </a:solidFill>
+                  </a:tcPr>
+                </a:tc>
+                <a:tc>
+                  <a:txBody>
+                    <a:bodyPr wrap="square"/>
+                    <a:lstStyle/>
+                    <a:p>
+                      <a:pPr algn="l"/>
+                      <a:r>
+                        <a:rPr sz="1600" b="0" i="0" lang="es-ES">
+                          <a:solidFill>
+                            <a:srgbClr val="5E6B78"/>
+                          </a:solidFill>
+                        </a:rPr>
+                        <a:t>[pendiente]</a:t>
+                      </a:r>
+                    </a:p>
+                  </a:txBody>
+                  <a:tcPr anchor="ctr" marL="38100" marR="38100" marT="25400" marB="25400">
+                    <a:lnL w="19050" cap="flat" cmpd="sng" algn="ctr">
+                      <a:solidFill>
+                        <a:srgbClr val="FFFFFF"/>
+                      </a:solidFill>
+                      <a:prstDash val="solid"/>
+                    </a:lnL>
+                    <a:lnR w="19050" cap="flat" cmpd="sng" algn="ctr">
+                      <a:solidFill>
+                        <a:srgbClr val="FFFFFF"/>
+                      </a:solidFill>
+                      <a:prstDash val="solid"/>
+                    </a:lnR>
+                    <a:lnT w="31750" cap="flat" cmpd="sng" algn="ctr">
+                      <a:solidFill>
+                        <a:srgbClr val="263445"/>
+                      </a:solidFill>
+                      <a:prstDash val="solid"/>
+                    </a:lnT>
+                    <a:lnB w="19050" cap="flat" cmpd="sng" algn="ctr">
+                      <a:solidFill>
+                        <a:srgbClr val="FFFFFF"/>
+                      </a:solidFill>
+                      <a:prstDash val="solid"/>
+                    </a:lnB>
+                    <a:solidFill>
+                      <a:srgbClr val="F3F6F9"/>
+                    </a:solidFill>
+                  </a:tcPr>
+                </a:tc>
+              </a:tr>
+              <a:tr h="304800">
+                <a:tc vMerge="1">
+                  <a:txBody>
+                    <a:bodyPr wrap="square"/>
+                    <a:lstStyle/>
+                    <a:p/>
+                  </a:txBody>
+                  <a:tcPr anchor="ctr" marL="38100" marR="38100" marT="25400" marB="25400">
+                    <a:lnL w="19050" cap="flat" cmpd="sng" algn="ctr">
+                      <a:solidFill>
+                        <a:srgbClr val="FFFFFF"/>
+                      </a:solidFill>
+                      <a:prstDash val="solid"/>
+                    </a:lnL>
+                    <a:lnR w="19050" cap="flat" cmpd="sng" algn="ctr">
+                      <a:solidFill>
+                        <a:srgbClr val="FFFFFF"/>
+                      </a:solidFill>
+                      <a:prstDash val="solid"/>
+                    </a:lnR>
+                    <a:lnT w="19050" cap="flat" cmpd="sng" algn="ctr">
+                      <a:solidFill>
+                        <a:srgbClr val="FFFFFF"/>
+                      </a:solidFill>
+                      <a:prstDash val="solid"/>
+                    </a:lnT>
+                    <a:lnB w="19050" cap="flat" cmpd="sng" algn="ctr">
+                      <a:solidFill>
+                        <a:srgbClr val="FFFFFF"/>
+                      </a:solidFill>
+                      <a:prstDash val="solid"/>
+                    </a:lnB>
+                    <a:solidFill>
+                      <a:srgbClr val="FFFFFF"/>
+                    </a:solidFill>
+                  </a:tcPr>
+                </a:tc>
+                <a:tc>
+                  <a:txBody>
+                    <a:bodyPr wrap="square"/>
+                    <a:lstStyle/>
+                    <a:p>
+                      <a:pPr algn="ctr"/>
+                      <a:r>
+                        <a:rPr sz="1600" b="0" i="0" lang="es-ES">
+                          <a:solidFill>
+                            <a:srgbClr val="263445"/>
+                          </a:solidFill>
+                        </a:rPr>
+                        <a:t>2</a:t>
+                      </a:r>
+                    </a:p>
+                  </a:txBody>
+                  <a:tcPr anchor="ctr" marL="38100" marR="38100" marT="25400" marB="25400">
+                    <a:lnL w="19050" cap="flat" cmpd="sng" algn="ctr">
+                      <a:solidFill>
+                        <a:srgbClr val="FFFFFF"/>
+                      </a:solidFill>
+                      <a:prstDash val="solid"/>
+                    </a:lnL>
+                    <a:lnR w="19050" cap="flat" cmpd="sng" algn="ctr">
+                      <a:solidFill>
+                        <a:srgbClr val="FFFFFF"/>
+                      </a:solidFill>
+                      <a:prstDash val="solid"/>
+                    </a:lnR>
+                    <a:lnT w="19050" cap="flat" cmpd="sng" algn="ctr">
+                      <a:solidFill>
+                        <a:srgbClr val="FFFFFF"/>
+                      </a:solidFill>
+                      <a:prstDash val="solid"/>
+                    </a:lnT>
+                    <a:lnB w="19050" cap="flat" cmpd="sng" algn="ctr">
+                      <a:solidFill>
+                        <a:srgbClr val="FFFFFF"/>
+                      </a:solidFill>
+                      <a:prstDash val="solid"/>
+                    </a:lnB>
+                    <a:solidFill>
+                      <a:srgbClr val="FFFFFF"/>
+                    </a:solidFill>
+                  </a:tcPr>
+                </a:tc>
+                <a:tc>
+                  <a:txBody>
+                    <a:bodyPr wrap="square"/>
+                    <a:lstStyle/>
+                    <a:p>
+                      <a:pPr algn="ctr"/>
+                      <a:r>
+                        <a:rPr sz="1600" b="0" i="0" lang="es-ES">
+                          <a:solidFill>
+                            <a:srgbClr val="5E6B78"/>
+                          </a:solidFill>
+                        </a:rPr>
+                        <a:t>[pendiente]</a:t>
+                      </a:r>
+                    </a:p>
+                  </a:txBody>
+                  <a:tcPr anchor="ctr" marL="38100" marR="38100" marT="25400" marB="25400">
+                    <a:lnL w="19050" cap="flat" cmpd="sng" algn="ctr">
+                      <a:solidFill>
+                        <a:srgbClr val="FFFFFF"/>
+                      </a:solidFill>
+                      <a:prstDash val="solid"/>
+                    </a:lnL>
+                    <a:lnR w="19050" cap="flat" cmpd="sng" algn="ctr">
+                      <a:solidFill>
+                        <a:srgbClr val="FFFFFF"/>
+                      </a:solidFill>
+                      <a:prstDash val="solid"/>
+                    </a:lnR>
+                    <a:lnT w="19050" cap="flat" cmpd="sng" algn="ctr">
+                      <a:solidFill>
+                        <a:srgbClr val="FFFFFF"/>
+                      </a:solidFill>
+                      <a:prstDash val="solid"/>
+                    </a:lnT>
+                    <a:lnB w="19050" cap="flat" cmpd="sng" algn="ctr">
+                      <a:solidFill>
+                        <a:srgbClr val="FFFFFF"/>
+                      </a:solidFill>
+                      <a:prstDash val="solid"/>
+                    </a:lnB>
+                    <a:solidFill>
+                      <a:srgbClr val="F3F6F9"/>
+                    </a:solidFill>
+                  </a:tcPr>
+                </a:tc>
+                <a:tc>
+                  <a:txBody>
+                    <a:bodyPr wrap="square"/>
+                    <a:lstStyle/>
+                    <a:p>
+                      <a:pPr algn="l"/>
+                      <a:r>
+                        <a:rPr sz="1600" b="0" i="0" lang="es-ES">
+                          <a:solidFill>
+                            <a:srgbClr val="5E6B78"/>
+                          </a:solidFill>
+                        </a:rPr>
+                        <a:t>[pendiente]</a:t>
+                      </a:r>
+                    </a:p>
+                  </a:txBody>
+                  <a:tcPr anchor="ctr" marL="38100" marR="38100" marT="25400" marB="25400">
+                    <a:lnL w="19050" cap="flat" cmpd="sng" algn="ctr">
+                      <a:solidFill>
+                        <a:srgbClr val="FFFFFF"/>
+                      </a:solidFill>
+                      <a:prstDash val="solid"/>
+                    </a:lnL>
+                    <a:lnR w="19050" cap="flat" cmpd="sng" algn="ctr">
+                      <a:solidFill>
+                        <a:srgbClr val="FFFFFF"/>
+                      </a:solidFill>
+                      <a:prstDash val="solid"/>
+                    </a:lnR>
+                    <a:lnT w="19050" cap="flat" cmpd="sng" algn="ctr">
+                      <a:solidFill>
+                        <a:srgbClr val="FFFFFF"/>
+                      </a:solidFill>
+                      <a:prstDash val="solid"/>
+                    </a:lnT>
+                    <a:lnB w="19050" cap="flat" cmpd="sng" algn="ctr">
+                      <a:solidFill>
+                        <a:srgbClr val="FFFFFF"/>
+                      </a:solidFill>
+                      <a:prstDash val="solid"/>
+                    </a:lnB>
+                    <a:solidFill>
+                      <a:srgbClr val="F3F6F9"/>
+                    </a:solidFill>
+                  </a:tcPr>
+                </a:tc>
+                <a:tc>
+                  <a:txBody>
+                    <a:bodyPr wrap="square"/>
+                    <a:lstStyle/>
+                    <a:p>
+                      <a:pPr algn="l"/>
+                      <a:r>
+                        <a:rPr sz="1600" b="0" i="0" lang="es-ES">
+                          <a:solidFill>
+                            <a:srgbClr val="5E6B78"/>
+                          </a:solidFill>
+                        </a:rPr>
+                        <a:t>[pendiente]</a:t>
+                      </a:r>
+                    </a:p>
+                  </a:txBody>
+                  <a:tcPr anchor="ctr" marL="38100" marR="38100" marT="25400" marB="25400">
+                    <a:lnL w="19050" cap="flat" cmpd="sng" algn="ctr">
+                      <a:solidFill>
+                        <a:srgbClr val="FFFFFF"/>
+                      </a:solidFill>
+                      <a:prstDash val="solid"/>
+                    </a:lnL>
+                    <a:lnR w="19050" cap="flat" cmpd="sng" algn="ctr">
+                      <a:solidFill>
+                        <a:srgbClr val="FFFFFF"/>
+                      </a:solidFill>
+                      <a:prstDash val="solid"/>
+                    </a:lnR>
+                    <a:lnT w="19050" cap="flat" cmpd="sng" algn="ctr">
+                      <a:solidFill>
+                        <a:srgbClr val="FFFFFF"/>
+                      </a:solidFill>
+                      <a:prstDash val="solid"/>
+                    </a:lnT>
+                    <a:lnB w="19050" cap="flat" cmpd="sng" algn="ctr">
+                      <a:solidFill>
+                        <a:srgbClr val="FFFFFF"/>
+                      </a:solidFill>
+                      <a:prstDash val="solid"/>
+                    </a:lnB>
+                    <a:solidFill>
+                      <a:srgbClr val="F3F6F9"/>
+                    </a:solidFill>
+                  </a:tcPr>
+                </a:tc>
+                <a:tc>
+                  <a:txBody>
+                    <a:bodyPr wrap="square"/>
+                    <a:lstStyle/>
+                    <a:p>
+                      <a:pPr algn="l"/>
+                      <a:r>
+                        <a:rPr sz="1600" b="0" i="0" lang="es-ES">
+                          <a:solidFill>
+                            <a:srgbClr val="5E6B78"/>
+                          </a:solidFill>
+                        </a:rPr>
+                        <a:t>[pendiente]</a:t>
+                      </a:r>
+                    </a:p>
+                  </a:txBody>
+                  <a:tcPr anchor="ctr" marL="38100" marR="38100" marT="25400" marB="25400">
+                    <a:lnL w="19050" cap="flat" cmpd="sng" algn="ctr">
+                      <a:solidFill>
+                        <a:srgbClr val="FFFFFF"/>
+                      </a:solidFill>
+                      <a:prstDash val="solid"/>
+                    </a:lnL>
+                    <a:lnR w="19050" cap="flat" cmpd="sng" algn="ctr">
+                      <a:solidFill>
+                        <a:srgbClr val="FFFFFF"/>
+                      </a:solidFill>
+                      <a:prstDash val="solid"/>
+                    </a:lnR>
+                    <a:lnT w="19050" cap="flat" cmpd="sng" algn="ctr">
+                      <a:solidFill>
+                        <a:srgbClr val="FFFFFF"/>
+                      </a:solidFill>
+                      <a:prstDash val="solid"/>
+                    </a:lnT>
+                    <a:lnB w="19050" cap="flat" cmpd="sng" algn="ctr">
+                      <a:solidFill>
+                        <a:srgbClr val="FFFFFF"/>
+                      </a:solidFill>
+                      <a:prstDash val="solid"/>
+                    </a:lnB>
+                    <a:solidFill>
+                      <a:srgbClr val="F3F6F9"/>
+                    </a:solidFill>
+                  </a:tcPr>
+                </a:tc>
+              </a:tr>
+              <a:tr h="304800">
+                <a:tc vMerge="1">
+                  <a:txBody>
+                    <a:bodyPr wrap="square"/>
+                    <a:lstStyle/>
+                    <a:p/>
+                  </a:txBody>
+                  <a:tcPr anchor="ctr" marL="38100" marR="38100" marT="25400" marB="25400">
+                    <a:lnL w="19050" cap="flat" cmpd="sng" algn="ctr">
+                      <a:solidFill>
+                        <a:srgbClr val="FFFFFF"/>
+                      </a:solidFill>
+                      <a:prstDash val="solid"/>
+                    </a:lnL>
+                    <a:lnR w="19050" cap="flat" cmpd="sng" algn="ctr">
+                      <a:solidFill>
+                        <a:srgbClr val="FFFFFF"/>
+                      </a:solidFill>
+                      <a:prstDash val="solid"/>
+                    </a:lnR>
+                    <a:lnT w="19050" cap="flat" cmpd="sng" algn="ctr">
+                      <a:solidFill>
+                        <a:srgbClr val="FFFFFF"/>
+                      </a:solidFill>
+                      <a:prstDash val="solid"/>
+                    </a:lnT>
+                    <a:lnB w="19050" cap="flat" cmpd="sng" algn="ctr">
+                      <a:solidFill>
+                        <a:srgbClr val="FFFFFF"/>
+                      </a:solidFill>
+                      <a:prstDash val="solid"/>
+                    </a:lnB>
+                    <a:solidFill>
+                      <a:srgbClr val="FFFFFF"/>
+                    </a:solidFill>
+                  </a:tcPr>
+                </a:tc>
+                <a:tc>
+                  <a:txBody>
+                    <a:bodyPr wrap="square"/>
+                    <a:lstStyle/>
+                    <a:p>
+                      <a:pPr algn="ctr"/>
+                      <a:r>
+                        <a:rPr sz="1600" b="0" i="0" lang="es-ES">
+                          <a:solidFill>
+                            <a:srgbClr val="263445"/>
+                          </a:solidFill>
+                        </a:rPr>
+                        <a:t>3</a:t>
+                      </a:r>
+                    </a:p>
+                  </a:txBody>
+                  <a:tcPr anchor="ctr" marL="38100" marR="38100" marT="25400" marB="25400">
+                    <a:lnL w="19050" cap="flat" cmpd="sng" algn="ctr">
+                      <a:solidFill>
+                        <a:srgbClr val="FFFFFF"/>
+                      </a:solidFill>
+                      <a:prstDash val="solid"/>
+                    </a:lnL>
+                    <a:lnR w="19050" cap="flat" cmpd="sng" algn="ctr">
+                      <a:solidFill>
+                        <a:srgbClr val="FFFFFF"/>
+                      </a:solidFill>
+                      <a:prstDash val="solid"/>
+                    </a:lnR>
+                    <a:lnT w="19050" cap="flat" cmpd="sng" algn="ctr">
+                      <a:solidFill>
+                        <a:srgbClr val="FFFFFF"/>
+                      </a:solidFill>
+                      <a:prstDash val="solid"/>
+                    </a:lnT>
+                    <a:lnB w="19050" cap="flat" cmpd="sng" algn="ctr">
+                      <a:solidFill>
+                        <a:srgbClr val="FFFFFF"/>
+                      </a:solidFill>
+                      <a:prstDash val="solid"/>
+                    </a:lnB>
+                    <a:solidFill>
+                      <a:srgbClr val="FFFFFF"/>
+                    </a:solidFill>
+                  </a:tcPr>
+                </a:tc>
+                <a:tc>
+                  <a:txBody>
+                    <a:bodyPr wrap="square"/>
+                    <a:lstStyle/>
+                    <a:p>
+                      <a:pPr algn="ctr"/>
+                      <a:r>
+                        <a:rPr sz="1600" b="0" i="0" lang="es-ES">
+                          <a:solidFill>
+                            <a:srgbClr val="5E6B78"/>
+                          </a:solidFill>
+                        </a:rPr>
+                        <a:t>[pendiente]</a:t>
+                      </a:r>
+                    </a:p>
+                  </a:txBody>
+                  <a:tcPr anchor="ctr" marL="38100" marR="38100" marT="25400" marB="25400">
+                    <a:lnL w="19050" cap="flat" cmpd="sng" algn="ctr">
+                      <a:solidFill>
+                        <a:srgbClr val="FFFFFF"/>
+                      </a:solidFill>
+                      <a:prstDash val="solid"/>
+                    </a:lnL>
+                    <a:lnR w="19050" cap="flat" cmpd="sng" algn="ctr">
+                      <a:solidFill>
+                        <a:srgbClr val="FFFFFF"/>
+                      </a:solidFill>
+                      <a:prstDash val="solid"/>
+                    </a:lnR>
+                    <a:lnT w="19050" cap="flat" cmpd="sng" algn="ctr">
+                      <a:solidFill>
+                        <a:srgbClr val="FFFFFF"/>
+                      </a:solidFill>
+                      <a:prstDash val="solid"/>
+                    </a:lnT>
+                    <a:lnB w="19050" cap="flat" cmpd="sng" algn="ctr">
+                      <a:solidFill>
+                        <a:srgbClr val="FFFFFF"/>
+                      </a:solidFill>
+                      <a:prstDash val="solid"/>
+                    </a:lnB>
+                    <a:solidFill>
+                      <a:srgbClr val="F3F6F9"/>
+                    </a:solidFill>
+                  </a:tcPr>
+                </a:tc>
+                <a:tc>
+                  <a:txBody>
+                    <a:bodyPr wrap="square"/>
+                    <a:lstStyle/>
+                    <a:p>
+                      <a:pPr algn="l"/>
+                      <a:r>
+                        <a:rPr sz="1600" b="0" i="0" lang="es-ES">
+                          <a:solidFill>
+                            <a:srgbClr val="5E6B78"/>
+                          </a:solidFill>
+                        </a:rPr>
+                        <a:t>[pendiente]</a:t>
+                      </a:r>
+                    </a:p>
+                  </a:txBody>
+                  <a:tcPr anchor="ctr" marL="38100" marR="38100" marT="25400" marB="25400">
+                    <a:lnL w="19050" cap="flat" cmpd="sng" algn="ctr">
+                      <a:solidFill>
+                        <a:srgbClr val="FFFFFF"/>
+                      </a:solidFill>
+                      <a:prstDash val="solid"/>
+                    </a:lnL>
+                    <a:lnR w="19050" cap="flat" cmpd="sng" algn="ctr">
+                      <a:solidFill>
+                        <a:srgbClr val="FFFFFF"/>
+                      </a:solidFill>
+                      <a:prstDash val="solid"/>
+                    </a:lnR>
+                    <a:lnT w="19050" cap="flat" cmpd="sng" algn="ctr">
+                      <a:solidFill>
+                        <a:srgbClr val="FFFFFF"/>
+                      </a:solidFill>
+                      <a:prstDash val="solid"/>
+                    </a:lnT>
+                    <a:lnB w="19050" cap="flat" cmpd="sng" algn="ctr">
+                      <a:solidFill>
+                        <a:srgbClr val="FFFFFF"/>
+                      </a:solidFill>
+                      <a:prstDash val="solid"/>
+                    </a:lnB>
+                    <a:solidFill>
+                      <a:srgbClr val="F3F6F9"/>
+                    </a:solidFill>
+                  </a:tcPr>
+                </a:tc>
+                <a:tc>
+                  <a:txBody>
+                    <a:bodyPr wrap="square"/>
+                    <a:lstStyle/>
+                    <a:p>
+                      <a:pPr algn="l"/>
+                      <a:r>
+                        <a:rPr sz="1600" b="0" i="0" lang="es-ES">
+                          <a:solidFill>
+                            <a:srgbClr val="5E6B78"/>
+                          </a:solidFill>
+                        </a:rPr>
+                        <a:t>[pendiente]</a:t>
+                      </a:r>
+                    </a:p>
+                  </a:txBody>
+                  <a:tcPr anchor="ctr" marL="38100" marR="38100" marT="25400" marB="25400">
+                    <a:lnL w="19050" cap="flat" cmpd="sng" algn="ctr">
+                      <a:solidFill>
+                        <a:srgbClr val="FFFFFF"/>
+                      </a:solidFill>
+                      <a:prstDash val="solid"/>
+                    </a:lnL>
+                    <a:lnR w="19050" cap="flat" cmpd="sng" algn="ctr">
+                      <a:solidFill>
+                        <a:srgbClr val="FFFFFF"/>
+                      </a:solidFill>
+                      <a:prstDash val="solid"/>
+                    </a:lnR>
+                    <a:lnT w="19050" cap="flat" cmpd="sng" algn="ctr">
+                      <a:solidFill>
+                        <a:srgbClr val="FFFFFF"/>
+                      </a:solidFill>
+                      <a:prstDash val="solid"/>
+                    </a:lnT>
+                    <a:lnB w="19050" cap="flat" cmpd="sng" algn="ctr">
+                      <a:solidFill>
+                        <a:srgbClr val="FFFFFF"/>
+                      </a:solidFill>
+                      <a:prstDash val="solid"/>
+                    </a:lnB>
+                    <a:solidFill>
+                      <a:srgbClr val="F3F6F9"/>
+                    </a:solidFill>
+                  </a:tcPr>
+                </a:tc>
+                <a:tc>
+                  <a:txBody>
+                    <a:bodyPr wrap="square"/>
+                    <a:lstStyle/>
+                    <a:p>
+                      <a:pPr algn="l"/>
+                      <a:r>
+                        <a:rPr sz="1600" b="0" i="0" lang="es-ES">
+                          <a:solidFill>
+                            <a:srgbClr val="5E6B78"/>
+                          </a:solidFill>
+                        </a:rPr>
+                        <a:t>[pendiente]</a:t>
+                      </a:r>
+                    </a:p>
+                  </a:txBody>
+                  <a:tcPr anchor="ctr" marL="38100" marR="38100" marT="25400" marB="25400">
+                    <a:lnL w="19050" cap="flat" cmpd="sng" algn="ctr">
+                      <a:solidFill>
+                        <a:srgbClr val="FFFFFF"/>
+                      </a:solidFill>
+                      <a:prstDash val="solid"/>
+                    </a:lnL>
+                    <a:lnR w="19050" cap="flat" cmpd="sng" algn="ctr">
+                      <a:solidFill>
+                        <a:srgbClr val="FFFFFF"/>
+                      </a:solidFill>
+                      <a:prstDash val="solid"/>
+                    </a:lnR>
+                    <a:lnT w="19050" cap="flat" cmpd="sng" algn="ctr">
+                      <a:solidFill>
+                        <a:srgbClr val="FFFFFF"/>
+                      </a:solidFill>
+                      <a:prstDash val="solid"/>
+                    </a:lnT>
+                    <a:lnB w="19050" cap="flat" cmpd="sng" algn="ctr">
+                      <a:solidFill>
+                        <a:srgbClr val="FFFFFF"/>
+                      </a:solidFill>
+                      <a:prstDash val="solid"/>
+                    </a:lnB>
+                    <a:solidFill>
+                      <a:srgbClr val="F3F6F9"/>
+                    </a:solidFill>
+                  </a:tcPr>
+                </a:tc>
+              </a:tr>
+            </a:tbl>
+          </a:graphicData>
+        </a:graphic>
+      </p:graphicFrame>
+      <p:sp>
+        <p:nvSpPr>
+          <p:cNvPr id="7" name="Franja"/>
+          <p:cNvSpPr/>
+          <p:nvPr/>
+        </p:nvSpPr>
+        <p:spPr>
+          <a:xfrm>
+            <a:off x="508000" y="5676900"/>
+            <a:ext cx="11176000" cy="444500"/>
+          </a:xfrm>
+          <a:prstGeom prst="roundRect">
+            <a:avLst>
+              <a:gd name="adj" fmla="val 22857"/>
+            </a:avLst>
+          </a:prstGeom>
+          <a:solidFill>
+            <a:srgbClr val="263445"/>
+          </a:solidFill>
+          <a:ln>
+            <a:noFill/>
+          </a:ln>
+        </p:spPr>
+        <p:txBody>
+          <a:bodyPr rtlCol="0" anchor="ctr" wrap="square" lIns="101600" tIns="0" rIns="101600" bIns="0">
+            <a:noAutofit/>
+          </a:bodyPr>
+          <a:lstStyle/>
+          <a:p>
+            <a:pPr algn="ctr"/>
+            <a:r>
+              <a:rPr sz="2200" b="1" i="0" lang="es-ES">
+                <a:solidFill>
+                  <a:srgbClr val="FFFFFF"/>
+                </a:solidFill>
+              </a:rPr>
+              <a:t>Dosis recomendada: 750 mg/12 h en las 9 respuestas · lo que cambia es el juicio que la rodea</a:t>
+            </a:r>
+          </a:p>
+        </p:txBody>
+      </p:sp>
+      <p:sp>
+        <p:nvSpPr>
+          <p:cNvPr id="8" name="Fuente"/>
+          <p:cNvSpPr txBox="1"/>
+          <p:nvPr/>
+        </p:nvSpPr>
+        <p:spPr>
+          <a:xfrm>
+            <a:off x="508000" y="6337300"/>
+            <a:ext cx="11176000" cy="241300"/>
+          </a:xfrm>
+          <a:prstGeom prst="rect">
+            <a:avLst/>
+          </a:prstGeom>
+          <a:noFill/>
+        </p:spPr>
+        <p:txBody>
+          <a:bodyPr wrap="square" lIns="0" tIns="0" rIns="0" bIns="0" anchor="b">
+            <a:noAutofit/>
+          </a:bodyPr>
+          <a:lstStyle/>
+          <a:p>
+            <a:pPr algn="l"/>
+            <a:r>
+              <a:rPr sz="1200" b="0" i="0" lang="es-ES">
+                <a:solidFill>
+                  <a:srgbClr val="5E6B78"/>
+                </a:solidFill>
+              </a:rPr>
+              <a:t>Elaboración propia · Gemini [versión], Claude [versión], ChatGPT [versión] · octubre de 2026 · Caso simulado (CL 3 L/h, V 60 L)</a:t>
+            </a:r>
+          </a:p>
+        </p:txBody>
+      </p:sp>
+    </p:spTree>
   </p:cSld>
   <p:clrMapOvr>
     <a:masterClrMapping/>

</xml_diff>

<commit_message>
Rehace la diapositiva 2: cuatro indicadores de aciertos en lugar de la tabla
- Titular «Todas aciertan la dosis. No todas aciertan el criterio.»
- Tarjeta del caso a la izquierda; a la derecha 9/9, 8/9, 7/9 y 3/9 con
  barra de nueve segmentos. El cuarto (perfusión) va separado y en rojo.
- insertar_diapositiva.py admite --sustituir y renumera las partes para
  no duplicar slideN.xml.
- DESIGN.md: regla de indicadores de recuento.

Co-Authored-By: Claude Opus 5.5 <noreply@anthropic.com>
Claude-Session: https://claude.ai/code/session_01JapwXnFbMzAQGkpArhuK67
</commit_message>
<xml_diff>
--- a/examples/sefh-71-ia-tdm/salida/ponencia-ia-tdm-montero.pptx
+++ b/examples/sefh-71-ia-tdm/salida/ponencia-ia-tdm-montero.pptx
@@ -921,7 +921,7 @@
           <a:lstStyle/>
           <a:p>
             <a:r>
-              <a:t>Pregunta a mano alzada. La dosis coincidió en todas; cambiaron el AUC, la decisión sobre la dosis de las 20:00, la siguiente extracción y la fuente. Nueve consultas no son un estudio: ¿me pasa solo a mí? → diapositiva siguiente.</a:t>
+              <a:t>Las 9 aciertan la dosis. Fallan alrededor: 2 omiten la dosis de las 20:00, 1 calcula mal el AUC, 2 citan mal sus fuentes y 6 perfunden más rápido de lo que permite la ficha técnica. El error de perfusión estaba en mi propio caso; solo lo detectó la IA que consultó la ficha. Nueve consultas no son un estudio: ¿me pasa solo a mí? → diapositiva siguiente.</a:t>
             </a:r>
           </a:p>
         </p:txBody>
@@ -1566,7 +1566,7 @@
                   <a:srgbClr val="263445"/>
                 </a:solidFill>
               </a:rPr>
-              <a:t>Misma pregunta, misma dosis… decisiones distintas.</a:t>
+              <a:t>Todas aciertan la dosis. No todas aciertan el criterio.</a:t>
             </a:r>
           </a:p>
         </p:txBody>
@@ -1579,8 +1579,8 @@
         </p:nvSpPr>
         <p:spPr>
           <a:xfrm>
-            <a:off x="508000" y="1778000"/>
-            <a:ext cx="3623818" cy="3771900"/>
+            <a:off x="508000" y="1651000"/>
+            <a:ext cx="3623818" cy="4292600"/>
           </a:xfrm>
           <a:prstGeom prst="roundRect">
             <a:avLst>
@@ -1610,8 +1610,8 @@
         </p:nvSpPr>
         <p:spPr>
           <a:xfrm>
-            <a:off x="711200" y="1981200"/>
-            <a:ext cx="3217418" cy="3111500"/>
+            <a:off x="711200" y="1854200"/>
+            <a:ext cx="3217418" cy="3441700"/>
           </a:xfrm>
           <a:prstGeom prst="rect">
             <a:avLst/>
@@ -1625,11 +1625,8 @@
           <a:lstStyle/>
           <a:p>
             <a:pPr algn="l">
-              <a:lnSpc>
-                <a:spcPct val="95000"/>
-              </a:lnSpc>
               <a:spcAft>
-                <a:spcPts val="600"/>
+                <a:spcPts val="1000"/>
               </a:spcAft>
             </a:pPr>
             <a:r>
@@ -1643,11 +1640,8 @@
           </a:p>
           <a:p>
             <a:pPr algn="l">
-              <a:lnSpc>
-                <a:spcPct val="95000"/>
-              </a:lnSpc>
               <a:spcAft>
-                <a:spcPts val="600"/>
+                <a:spcPts val="1000"/>
               </a:spcAft>
             </a:pPr>
             <a:r>
@@ -1661,11 +1655,8 @@
           </a:p>
           <a:p>
             <a:pPr algn="l">
-              <a:lnSpc>
-                <a:spcPct val="95000"/>
-              </a:lnSpc>
               <a:spcAft>
-                <a:spcPts val="600"/>
+                <a:spcPts val="1000"/>
               </a:spcAft>
             </a:pPr>
             <a:r>
@@ -1674,16 +1665,13 @@
                   <a:srgbClr val="263445"/>
                 </a:solidFill>
               </a:rPr>
-              <a:t>Creatinina 1,2 mg/dL estable</a:t>
+              <a:t>Creatinina 1,2 mg/dL estable · 1000 mg/12 h</a:t>
             </a:r>
           </a:p>
           <a:p>
             <a:pPr algn="l">
-              <a:lnSpc>
-                <a:spcPct val="95000"/>
-              </a:lnSpc>
               <a:spcAft>
-                <a:spcPts val="600"/>
+                <a:spcPts val="1000"/>
               </a:spcAft>
             </a:pPr>
             <a:r>
@@ -1692,9 +1680,155 @@
                   <a:srgbClr val="263445"/>
                 </a:solidFill>
               </a:rPr>
-              <a:t>1000 mg/12 h · pico 34,0 y valle 21,2 mg/L</a:t>
-            </a:r>
-          </a:p>
+              <a:t>Pico 34,0 y valle 21,2 mg/L</a:t>
+            </a:r>
+          </a:p>
+          <a:p>
+            <a:pPr algn="l"/>
+            <a:r>
+              <a:rPr sz="2000" b="1" i="0" lang="es-ES">
+                <a:solidFill>
+                  <a:srgbClr val="2B7D3D"/>
+                </a:solidFill>
+              </a:rPr>
+              <a:t>Referencia: </a:t>
+            </a:r>
+            <a:r>
+              <a:rPr sz="2000" b="0" i="0" lang="es-ES">
+                <a:solidFill>
+                  <a:srgbClr val="263445"/>
+                </a:solidFill>
+              </a:rPr>
+              <a:t>AUC</a:t>
+            </a:r>
+            <a:r>
+              <a:rPr sz="2000" b="0" i="0" lang="es-ES" baseline="-25000">
+                <a:solidFill>
+                  <a:srgbClr val="263445"/>
+                </a:solidFill>
+              </a:rPr>
+              <a:t>24</a:t>
+            </a:r>
+            <a:r>
+              <a:rPr sz="2000" b="0" i="0" lang="es-ES">
+                <a:solidFill>
+                  <a:srgbClr val="263445"/>
+                </a:solidFill>
+              </a:rPr>
+              <a:t> ≈ 667 → 750 mg/12 h (AUC</a:t>
+            </a:r>
+            <a:r>
+              <a:rPr sz="2000" b="0" i="0" lang="es-ES" baseline="-25000">
+                <a:solidFill>
+                  <a:srgbClr val="263445"/>
+                </a:solidFill>
+              </a:rPr>
+              <a:t>24</a:t>
+            </a:r>
+            <a:r>
+              <a:rPr sz="2000" b="0" i="0" lang="es-ES">
+                <a:solidFill>
+                  <a:srgbClr val="263445"/>
+                </a:solidFill>
+              </a:rPr>
+              <a:t> ≈ 500)</a:t>
+            </a:r>
+          </a:p>
+        </p:txBody>
+      </p:sp>
+      <p:sp>
+        <p:nvSpPr>
+          <p:cNvPr id="5" name="Pie caso"/>
+          <p:cNvSpPr txBox="1"/>
+          <p:nvPr/>
+        </p:nvSpPr>
+        <p:spPr>
+          <a:xfrm>
+            <a:off x="711200" y="5359400"/>
+            <a:ext cx="3217418" cy="381000"/>
+          </a:xfrm>
+          <a:prstGeom prst="rect">
+            <a:avLst/>
+          </a:prstGeom>
+          <a:noFill/>
+        </p:spPr>
+        <p:txBody>
+          <a:bodyPr wrap="square" lIns="0" tIns="0" rIns="0" bIns="0" anchor="b">
+            <a:noAutofit/>
+          </a:bodyPr>
+          <a:lstStyle/>
+          <a:p>
+            <a:pPr algn="l"/>
+            <a:r>
+              <a:rPr sz="1600" b="0" i="1" lang="es-ES">
+                <a:solidFill>
+                  <a:srgbClr val="5E6B78"/>
+                </a:solidFill>
+              </a:rPr>
+              <a:t>Gemini, ChatGPT y Claude · 3 chats nuevos cada uno · mismo texto</a:t>
+            </a:r>
+          </a:p>
+        </p:txBody>
+      </p:sp>
+      <p:sp>
+        <p:nvSpPr>
+          <p:cNvPr id="6" name="Cifra 1"/>
+          <p:cNvSpPr txBox="1"/>
+          <p:nvPr/>
+        </p:nvSpPr>
+        <p:spPr>
+          <a:xfrm>
+            <a:off x="4284218" y="1651000"/>
+            <a:ext cx="1587500" cy="990600"/>
+          </a:xfrm>
+          <a:prstGeom prst="rect">
+            <a:avLst/>
+          </a:prstGeom>
+          <a:noFill/>
+        </p:spPr>
+        <p:txBody>
+          <a:bodyPr wrap="square" lIns="0" tIns="0" rIns="0" bIns="0" anchor="ctr">
+            <a:noAutofit/>
+          </a:bodyPr>
+          <a:lstStyle/>
+          <a:p>
+            <a:pPr algn="r">
+              <a:lnSpc>
+                <a:spcPct val="80000"/>
+              </a:lnSpc>
+            </a:pPr>
+            <a:r>
+              <a:rPr sz="7200" b="1" i="0" lang="es-ES">
+                <a:solidFill>
+                  <a:srgbClr val="2B7D3D"/>
+                </a:solidFill>
+              </a:rPr>
+              <a:t>9/9</a:t>
+            </a:r>
+          </a:p>
+        </p:txBody>
+      </p:sp>
+      <p:sp>
+        <p:nvSpPr>
+          <p:cNvPr id="7" name="Texto 1"/>
+          <p:cNvSpPr txBox="1"/>
+          <p:nvPr/>
+        </p:nvSpPr>
+        <p:spPr>
+          <a:xfrm>
+            <a:off x="6024118" y="1847850"/>
+            <a:ext cx="5660136" cy="342900"/>
+          </a:xfrm>
+          <a:prstGeom prst="rect">
+            <a:avLst/>
+          </a:prstGeom>
+          <a:noFill/>
+        </p:spPr>
+        <p:txBody>
+          <a:bodyPr wrap="square" lIns="0" tIns="0" rIns="0" bIns="0" anchor="b">
+            <a:noAutofit/>
+          </a:bodyPr>
+          <a:lstStyle/>
           <a:p>
             <a:pPr algn="l">
               <a:lnSpc>
@@ -1702,66 +1836,305 @@
               </a:lnSpc>
             </a:pPr>
             <a:r>
-              <a:rPr sz="2000" b="1" i="0" lang="es-ES">
-                <a:solidFill>
-                  <a:srgbClr val="2B7D3D"/>
-                </a:solidFill>
-              </a:rPr>
-              <a:t>Respuesta de referencia: </a:t>
-            </a:r>
-            <a:r>
-              <a:rPr sz="2000" b="0" i="0" lang="es-ES">
+              <a:rPr sz="2200" b="0" i="0" lang="es-ES">
                 <a:solidFill>
                   <a:srgbClr val="263445"/>
                 </a:solidFill>
               </a:rPr>
-              <a:t>AUC</a:t>
-            </a:r>
-            <a:r>
-              <a:rPr sz="2000" b="0" i="0" lang="es-ES" baseline="-25000">
-                <a:solidFill>
-                  <a:srgbClr val="263445"/>
-                </a:solidFill>
-              </a:rPr>
-              <a:t>24</a:t>
-            </a:r>
-            <a:r>
-              <a:rPr sz="2000" b="0" i="0" lang="es-ES">
-                <a:solidFill>
-                  <a:srgbClr val="263445"/>
-                </a:solidFill>
-              </a:rPr>
-              <a:t> actual ≈ 667 → 750 mg/12 h (AUC</a:t>
-            </a:r>
-            <a:r>
-              <a:rPr sz="2000" b="0" i="0" lang="es-ES" baseline="-25000">
-                <a:solidFill>
-                  <a:srgbClr val="263445"/>
-                </a:solidFill>
-              </a:rPr>
-              <a:t>24</a:t>
-            </a:r>
-            <a:r>
-              <a:rPr sz="2000" b="0" i="0" lang="es-ES">
-                <a:solidFill>
-                  <a:srgbClr val="263445"/>
-                </a:solidFill>
-              </a:rPr>
-              <a:t> ≈ 500)</a:t>
-            </a:r>
-          </a:p>
-        </p:txBody>
-      </p:sp>
-      <p:sp>
-        <p:nvSpPr>
-          <p:cNvPr id="5" name="Nota caso"/>
+              <a:t>misma dosis: 750 mg/12 h</a:t>
+            </a:r>
+          </a:p>
+        </p:txBody>
+      </p:sp>
+      <p:sp>
+        <p:nvSpPr>
+          <p:cNvPr id="8" name="Segmento 1.1"/>
+          <p:cNvSpPr/>
+          <p:nvPr/>
+        </p:nvSpPr>
+        <p:spPr>
+          <a:xfrm>
+            <a:off x="6024118" y="2279650"/>
+            <a:ext cx="572460" cy="165100"/>
+          </a:xfrm>
+          <a:prstGeom prst="roundRect">
+            <a:avLst>
+              <a:gd name="adj" fmla="val 23076"/>
+            </a:avLst>
+          </a:prstGeom>
+          <a:solidFill>
+            <a:srgbClr val="5BB46C"/>
+          </a:solidFill>
+          <a:ln>
+            <a:noFill/>
+          </a:ln>
+        </p:spPr>
+        <p:txBody>
+          <a:bodyPr rtlCol="0" anchor="ctr"/>
+          <a:lstStyle/>
+          <a:p>
+            <a:pPr algn="ctr"/>
+          </a:p>
+        </p:txBody>
+      </p:sp>
+      <p:sp>
+        <p:nvSpPr>
+          <p:cNvPr id="9" name="Segmento 1.2"/>
+          <p:cNvSpPr/>
+          <p:nvPr/>
+        </p:nvSpPr>
+        <p:spPr>
+          <a:xfrm>
+            <a:off x="6660078" y="2279650"/>
+            <a:ext cx="572460" cy="165100"/>
+          </a:xfrm>
+          <a:prstGeom prst="roundRect">
+            <a:avLst>
+              <a:gd name="adj" fmla="val 23076"/>
+            </a:avLst>
+          </a:prstGeom>
+          <a:solidFill>
+            <a:srgbClr val="5BB46C"/>
+          </a:solidFill>
+          <a:ln>
+            <a:noFill/>
+          </a:ln>
+        </p:spPr>
+        <p:txBody>
+          <a:bodyPr rtlCol="0" anchor="ctr"/>
+          <a:lstStyle/>
+          <a:p>
+            <a:pPr algn="ctr"/>
+          </a:p>
+        </p:txBody>
+      </p:sp>
+      <p:sp>
+        <p:nvSpPr>
+          <p:cNvPr id="10" name="Segmento 1.3"/>
+          <p:cNvSpPr/>
+          <p:nvPr/>
+        </p:nvSpPr>
+        <p:spPr>
+          <a:xfrm>
+            <a:off x="7296037" y="2279650"/>
+            <a:ext cx="572460" cy="165100"/>
+          </a:xfrm>
+          <a:prstGeom prst="roundRect">
+            <a:avLst>
+              <a:gd name="adj" fmla="val 23076"/>
+            </a:avLst>
+          </a:prstGeom>
+          <a:solidFill>
+            <a:srgbClr val="5BB46C"/>
+          </a:solidFill>
+          <a:ln>
+            <a:noFill/>
+          </a:ln>
+        </p:spPr>
+        <p:txBody>
+          <a:bodyPr rtlCol="0" anchor="ctr"/>
+          <a:lstStyle/>
+          <a:p>
+            <a:pPr algn="ctr"/>
+          </a:p>
+        </p:txBody>
+      </p:sp>
+      <p:sp>
+        <p:nvSpPr>
+          <p:cNvPr id="11" name="Segmento 1.4"/>
+          <p:cNvSpPr/>
+          <p:nvPr/>
+        </p:nvSpPr>
+        <p:spPr>
+          <a:xfrm>
+            <a:off x="7931997" y="2279650"/>
+            <a:ext cx="572460" cy="165100"/>
+          </a:xfrm>
+          <a:prstGeom prst="roundRect">
+            <a:avLst>
+              <a:gd name="adj" fmla="val 23076"/>
+            </a:avLst>
+          </a:prstGeom>
+          <a:solidFill>
+            <a:srgbClr val="5BB46C"/>
+          </a:solidFill>
+          <a:ln>
+            <a:noFill/>
+          </a:ln>
+        </p:spPr>
+        <p:txBody>
+          <a:bodyPr rtlCol="0" anchor="ctr"/>
+          <a:lstStyle/>
+          <a:p>
+            <a:pPr algn="ctr"/>
+          </a:p>
+        </p:txBody>
+      </p:sp>
+      <p:sp>
+        <p:nvSpPr>
+          <p:cNvPr id="12" name="Segmento 1.5"/>
+          <p:cNvSpPr/>
+          <p:nvPr/>
+        </p:nvSpPr>
+        <p:spPr>
+          <a:xfrm>
+            <a:off x="8567956" y="2279650"/>
+            <a:ext cx="572460" cy="165100"/>
+          </a:xfrm>
+          <a:prstGeom prst="roundRect">
+            <a:avLst>
+              <a:gd name="adj" fmla="val 23076"/>
+            </a:avLst>
+          </a:prstGeom>
+          <a:solidFill>
+            <a:srgbClr val="5BB46C"/>
+          </a:solidFill>
+          <a:ln>
+            <a:noFill/>
+          </a:ln>
+        </p:spPr>
+        <p:txBody>
+          <a:bodyPr rtlCol="0" anchor="ctr"/>
+          <a:lstStyle/>
+          <a:p>
+            <a:pPr algn="ctr"/>
+          </a:p>
+        </p:txBody>
+      </p:sp>
+      <p:sp>
+        <p:nvSpPr>
+          <p:cNvPr id="13" name="Segmento 1.6"/>
+          <p:cNvSpPr/>
+          <p:nvPr/>
+        </p:nvSpPr>
+        <p:spPr>
+          <a:xfrm>
+            <a:off x="9203916" y="2279650"/>
+            <a:ext cx="572460" cy="165100"/>
+          </a:xfrm>
+          <a:prstGeom prst="roundRect">
+            <a:avLst>
+              <a:gd name="adj" fmla="val 23076"/>
+            </a:avLst>
+          </a:prstGeom>
+          <a:solidFill>
+            <a:srgbClr val="5BB46C"/>
+          </a:solidFill>
+          <a:ln>
+            <a:noFill/>
+          </a:ln>
+        </p:spPr>
+        <p:txBody>
+          <a:bodyPr rtlCol="0" anchor="ctr"/>
+          <a:lstStyle/>
+          <a:p>
+            <a:pPr algn="ctr"/>
+          </a:p>
+        </p:txBody>
+      </p:sp>
+      <p:sp>
+        <p:nvSpPr>
+          <p:cNvPr id="14" name="Segmento 1.7"/>
+          <p:cNvSpPr/>
+          <p:nvPr/>
+        </p:nvSpPr>
+        <p:spPr>
+          <a:xfrm>
+            <a:off x="9839875" y="2279650"/>
+            <a:ext cx="572460" cy="165100"/>
+          </a:xfrm>
+          <a:prstGeom prst="roundRect">
+            <a:avLst>
+              <a:gd name="adj" fmla="val 23076"/>
+            </a:avLst>
+          </a:prstGeom>
+          <a:solidFill>
+            <a:srgbClr val="5BB46C"/>
+          </a:solidFill>
+          <a:ln>
+            <a:noFill/>
+          </a:ln>
+        </p:spPr>
+        <p:txBody>
+          <a:bodyPr rtlCol="0" anchor="ctr"/>
+          <a:lstStyle/>
+          <a:p>
+            <a:pPr algn="ctr"/>
+          </a:p>
+        </p:txBody>
+      </p:sp>
+      <p:sp>
+        <p:nvSpPr>
+          <p:cNvPr id="15" name="Segmento 1.8"/>
+          <p:cNvSpPr/>
+          <p:nvPr/>
+        </p:nvSpPr>
+        <p:spPr>
+          <a:xfrm>
+            <a:off x="10475835" y="2279650"/>
+            <a:ext cx="572460" cy="165100"/>
+          </a:xfrm>
+          <a:prstGeom prst="roundRect">
+            <a:avLst>
+              <a:gd name="adj" fmla="val 23076"/>
+            </a:avLst>
+          </a:prstGeom>
+          <a:solidFill>
+            <a:srgbClr val="5BB46C"/>
+          </a:solidFill>
+          <a:ln>
+            <a:noFill/>
+          </a:ln>
+        </p:spPr>
+        <p:txBody>
+          <a:bodyPr rtlCol="0" anchor="ctr"/>
+          <a:lstStyle/>
+          <a:p>
+            <a:pPr algn="ctr"/>
+          </a:p>
+        </p:txBody>
+      </p:sp>
+      <p:sp>
+        <p:nvSpPr>
+          <p:cNvPr id="16" name="Segmento 1.9"/>
+          <p:cNvSpPr/>
+          <p:nvPr/>
+        </p:nvSpPr>
+        <p:spPr>
+          <a:xfrm>
+            <a:off x="11111794" y="2279650"/>
+            <a:ext cx="572460" cy="165100"/>
+          </a:xfrm>
+          <a:prstGeom prst="roundRect">
+            <a:avLst>
+              <a:gd name="adj" fmla="val 23076"/>
+            </a:avLst>
+          </a:prstGeom>
+          <a:solidFill>
+            <a:srgbClr val="5BB46C"/>
+          </a:solidFill>
+          <a:ln>
+            <a:noFill/>
+          </a:ln>
+        </p:spPr>
+        <p:txBody>
+          <a:bodyPr rtlCol="0" anchor="ctr"/>
+          <a:lstStyle/>
+          <a:p>
+            <a:pPr algn="ctr"/>
+          </a:p>
+        </p:txBody>
+      </p:sp>
+      <p:sp>
+        <p:nvSpPr>
+          <p:cNvPr id="17" name="Cifra 2"/>
           <p:cNvSpPr txBox="1"/>
           <p:nvPr/>
         </p:nvSpPr>
         <p:spPr>
           <a:xfrm>
-            <a:off x="711200" y="5156200"/>
-            <a:ext cx="3217418" cy="190500"/>
+            <a:off x="4284218" y="2641600"/>
+            <a:ext cx="1587500" cy="990600"/>
           </a:xfrm>
           <a:prstGeom prst="rect">
             <a:avLst/>
@@ -1769,2840 +2142,37 @@
           <a:noFill/>
         </p:spPr>
         <p:txBody>
-          <a:bodyPr wrap="square" lIns="0" tIns="0" rIns="0" bIns="0" anchor="t">
+          <a:bodyPr wrap="square" lIns="0" tIns="0" rIns="0" bIns="0" anchor="ctr">
             <a:noAutofit/>
           </a:bodyPr>
           <a:lstStyle/>
           <a:p>
-            <a:pPr algn="l"/>
-            <a:r>
-              <a:rPr sz="1600" b="0" i="1" lang="es-ES">
-                <a:solidFill>
-                  <a:srgbClr val="5E6B78"/>
-                </a:solidFill>
-              </a:rPr>
-              <a:t>3 IA × 3 chats nuevos · mismo texto</a:t>
-            </a:r>
-          </a:p>
-        </p:txBody>
-      </p:sp>
-      <p:graphicFrame>
-        <p:nvGraphicFramePr>
-          <p:cNvPr id="6" name="Tabla respuestas"/>
-          <p:cNvGraphicFramePr>
-            <a:graphicFrameLocks noGrp="1"/>
-          </p:cNvGraphicFramePr>
-          <p:nvPr/>
-        </p:nvGraphicFramePr>
-        <p:xfrm>
-          <a:off x="4284218" y="1778000"/>
-          <a:ext cx="7397750" cy="3771900"/>
-        </p:xfrm>
-        <a:graphic>
-          <a:graphicData uri="http://schemas.openxmlformats.org/drawingml/2006/table">
-            <a:tbl>
-              <a:tblPr firstRow="1">
-                <a:tableStyleId>{5C22544A-7EE6-4342-B048-85BDC9FD1C3A}</a:tableStyleId>
-              </a:tblPr>
-              <a:tblGrid>
-                <a:gridCol w="889000"/>
-                <a:gridCol w="711200"/>
-                <a:gridCol w="1206500"/>
-                <a:gridCol w="1270000"/>
-                <a:gridCol w="1365250"/>
-                <a:gridCol w="1955800"/>
-              </a:tblGrid>
-              <a:tr h="546100">
-                <a:tc>
-                  <a:txBody>
-                    <a:bodyPr wrap="square"/>
-                    <a:lstStyle/>
-                    <a:p>
-                      <a:pPr algn="l"/>
-                      <a:r>
-                        <a:rPr sz="1600" b="1" i="0" lang="es-ES">
-                          <a:solidFill>
-                            <a:srgbClr val="FFFFFF"/>
-                          </a:solidFill>
-                        </a:rPr>
-                        <a:t>IA</a:t>
-                      </a:r>
-                    </a:p>
-                  </a:txBody>
-                  <a:tcPr anchor="ctr" marL="38100" marR="38100" marT="25400" marB="25400">
-                    <a:lnL w="19050" cap="flat" cmpd="sng" algn="ctr">
-                      <a:solidFill>
-                        <a:srgbClr val="FFFFFF"/>
-                      </a:solidFill>
-                      <a:prstDash val="solid"/>
-                    </a:lnL>
-                    <a:lnR w="19050" cap="flat" cmpd="sng" algn="ctr">
-                      <a:solidFill>
-                        <a:srgbClr val="FFFFFF"/>
-                      </a:solidFill>
-                      <a:prstDash val="solid"/>
-                    </a:lnR>
-                    <a:lnT w="19050" cap="flat" cmpd="sng" algn="ctr">
-                      <a:solidFill>
-                        <a:srgbClr val="FFFFFF"/>
-                      </a:solidFill>
-                      <a:prstDash val="solid"/>
-                    </a:lnT>
-                    <a:lnB w="19050" cap="flat" cmpd="sng" algn="ctr">
-                      <a:solidFill>
-                        <a:srgbClr val="FFFFFF"/>
-                      </a:solidFill>
-                      <a:prstDash val="solid"/>
-                    </a:lnB>
-                    <a:solidFill>
-                      <a:srgbClr val="263445"/>
-                    </a:solidFill>
-                  </a:tcPr>
-                </a:tc>
-                <a:tc>
-                  <a:txBody>
-                    <a:bodyPr wrap="square"/>
-                    <a:lstStyle/>
-                    <a:p>
-                      <a:pPr algn="ctr"/>
-                      <a:r>
-                        <a:rPr sz="1600" b="1" i="0" lang="es-ES">
-                          <a:solidFill>
-                            <a:srgbClr val="FFFFFF"/>
-                          </a:solidFill>
-                        </a:rPr>
-                        <a:t>Prueba</a:t>
-                      </a:r>
-                    </a:p>
-                  </a:txBody>
-                  <a:tcPr anchor="ctr" marL="38100" marR="38100" marT="25400" marB="25400">
-                    <a:lnL w="19050" cap="flat" cmpd="sng" algn="ctr">
-                      <a:solidFill>
-                        <a:srgbClr val="FFFFFF"/>
-                      </a:solidFill>
-                      <a:prstDash val="solid"/>
-                    </a:lnL>
-                    <a:lnR w="19050" cap="flat" cmpd="sng" algn="ctr">
-                      <a:solidFill>
-                        <a:srgbClr val="FFFFFF"/>
-                      </a:solidFill>
-                      <a:prstDash val="solid"/>
-                    </a:lnR>
-                    <a:lnT w="19050" cap="flat" cmpd="sng" algn="ctr">
-                      <a:solidFill>
-                        <a:srgbClr val="FFFFFF"/>
-                      </a:solidFill>
-                      <a:prstDash val="solid"/>
-                    </a:lnT>
-                    <a:lnB w="19050" cap="flat" cmpd="sng" algn="ctr">
-                      <a:solidFill>
-                        <a:srgbClr val="FFFFFF"/>
-                      </a:solidFill>
-                      <a:prstDash val="solid"/>
-                    </a:lnB>
-                    <a:solidFill>
-                      <a:srgbClr val="263445"/>
-                    </a:solidFill>
-                  </a:tcPr>
-                </a:tc>
-                <a:tc>
-                  <a:txBody>
-                    <a:bodyPr wrap="square"/>
-                    <a:lstStyle/>
-                    <a:p>
-                      <a:pPr algn="ctr"/>
-                      <a:r>
-                        <a:rPr sz="1600" b="1" i="0" lang="es-ES">
-                          <a:solidFill>
-                            <a:srgbClr val="FFFFFF"/>
-                          </a:solidFill>
-                        </a:rPr>
-                        <a:t>AUC</a:t>
-                      </a:r>
-                      <a:r>
-                        <a:rPr sz="1600" b="1" i="0" lang="es-ES" baseline="-25000">
-                          <a:solidFill>
-                            <a:srgbClr val="FFFFFF"/>
-                          </a:solidFill>
-                        </a:rPr>
-                        <a:t>24</a:t>
-                      </a:r>
-                      <a:r>
-                        <a:rPr sz="1600" b="1" i="0" lang="es-ES">
-                          <a:solidFill>
-                            <a:srgbClr val="FFFFFF"/>
-                          </a:solidFill>
-                        </a:rPr>
-                        <a:t> actual (ref. 667)</a:t>
-                      </a:r>
-                    </a:p>
-                  </a:txBody>
-                  <a:tcPr anchor="ctr" marL="38100" marR="38100" marT="25400" marB="25400">
-                    <a:lnL w="19050" cap="flat" cmpd="sng" algn="ctr">
-                      <a:solidFill>
-                        <a:srgbClr val="FFFFFF"/>
-                      </a:solidFill>
-                      <a:prstDash val="solid"/>
-                    </a:lnL>
-                    <a:lnR w="19050" cap="flat" cmpd="sng" algn="ctr">
-                      <a:solidFill>
-                        <a:srgbClr val="FFFFFF"/>
-                      </a:solidFill>
-                      <a:prstDash val="solid"/>
-                    </a:lnR>
-                    <a:lnT w="19050" cap="flat" cmpd="sng" algn="ctr">
-                      <a:solidFill>
-                        <a:srgbClr val="FFFFFF"/>
-                      </a:solidFill>
-                      <a:prstDash val="solid"/>
-                    </a:lnT>
-                    <a:lnB w="19050" cap="flat" cmpd="sng" algn="ctr">
-                      <a:solidFill>
-                        <a:srgbClr val="FFFFFF"/>
-                      </a:solidFill>
-                      <a:prstDash val="solid"/>
-                    </a:lnB>
-                    <a:solidFill>
-                      <a:srgbClr val="263445"/>
-                    </a:solidFill>
-                  </a:tcPr>
-                </a:tc>
-                <a:tc>
-                  <a:txBody>
-                    <a:bodyPr wrap="square"/>
-                    <a:lstStyle/>
-                    <a:p>
-                      <a:pPr algn="ctr"/>
-                      <a:r>
-                        <a:rPr sz="1600" b="1" i="0" lang="es-ES">
-                          <a:solidFill>
-                            <a:srgbClr val="FFFFFF"/>
-                          </a:solidFill>
-                        </a:rPr>
-                        <a:t>Dosis de las 20:00</a:t>
-                      </a:r>
-                    </a:p>
-                  </a:txBody>
-                  <a:tcPr anchor="ctr" marL="38100" marR="38100" marT="25400" marB="25400">
-                    <a:lnL w="19050" cap="flat" cmpd="sng" algn="ctr">
-                      <a:solidFill>
-                        <a:srgbClr val="FFFFFF"/>
-                      </a:solidFill>
-                      <a:prstDash val="solid"/>
-                    </a:lnL>
-                    <a:lnR w="19050" cap="flat" cmpd="sng" algn="ctr">
-                      <a:solidFill>
-                        <a:srgbClr val="FFFFFF"/>
-                      </a:solidFill>
-                      <a:prstDash val="solid"/>
-                    </a:lnR>
-                    <a:lnT w="19050" cap="flat" cmpd="sng" algn="ctr">
-                      <a:solidFill>
-                        <a:srgbClr val="FFFFFF"/>
-                      </a:solidFill>
-                      <a:prstDash val="solid"/>
-                    </a:lnT>
-                    <a:lnB w="19050" cap="flat" cmpd="sng" algn="ctr">
-                      <a:solidFill>
-                        <a:srgbClr val="FFFFFF"/>
-                      </a:solidFill>
-                      <a:prstDash val="solid"/>
-                    </a:lnB>
-                    <a:solidFill>
-                      <a:srgbClr val="263445"/>
-                    </a:solidFill>
-                  </a:tcPr>
-                </a:tc>
-                <a:tc>
-                  <a:txBody>
-                    <a:bodyPr wrap="square"/>
-                    <a:lstStyle/>
-                    <a:p>
-                      <a:pPr algn="ctr"/>
-                      <a:r>
-                        <a:rPr sz="1600" b="1" i="0" lang="es-ES">
-                          <a:solidFill>
-                            <a:srgbClr val="FFFFFF"/>
-                          </a:solidFill>
-                        </a:rPr>
-                        <a:t>Siguiente extracción</a:t>
-                      </a:r>
-                    </a:p>
-                  </a:txBody>
-                  <a:tcPr anchor="ctr" marL="38100" marR="38100" marT="25400" marB="25400">
-                    <a:lnL w="19050" cap="flat" cmpd="sng" algn="ctr">
-                      <a:solidFill>
-                        <a:srgbClr val="FFFFFF"/>
-                      </a:solidFill>
-                      <a:prstDash val="solid"/>
-                    </a:lnL>
-                    <a:lnR w="19050" cap="flat" cmpd="sng" algn="ctr">
-                      <a:solidFill>
-                        <a:srgbClr val="FFFFFF"/>
-                      </a:solidFill>
-                      <a:prstDash val="solid"/>
-                    </a:lnR>
-                    <a:lnT w="19050" cap="flat" cmpd="sng" algn="ctr">
-                      <a:solidFill>
-                        <a:srgbClr val="FFFFFF"/>
-                      </a:solidFill>
-                      <a:prstDash val="solid"/>
-                    </a:lnT>
-                    <a:lnB w="19050" cap="flat" cmpd="sng" algn="ctr">
-                      <a:solidFill>
-                        <a:srgbClr val="FFFFFF"/>
-                      </a:solidFill>
-                      <a:prstDash val="solid"/>
-                    </a:lnB>
-                    <a:solidFill>
-                      <a:srgbClr val="263445"/>
-                    </a:solidFill>
-                  </a:tcPr>
-                </a:tc>
-                <a:tc>
-                  <a:txBody>
-                    <a:bodyPr wrap="square"/>
-                    <a:lstStyle/>
-                    <a:p>
-                      <a:pPr algn="ctr"/>
-                      <a:r>
-                        <a:rPr sz="1600" b="1" i="0" lang="es-ES">
-                          <a:solidFill>
-                            <a:srgbClr val="FFFFFF"/>
-                          </a:solidFill>
-                        </a:rPr>
-                        <a:t>Fuente citada</a:t>
-                      </a:r>
-                    </a:p>
-                  </a:txBody>
-                  <a:tcPr anchor="ctr" marL="38100" marR="38100" marT="25400" marB="25400">
-                    <a:lnL w="19050" cap="flat" cmpd="sng" algn="ctr">
-                      <a:solidFill>
-                        <a:srgbClr val="FFFFFF"/>
-                      </a:solidFill>
-                      <a:prstDash val="solid"/>
-                    </a:lnL>
-                    <a:lnR w="19050" cap="flat" cmpd="sng" algn="ctr">
-                      <a:solidFill>
-                        <a:srgbClr val="FFFFFF"/>
-                      </a:solidFill>
-                      <a:prstDash val="solid"/>
-                    </a:lnR>
-                    <a:lnT w="19050" cap="flat" cmpd="sng" algn="ctr">
-                      <a:solidFill>
-                        <a:srgbClr val="FFFFFF"/>
-                      </a:solidFill>
-                      <a:prstDash val="solid"/>
-                    </a:lnT>
-                    <a:lnB w="19050" cap="flat" cmpd="sng" algn="ctr">
-                      <a:solidFill>
-                        <a:srgbClr val="FFFFFF"/>
-                      </a:solidFill>
-                      <a:prstDash val="solid"/>
-                    </a:lnB>
-                    <a:solidFill>
-                      <a:srgbClr val="263445"/>
-                    </a:solidFill>
-                  </a:tcPr>
-                </a:tc>
-              </a:tr>
-              <a:tr h="546100">
-                <a:tc rowSpan="3">
-                  <a:txBody>
-                    <a:bodyPr wrap="square"/>
-                    <a:lstStyle/>
-                    <a:p>
-                      <a:pPr algn="l"/>
-                      <a:r>
-                        <a:rPr sz="1600" b="1" i="0" lang="es-ES">
-                          <a:solidFill>
-                            <a:srgbClr val="263445"/>
-                          </a:solidFill>
-                        </a:rPr>
-                        <a:t>Gemini</a:t>
-                      </a:r>
-                    </a:p>
-                  </a:txBody>
-                  <a:tcPr anchor="ctr" marL="38100" marR="38100" marT="25400" marB="25400">
-                    <a:lnL w="19050" cap="flat" cmpd="sng" algn="ctr">
-                      <a:solidFill>
-                        <a:srgbClr val="FFFFFF"/>
-                      </a:solidFill>
-                      <a:prstDash val="solid"/>
-                    </a:lnL>
-                    <a:lnR w="19050" cap="flat" cmpd="sng" algn="ctr">
-                      <a:solidFill>
-                        <a:srgbClr val="FFFFFF"/>
-                      </a:solidFill>
-                      <a:prstDash val="solid"/>
-                    </a:lnR>
-                    <a:lnT w="19050" cap="flat" cmpd="sng" algn="ctr">
-                      <a:solidFill>
-                        <a:srgbClr val="FFFFFF"/>
-                      </a:solidFill>
-                      <a:prstDash val="solid"/>
-                    </a:lnT>
-                    <a:lnB w="19050" cap="flat" cmpd="sng" algn="ctr">
-                      <a:solidFill>
-                        <a:srgbClr val="FFFFFF"/>
-                      </a:solidFill>
-                      <a:prstDash val="solid"/>
-                    </a:lnB>
-                    <a:solidFill>
-                      <a:srgbClr val="FFFFFF"/>
-                    </a:solidFill>
-                  </a:tcPr>
-                </a:tc>
-                <a:tc>
-                  <a:txBody>
-                    <a:bodyPr wrap="square"/>
-                    <a:lstStyle/>
-                    <a:p>
-                      <a:pPr algn="ctr"/>
-                      <a:r>
-                        <a:rPr sz="1600" b="0" i="0" lang="es-ES">
-                          <a:solidFill>
-                            <a:srgbClr val="263445"/>
-                          </a:solidFill>
-                        </a:rPr>
-                        <a:t>1</a:t>
-                      </a:r>
-                    </a:p>
-                  </a:txBody>
-                  <a:tcPr anchor="ctr" marL="38100" marR="38100" marT="25400" marB="25400">
-                    <a:lnL w="19050" cap="flat" cmpd="sng" algn="ctr">
-                      <a:solidFill>
-                        <a:srgbClr val="FFFFFF"/>
-                      </a:solidFill>
-                      <a:prstDash val="solid"/>
-                    </a:lnL>
-                    <a:lnR w="19050" cap="flat" cmpd="sng" algn="ctr">
-                      <a:solidFill>
-                        <a:srgbClr val="FFFFFF"/>
-                      </a:solidFill>
-                      <a:prstDash val="solid"/>
-                    </a:lnR>
-                    <a:lnT w="19050" cap="flat" cmpd="sng" algn="ctr">
-                      <a:solidFill>
-                        <a:srgbClr val="FFFFFF"/>
-                      </a:solidFill>
-                      <a:prstDash val="solid"/>
-                    </a:lnT>
-                    <a:lnB w="19050" cap="flat" cmpd="sng" algn="ctr">
-                      <a:solidFill>
-                        <a:srgbClr val="FFFFFF"/>
-                      </a:solidFill>
-                      <a:prstDash val="solid"/>
-                    </a:lnB>
-                    <a:solidFill>
-                      <a:srgbClr val="FFFFFF"/>
-                    </a:solidFill>
-                  </a:tcPr>
-                </a:tc>
-                <a:tc>
-                  <a:txBody>
-                    <a:bodyPr wrap="square"/>
-                    <a:lstStyle/>
-                    <a:p>
-                      <a:pPr algn="ctr"/>
-                      <a:r>
-                        <a:rPr sz="1600" b="0" i="0" lang="es-ES">
-                          <a:solidFill>
-                            <a:srgbClr val="263445"/>
-                          </a:solidFill>
-                        </a:rPr>
-                        <a:t>697</a:t>
-                      </a:r>
-                    </a:p>
-                  </a:txBody>
-                  <a:tcPr anchor="ctr" marL="38100" marR="38100" marT="25400" marB="25400">
-                    <a:lnL w="19050" cap="flat" cmpd="sng" algn="ctr">
-                      <a:solidFill>
-                        <a:srgbClr val="FFFFFF"/>
-                      </a:solidFill>
-                      <a:prstDash val="solid"/>
-                    </a:lnL>
-                    <a:lnR w="19050" cap="flat" cmpd="sng" algn="ctr">
-                      <a:solidFill>
-                        <a:srgbClr val="FFFFFF"/>
-                      </a:solidFill>
-                      <a:prstDash val="solid"/>
-                    </a:lnR>
-                    <a:lnT w="19050" cap="flat" cmpd="sng" algn="ctr">
-                      <a:solidFill>
-                        <a:srgbClr val="FFFFFF"/>
-                      </a:solidFill>
-                      <a:prstDash val="solid"/>
-                    </a:lnT>
-                    <a:lnB w="19050" cap="flat" cmpd="sng" algn="ctr">
-                      <a:solidFill>
-                        <a:srgbClr val="FFFFFF"/>
-                      </a:solidFill>
-                      <a:prstDash val="solid"/>
-                    </a:lnB>
-                    <a:solidFill>
-                      <a:srgbClr val="FCE4E6"/>
-                    </a:solidFill>
-                  </a:tcPr>
-                </a:tc>
-                <a:tc>
-                  <a:txBody>
-                    <a:bodyPr wrap="square"/>
-                    <a:lstStyle/>
-                    <a:p>
-                      <a:pPr algn="l"/>
-                      <a:r>
-                        <a:rPr sz="1600" b="0" i="0" lang="es-ES">
-                          <a:solidFill>
-                            <a:srgbClr val="263445"/>
-                          </a:solidFill>
-                        </a:rPr>
-                        <a:t>Darla (750 mg)</a:t>
-                      </a:r>
-                    </a:p>
-                  </a:txBody>
-                  <a:tcPr anchor="ctr" marL="38100" marR="38100" marT="25400" marB="25400">
-                    <a:lnL w="19050" cap="flat" cmpd="sng" algn="ctr">
-                      <a:solidFill>
-                        <a:srgbClr val="FFFFFF"/>
-                      </a:solidFill>
-                      <a:prstDash val="solid"/>
-                    </a:lnL>
-                    <a:lnR w="19050" cap="flat" cmpd="sng" algn="ctr">
-                      <a:solidFill>
-                        <a:srgbClr val="FFFFFF"/>
-                      </a:solidFill>
-                      <a:prstDash val="solid"/>
-                    </a:lnR>
-                    <a:lnT w="19050" cap="flat" cmpd="sng" algn="ctr">
-                      <a:solidFill>
-                        <a:srgbClr val="FFFFFF"/>
-                      </a:solidFill>
-                      <a:prstDash val="solid"/>
-                    </a:lnT>
-                    <a:lnB w="19050" cap="flat" cmpd="sng" algn="ctr">
-                      <a:solidFill>
-                        <a:srgbClr val="FFFFFF"/>
-                      </a:solidFill>
-                      <a:prstDash val="solid"/>
-                    </a:lnB>
-                    <a:solidFill>
-                      <a:srgbClr val="E7F4E9"/>
-                    </a:solidFill>
-                  </a:tcPr>
-                </a:tc>
-                <a:tc>
-                  <a:txBody>
-                    <a:bodyPr wrap="square"/>
-                    <a:lstStyle/>
-                    <a:p>
-                      <a:pPr algn="l"/>
-                      <a:r>
-                        <a:rPr sz="1600" b="0" i="0" lang="es-ES">
-                          <a:solidFill>
-                            <a:srgbClr val="263445"/>
-                          </a:solidFill>
-                        </a:rPr>
-                        <a:t>A las 48-72 h</a:t>
-                      </a:r>
-                    </a:p>
-                  </a:txBody>
-                  <a:tcPr anchor="ctr" marL="38100" marR="38100" marT="25400" marB="25400">
-                    <a:lnL w="19050" cap="flat" cmpd="sng" algn="ctr">
-                      <a:solidFill>
-                        <a:srgbClr val="FFFFFF"/>
-                      </a:solidFill>
-                      <a:prstDash val="solid"/>
-                    </a:lnL>
-                    <a:lnR w="19050" cap="flat" cmpd="sng" algn="ctr">
-                      <a:solidFill>
-                        <a:srgbClr val="FFFFFF"/>
-                      </a:solidFill>
-                      <a:prstDash val="solid"/>
-                    </a:lnR>
-                    <a:lnT w="19050" cap="flat" cmpd="sng" algn="ctr">
-                      <a:solidFill>
-                        <a:srgbClr val="FFFFFF"/>
-                      </a:solidFill>
-                      <a:prstDash val="solid"/>
-                    </a:lnT>
-                    <a:lnB w="19050" cap="flat" cmpd="sng" algn="ctr">
-                      <a:solidFill>
-                        <a:srgbClr val="FFFFFF"/>
-                      </a:solidFill>
-                      <a:prstDash val="solid"/>
-                    </a:lnB>
-                    <a:solidFill>
-                      <a:srgbClr val="E7F4E9"/>
-                    </a:solidFill>
-                  </a:tcPr>
-                </a:tc>
-                <a:tc>
-                  <a:txBody>
-                    <a:bodyPr wrap="square"/>
-                    <a:lstStyle/>
-                    <a:p>
-                      <a:pPr algn="l"/>
-                      <a:r>
-                        <a:rPr sz="1600" b="0" i="0" lang="es-ES">
-                          <a:solidFill>
-                            <a:srgbClr val="263445"/>
-                          </a:solidFill>
-                        </a:rPr>
-                        <a:t>Una guía, como si fuera un modelo</a:t>
-                      </a:r>
-                    </a:p>
-                  </a:txBody>
-                  <a:tcPr anchor="ctr" marL="38100" marR="38100" marT="25400" marB="25400">
-                    <a:lnL w="19050" cap="flat" cmpd="sng" algn="ctr">
-                      <a:solidFill>
-                        <a:srgbClr val="FFFFFF"/>
-                      </a:solidFill>
-                      <a:prstDash val="solid"/>
-                    </a:lnL>
-                    <a:lnR w="19050" cap="flat" cmpd="sng" algn="ctr">
-                      <a:solidFill>
-                        <a:srgbClr val="FFFFFF"/>
-                      </a:solidFill>
-                      <a:prstDash val="solid"/>
-                    </a:lnR>
-                    <a:lnT w="19050" cap="flat" cmpd="sng" algn="ctr">
-                      <a:solidFill>
-                        <a:srgbClr val="FFFFFF"/>
-                      </a:solidFill>
-                      <a:prstDash val="solid"/>
-                    </a:lnT>
-                    <a:lnB w="19050" cap="flat" cmpd="sng" algn="ctr">
-                      <a:solidFill>
-                        <a:srgbClr val="FFFFFF"/>
-                      </a:solidFill>
-                      <a:prstDash val="solid"/>
-                    </a:lnB>
-                    <a:solidFill>
-                      <a:srgbClr val="FCE4E6"/>
-                    </a:solidFill>
-                  </a:tcPr>
-                </a:tc>
-              </a:tr>
-              <a:tr h="304800">
-                <a:tc vMerge="1">
-                  <a:txBody>
-                    <a:bodyPr wrap="square"/>
-                    <a:lstStyle/>
-                    <a:p/>
-                  </a:txBody>
-                  <a:tcPr anchor="ctr" marL="38100" marR="38100" marT="25400" marB="25400">
-                    <a:lnL w="19050" cap="flat" cmpd="sng" algn="ctr">
-                      <a:solidFill>
-                        <a:srgbClr val="FFFFFF"/>
-                      </a:solidFill>
-                      <a:prstDash val="solid"/>
-                    </a:lnL>
-                    <a:lnR w="19050" cap="flat" cmpd="sng" algn="ctr">
-                      <a:solidFill>
-                        <a:srgbClr val="FFFFFF"/>
-                      </a:solidFill>
-                      <a:prstDash val="solid"/>
-                    </a:lnR>
-                    <a:lnT w="19050" cap="flat" cmpd="sng" algn="ctr">
-                      <a:solidFill>
-                        <a:srgbClr val="FFFFFF"/>
-                      </a:solidFill>
-                      <a:prstDash val="solid"/>
-                    </a:lnT>
-                    <a:lnB w="19050" cap="flat" cmpd="sng" algn="ctr">
-                      <a:solidFill>
-                        <a:srgbClr val="FFFFFF"/>
-                      </a:solidFill>
-                      <a:prstDash val="solid"/>
-                    </a:lnB>
-                    <a:solidFill>
-                      <a:srgbClr val="FFFFFF"/>
-                    </a:solidFill>
-                  </a:tcPr>
-                </a:tc>
-                <a:tc>
-                  <a:txBody>
-                    <a:bodyPr wrap="square"/>
-                    <a:lstStyle/>
-                    <a:p>
-                      <a:pPr algn="ctr"/>
-                      <a:r>
-                        <a:rPr sz="1600" b="0" i="0" lang="es-ES">
-                          <a:solidFill>
-                            <a:srgbClr val="263445"/>
-                          </a:solidFill>
-                        </a:rPr>
-                        <a:t>2</a:t>
-                      </a:r>
-                    </a:p>
-                  </a:txBody>
-                  <a:tcPr anchor="ctr" marL="38100" marR="38100" marT="25400" marB="25400">
-                    <a:lnL w="19050" cap="flat" cmpd="sng" algn="ctr">
-                      <a:solidFill>
-                        <a:srgbClr val="FFFFFF"/>
-                      </a:solidFill>
-                      <a:prstDash val="solid"/>
-                    </a:lnL>
-                    <a:lnR w="19050" cap="flat" cmpd="sng" algn="ctr">
-                      <a:solidFill>
-                        <a:srgbClr val="FFFFFF"/>
-                      </a:solidFill>
-                      <a:prstDash val="solid"/>
-                    </a:lnR>
-                    <a:lnT w="19050" cap="flat" cmpd="sng" algn="ctr">
-                      <a:solidFill>
-                        <a:srgbClr val="FFFFFF"/>
-                      </a:solidFill>
-                      <a:prstDash val="solid"/>
-                    </a:lnT>
-                    <a:lnB w="19050" cap="flat" cmpd="sng" algn="ctr">
-                      <a:solidFill>
-                        <a:srgbClr val="FFFFFF"/>
-                      </a:solidFill>
-                      <a:prstDash val="solid"/>
-                    </a:lnB>
-                    <a:solidFill>
-                      <a:srgbClr val="FFFFFF"/>
-                    </a:solidFill>
-                  </a:tcPr>
-                </a:tc>
-                <a:tc>
-                  <a:txBody>
-                    <a:bodyPr wrap="square"/>
-                    <a:lstStyle/>
-                    <a:p>
-                      <a:pPr algn="ctr"/>
-                      <a:r>
-                        <a:rPr sz="1600" b="0" i="0" lang="es-ES">
-                          <a:solidFill>
-                            <a:srgbClr val="263445"/>
-                          </a:solidFill>
-                        </a:rPr>
-                        <a:t>662</a:t>
-                      </a:r>
-                    </a:p>
-                  </a:txBody>
-                  <a:tcPr anchor="ctr" marL="38100" marR="38100" marT="25400" marB="25400">
-                    <a:lnL w="19050" cap="flat" cmpd="sng" algn="ctr">
-                      <a:solidFill>
-                        <a:srgbClr val="FFFFFF"/>
-                      </a:solidFill>
-                      <a:prstDash val="solid"/>
-                    </a:lnL>
-                    <a:lnR w="19050" cap="flat" cmpd="sng" algn="ctr">
-                      <a:solidFill>
-                        <a:srgbClr val="FFFFFF"/>
-                      </a:solidFill>
-                      <a:prstDash val="solid"/>
-                    </a:lnR>
-                    <a:lnT w="19050" cap="flat" cmpd="sng" algn="ctr">
-                      <a:solidFill>
-                        <a:srgbClr val="FFFFFF"/>
-                      </a:solidFill>
-                      <a:prstDash val="solid"/>
-                    </a:lnT>
-                    <a:lnB w="19050" cap="flat" cmpd="sng" algn="ctr">
-                      <a:solidFill>
-                        <a:srgbClr val="FFFFFF"/>
-                      </a:solidFill>
-                      <a:prstDash val="solid"/>
-                    </a:lnB>
-                    <a:solidFill>
-                      <a:srgbClr val="E7F4E9"/>
-                    </a:solidFill>
-                  </a:tcPr>
-                </a:tc>
-                <a:tc>
-                  <a:txBody>
-                    <a:bodyPr wrap="square"/>
-                    <a:lstStyle/>
-                    <a:p>
-                      <a:pPr algn="l"/>
-                      <a:r>
-                        <a:rPr sz="1600" b="0" i="0" lang="es-ES">
-                          <a:solidFill>
-                            <a:srgbClr val="263445"/>
-                          </a:solidFill>
-                        </a:rPr>
-                        <a:t>Omitirla</a:t>
-                      </a:r>
-                    </a:p>
-                  </a:txBody>
-                  <a:tcPr anchor="ctr" marL="38100" marR="38100" marT="25400" marB="25400">
-                    <a:lnL w="19050" cap="flat" cmpd="sng" algn="ctr">
-                      <a:solidFill>
-                        <a:srgbClr val="FFFFFF"/>
-                      </a:solidFill>
-                      <a:prstDash val="solid"/>
-                    </a:lnL>
-                    <a:lnR w="19050" cap="flat" cmpd="sng" algn="ctr">
-                      <a:solidFill>
-                        <a:srgbClr val="FFFFFF"/>
-                      </a:solidFill>
-                      <a:prstDash val="solid"/>
-                    </a:lnR>
-                    <a:lnT w="19050" cap="flat" cmpd="sng" algn="ctr">
-                      <a:solidFill>
-                        <a:srgbClr val="FFFFFF"/>
-                      </a:solidFill>
-                      <a:prstDash val="solid"/>
-                    </a:lnT>
-                    <a:lnB w="19050" cap="flat" cmpd="sng" algn="ctr">
-                      <a:solidFill>
-                        <a:srgbClr val="FFFFFF"/>
-                      </a:solidFill>
-                      <a:prstDash val="solid"/>
-                    </a:lnB>
-                    <a:solidFill>
-                      <a:srgbClr val="FCEFD1"/>
-                    </a:solidFill>
-                  </a:tcPr>
-                </a:tc>
-                <a:tc>
-                  <a:txBody>
-                    <a:bodyPr wrap="square"/>
-                    <a:lstStyle/>
-                    <a:p>
-                      <a:pPr algn="l"/>
-                      <a:r>
-                        <a:rPr sz="1600" b="0" i="0" lang="es-ES">
-                          <a:solidFill>
-                            <a:srgbClr val="263445"/>
-                          </a:solidFill>
-                        </a:rPr>
-                        <a:t>Día 5, 20:00</a:t>
-                      </a:r>
-                    </a:p>
-                  </a:txBody>
-                  <a:tcPr anchor="ctr" marL="38100" marR="38100" marT="25400" marB="25400">
-                    <a:lnL w="19050" cap="flat" cmpd="sng" algn="ctr">
-                      <a:solidFill>
-                        <a:srgbClr val="FFFFFF"/>
-                      </a:solidFill>
-                      <a:prstDash val="solid"/>
-                    </a:lnL>
-                    <a:lnR w="19050" cap="flat" cmpd="sng" algn="ctr">
-                      <a:solidFill>
-                        <a:srgbClr val="FFFFFF"/>
-                      </a:solidFill>
-                      <a:prstDash val="solid"/>
-                    </a:lnR>
-                    <a:lnT w="19050" cap="flat" cmpd="sng" algn="ctr">
-                      <a:solidFill>
-                        <a:srgbClr val="FFFFFF"/>
-                      </a:solidFill>
-                      <a:prstDash val="solid"/>
-                    </a:lnT>
-                    <a:lnB w="19050" cap="flat" cmpd="sng" algn="ctr">
-                      <a:solidFill>
-                        <a:srgbClr val="FFFFFF"/>
-                      </a:solidFill>
-                      <a:prstDash val="solid"/>
-                    </a:lnB>
-                    <a:solidFill>
-                      <a:srgbClr val="FCEFD1"/>
-                    </a:solidFill>
-                  </a:tcPr>
-                </a:tc>
-                <a:tc>
-                  <a:txBody>
-                    <a:bodyPr wrap="square"/>
-                    <a:lstStyle/>
-                    <a:p>
-                      <a:pPr algn="l"/>
-                      <a:r>
-                        <a:rPr sz="1600" b="0" i="0" lang="es-ES">
-                          <a:solidFill>
-                            <a:srgbClr val="263445"/>
-                          </a:solidFill>
-                        </a:rPr>
-                        <a:t>Ecuación mal aplicada</a:t>
-                      </a:r>
-                    </a:p>
-                  </a:txBody>
-                  <a:tcPr anchor="ctr" marL="38100" marR="38100" marT="25400" marB="25400">
-                    <a:lnL w="19050" cap="flat" cmpd="sng" algn="ctr">
-                      <a:solidFill>
-                        <a:srgbClr val="FFFFFF"/>
-                      </a:solidFill>
-                      <a:prstDash val="solid"/>
-                    </a:lnL>
-                    <a:lnR w="19050" cap="flat" cmpd="sng" algn="ctr">
-                      <a:solidFill>
-                        <a:srgbClr val="FFFFFF"/>
-                      </a:solidFill>
-                      <a:prstDash val="solid"/>
-                    </a:lnR>
-                    <a:lnT w="19050" cap="flat" cmpd="sng" algn="ctr">
-                      <a:solidFill>
-                        <a:srgbClr val="FFFFFF"/>
-                      </a:solidFill>
-                      <a:prstDash val="solid"/>
-                    </a:lnT>
-                    <a:lnB w="19050" cap="flat" cmpd="sng" algn="ctr">
-                      <a:solidFill>
-                        <a:srgbClr val="FFFFFF"/>
-                      </a:solidFill>
-                      <a:prstDash val="solid"/>
-                    </a:lnB>
-                    <a:solidFill>
-                      <a:srgbClr val="FCE4E6"/>
-                    </a:solidFill>
-                  </a:tcPr>
-                </a:tc>
-              </a:tr>
-              <a:tr h="546100">
-                <a:tc vMerge="1">
-                  <a:txBody>
-                    <a:bodyPr wrap="square"/>
-                    <a:lstStyle/>
-                    <a:p/>
-                  </a:txBody>
-                  <a:tcPr anchor="ctr" marL="38100" marR="38100" marT="25400" marB="25400">
-                    <a:lnL w="19050" cap="flat" cmpd="sng" algn="ctr">
-                      <a:solidFill>
-                        <a:srgbClr val="FFFFFF"/>
-                      </a:solidFill>
-                      <a:prstDash val="solid"/>
-                    </a:lnL>
-                    <a:lnR w="19050" cap="flat" cmpd="sng" algn="ctr">
-                      <a:solidFill>
-                        <a:srgbClr val="FFFFFF"/>
-                      </a:solidFill>
-                      <a:prstDash val="solid"/>
-                    </a:lnR>
-                    <a:lnT w="19050" cap="flat" cmpd="sng" algn="ctr">
-                      <a:solidFill>
-                        <a:srgbClr val="FFFFFF"/>
-                      </a:solidFill>
-                      <a:prstDash val="solid"/>
-                    </a:lnT>
-                    <a:lnB w="19050" cap="flat" cmpd="sng" algn="ctr">
-                      <a:solidFill>
-                        <a:srgbClr val="FFFFFF"/>
-                      </a:solidFill>
-                      <a:prstDash val="solid"/>
-                    </a:lnB>
-                    <a:solidFill>
-                      <a:srgbClr val="FFFFFF"/>
-                    </a:solidFill>
-                  </a:tcPr>
-                </a:tc>
-                <a:tc>
-                  <a:txBody>
-                    <a:bodyPr wrap="square"/>
-                    <a:lstStyle/>
-                    <a:p>
-                      <a:pPr algn="ctr"/>
-                      <a:r>
-                        <a:rPr sz="1600" b="0" i="0" lang="es-ES">
-                          <a:solidFill>
-                            <a:srgbClr val="263445"/>
-                          </a:solidFill>
-                        </a:rPr>
-                        <a:t>3</a:t>
-                      </a:r>
-                    </a:p>
-                  </a:txBody>
-                  <a:tcPr anchor="ctr" marL="38100" marR="38100" marT="25400" marB="25400">
-                    <a:lnL w="19050" cap="flat" cmpd="sng" algn="ctr">
-                      <a:solidFill>
-                        <a:srgbClr val="FFFFFF"/>
-                      </a:solidFill>
-                      <a:prstDash val="solid"/>
-                    </a:lnL>
-                    <a:lnR w="19050" cap="flat" cmpd="sng" algn="ctr">
-                      <a:solidFill>
-                        <a:srgbClr val="FFFFFF"/>
-                      </a:solidFill>
-                      <a:prstDash val="solid"/>
-                    </a:lnR>
-                    <a:lnT w="19050" cap="flat" cmpd="sng" algn="ctr">
-                      <a:solidFill>
-                        <a:srgbClr val="FFFFFF"/>
-                      </a:solidFill>
-                      <a:prstDash val="solid"/>
-                    </a:lnT>
-                    <a:lnB w="19050" cap="flat" cmpd="sng" algn="ctr">
-                      <a:solidFill>
-                        <a:srgbClr val="FFFFFF"/>
-                      </a:solidFill>
-                      <a:prstDash val="solid"/>
-                    </a:lnB>
-                    <a:solidFill>
-                      <a:srgbClr val="FFFFFF"/>
-                    </a:solidFill>
-                  </a:tcPr>
-                </a:tc>
-                <a:tc>
-                  <a:txBody>
-                    <a:bodyPr wrap="square"/>
-                    <a:lstStyle/>
-                    <a:p>
-                      <a:pPr algn="ctr"/>
-                      <a:r>
-                        <a:rPr sz="1600" b="0" i="0" lang="es-ES">
-                          <a:solidFill>
-                            <a:srgbClr val="263445"/>
-                          </a:solidFill>
-                        </a:rPr>
-                        <a:t>662</a:t>
-                      </a:r>
-                    </a:p>
-                  </a:txBody>
-                  <a:tcPr anchor="ctr" marL="38100" marR="38100" marT="25400" marB="25400">
-                    <a:lnL w="19050" cap="flat" cmpd="sng" algn="ctr">
-                      <a:solidFill>
-                        <a:srgbClr val="FFFFFF"/>
-                      </a:solidFill>
-                      <a:prstDash val="solid"/>
-                    </a:lnL>
-                    <a:lnR w="19050" cap="flat" cmpd="sng" algn="ctr">
-                      <a:solidFill>
-                        <a:srgbClr val="FFFFFF"/>
-                      </a:solidFill>
-                      <a:prstDash val="solid"/>
-                    </a:lnR>
-                    <a:lnT w="19050" cap="flat" cmpd="sng" algn="ctr">
-                      <a:solidFill>
-                        <a:srgbClr val="FFFFFF"/>
-                      </a:solidFill>
-                      <a:prstDash val="solid"/>
-                    </a:lnT>
-                    <a:lnB w="19050" cap="flat" cmpd="sng" algn="ctr">
-                      <a:solidFill>
-                        <a:srgbClr val="FFFFFF"/>
-                      </a:solidFill>
-                      <a:prstDash val="solid"/>
-                    </a:lnB>
-                    <a:solidFill>
-                      <a:srgbClr val="E7F4E9"/>
-                    </a:solidFill>
-                  </a:tcPr>
-                </a:tc>
-                <a:tc>
-                  <a:txBody>
-                    <a:bodyPr wrap="square"/>
-                    <a:lstStyle/>
-                    <a:p>
-                      <a:pPr algn="l"/>
-                      <a:r>
-                        <a:rPr sz="1600" b="0" i="0" lang="es-ES">
-                          <a:solidFill>
-                            <a:srgbClr val="263445"/>
-                          </a:solidFill>
-                        </a:rPr>
-                        <a:t>Omitirla</a:t>
-                      </a:r>
-                    </a:p>
-                  </a:txBody>
-                  <a:tcPr anchor="ctr" marL="38100" marR="38100" marT="25400" marB="25400">
-                    <a:lnL w="19050" cap="flat" cmpd="sng" algn="ctr">
-                      <a:solidFill>
-                        <a:srgbClr val="FFFFFF"/>
-                      </a:solidFill>
-                      <a:prstDash val="solid"/>
-                    </a:lnL>
-                    <a:lnR w="19050" cap="flat" cmpd="sng" algn="ctr">
-                      <a:solidFill>
-                        <a:srgbClr val="FFFFFF"/>
-                      </a:solidFill>
-                      <a:prstDash val="solid"/>
-                    </a:lnR>
-                    <a:lnT w="19050" cap="flat" cmpd="sng" algn="ctr">
-                      <a:solidFill>
-                        <a:srgbClr val="FFFFFF"/>
-                      </a:solidFill>
-                      <a:prstDash val="solid"/>
-                    </a:lnT>
-                    <a:lnB w="19050" cap="flat" cmpd="sng" algn="ctr">
-                      <a:solidFill>
-                        <a:srgbClr val="FFFFFF"/>
-                      </a:solidFill>
-                      <a:prstDash val="solid"/>
-                    </a:lnB>
-                    <a:solidFill>
-                      <a:srgbClr val="FCEFD1"/>
-                    </a:solidFill>
-                  </a:tcPr>
-                </a:tc>
-                <a:tc>
-                  <a:txBody>
-                    <a:bodyPr wrap="square"/>
-                    <a:lstStyle/>
-                    <a:p>
-                      <a:pPr algn="l"/>
-                      <a:r>
-                        <a:rPr sz="1600" b="0" i="0" lang="es-ES">
-                          <a:solidFill>
-                            <a:srgbClr val="263445"/>
-                          </a:solidFill>
-                        </a:rPr>
-                        <a:t>Día 5, 08:00 («equilibrio»)</a:t>
-                      </a:r>
-                    </a:p>
-                  </a:txBody>
-                  <a:tcPr anchor="ctr" marL="38100" marR="38100" marT="25400" marB="25400">
-                    <a:lnL w="19050" cap="flat" cmpd="sng" algn="ctr">
-                      <a:solidFill>
-                        <a:srgbClr val="FFFFFF"/>
-                      </a:solidFill>
-                      <a:prstDash val="solid"/>
-                    </a:lnL>
-                    <a:lnR w="19050" cap="flat" cmpd="sng" algn="ctr">
-                      <a:solidFill>
-                        <a:srgbClr val="FFFFFF"/>
-                      </a:solidFill>
-                      <a:prstDash val="solid"/>
-                    </a:lnR>
-                    <a:lnT w="19050" cap="flat" cmpd="sng" algn="ctr">
-                      <a:solidFill>
-                        <a:srgbClr val="FFFFFF"/>
-                      </a:solidFill>
-                      <a:prstDash val="solid"/>
-                    </a:lnT>
-                    <a:lnB w="19050" cap="flat" cmpd="sng" algn="ctr">
-                      <a:solidFill>
-                        <a:srgbClr val="FFFFFF"/>
-                      </a:solidFill>
-                      <a:prstDash val="solid"/>
-                    </a:lnB>
-                    <a:solidFill>
-                      <a:srgbClr val="FCE4E6"/>
-                    </a:solidFill>
-                  </a:tcPr>
-                </a:tc>
-                <a:tc>
-                  <a:txBody>
-                    <a:bodyPr wrap="square"/>
-                    <a:lstStyle/>
-                    <a:p>
-                      <a:pPr algn="l"/>
-                      <a:r>
-                        <a:rPr sz="1600" b="0" i="0" lang="es-ES">
-                          <a:solidFill>
-                            <a:srgbClr val="5E6B78"/>
-                          </a:solidFill>
-                        </a:rPr>
-                        <a:t>Ninguna</a:t>
-                      </a:r>
-                    </a:p>
-                  </a:txBody>
-                  <a:tcPr anchor="ctr" marL="38100" marR="38100" marT="25400" marB="25400">
-                    <a:lnL w="19050" cap="flat" cmpd="sng" algn="ctr">
-                      <a:solidFill>
-                        <a:srgbClr val="FFFFFF"/>
-                      </a:solidFill>
-                      <a:prstDash val="solid"/>
-                    </a:lnL>
-                    <a:lnR w="19050" cap="flat" cmpd="sng" algn="ctr">
-                      <a:solidFill>
-                        <a:srgbClr val="FFFFFF"/>
-                      </a:solidFill>
-                      <a:prstDash val="solid"/>
-                    </a:lnR>
-                    <a:lnT w="19050" cap="flat" cmpd="sng" algn="ctr">
-                      <a:solidFill>
-                        <a:srgbClr val="FFFFFF"/>
-                      </a:solidFill>
-                      <a:prstDash val="solid"/>
-                    </a:lnT>
-                    <a:lnB w="19050" cap="flat" cmpd="sng" algn="ctr">
-                      <a:solidFill>
-                        <a:srgbClr val="FFFFFF"/>
-                      </a:solidFill>
-                      <a:prstDash val="solid"/>
-                    </a:lnB>
-                    <a:solidFill>
-                      <a:srgbClr val="F3F6F9"/>
-                    </a:solidFill>
-                  </a:tcPr>
-                </a:tc>
-              </a:tr>
-              <a:tr h="304800">
-                <a:tc rowSpan="3">
-                  <a:txBody>
-                    <a:bodyPr wrap="square"/>
-                    <a:lstStyle/>
-                    <a:p>
-                      <a:pPr algn="l"/>
-                      <a:r>
-                        <a:rPr sz="1600" b="1" i="0" lang="es-ES">
-                          <a:solidFill>
-                            <a:srgbClr val="263445"/>
-                          </a:solidFill>
-                        </a:rPr>
-                        <a:t>Claude</a:t>
-                      </a:r>
-                    </a:p>
-                  </a:txBody>
-                  <a:tcPr anchor="ctr" marL="38100" marR="38100" marT="25400" marB="25400">
-                    <a:lnL w="19050" cap="flat" cmpd="sng" algn="ctr">
-                      <a:solidFill>
-                        <a:srgbClr val="FFFFFF"/>
-                      </a:solidFill>
-                      <a:prstDash val="solid"/>
-                    </a:lnL>
-                    <a:lnR w="19050" cap="flat" cmpd="sng" algn="ctr">
-                      <a:solidFill>
-                        <a:srgbClr val="FFFFFF"/>
-                      </a:solidFill>
-                      <a:prstDash val="solid"/>
-                    </a:lnR>
-                    <a:lnT w="31750" cap="flat" cmpd="sng" algn="ctr">
-                      <a:solidFill>
-                        <a:srgbClr val="263445"/>
-                      </a:solidFill>
-                      <a:prstDash val="solid"/>
-                    </a:lnT>
-                    <a:lnB w="19050" cap="flat" cmpd="sng" algn="ctr">
-                      <a:solidFill>
-                        <a:srgbClr val="FFFFFF"/>
-                      </a:solidFill>
-                      <a:prstDash val="solid"/>
-                    </a:lnB>
-                    <a:solidFill>
-                      <a:srgbClr val="FFFFFF"/>
-                    </a:solidFill>
-                  </a:tcPr>
-                </a:tc>
-                <a:tc>
-                  <a:txBody>
-                    <a:bodyPr wrap="square"/>
-                    <a:lstStyle/>
-                    <a:p>
-                      <a:pPr algn="ctr"/>
-                      <a:r>
-                        <a:rPr sz="1600" b="0" i="0" lang="es-ES">
-                          <a:solidFill>
-                            <a:srgbClr val="263445"/>
-                          </a:solidFill>
-                        </a:rPr>
-                        <a:t>1</a:t>
-                      </a:r>
-                    </a:p>
-                  </a:txBody>
-                  <a:tcPr anchor="ctr" marL="38100" marR="38100" marT="25400" marB="25400">
-                    <a:lnL w="19050" cap="flat" cmpd="sng" algn="ctr">
-                      <a:solidFill>
-                        <a:srgbClr val="FFFFFF"/>
-                      </a:solidFill>
-                      <a:prstDash val="solid"/>
-                    </a:lnL>
-                    <a:lnR w="19050" cap="flat" cmpd="sng" algn="ctr">
-                      <a:solidFill>
-                        <a:srgbClr val="FFFFFF"/>
-                      </a:solidFill>
-                      <a:prstDash val="solid"/>
-                    </a:lnR>
-                    <a:lnT w="31750" cap="flat" cmpd="sng" algn="ctr">
-                      <a:solidFill>
-                        <a:srgbClr val="263445"/>
-                      </a:solidFill>
-                      <a:prstDash val="solid"/>
-                    </a:lnT>
-                    <a:lnB w="19050" cap="flat" cmpd="sng" algn="ctr">
-                      <a:solidFill>
-                        <a:srgbClr val="FFFFFF"/>
-                      </a:solidFill>
-                      <a:prstDash val="solid"/>
-                    </a:lnB>
-                    <a:solidFill>
-                      <a:srgbClr val="FFFFFF"/>
-                    </a:solidFill>
-                  </a:tcPr>
-                </a:tc>
-                <a:tc>
-                  <a:txBody>
-                    <a:bodyPr wrap="square"/>
-                    <a:lstStyle/>
-                    <a:p>
-                      <a:pPr algn="ctr"/>
-                      <a:r>
-                        <a:rPr sz="1600" b="0" i="0" lang="es-ES">
-                          <a:solidFill>
-                            <a:srgbClr val="5E6B78"/>
-                          </a:solidFill>
-                        </a:rPr>
-                        <a:t>[pendiente]</a:t>
-                      </a:r>
-                    </a:p>
-                  </a:txBody>
-                  <a:tcPr anchor="ctr" marL="38100" marR="38100" marT="25400" marB="25400">
-                    <a:lnL w="19050" cap="flat" cmpd="sng" algn="ctr">
-                      <a:solidFill>
-                        <a:srgbClr val="FFFFFF"/>
-                      </a:solidFill>
-                      <a:prstDash val="solid"/>
-                    </a:lnL>
-                    <a:lnR w="19050" cap="flat" cmpd="sng" algn="ctr">
-                      <a:solidFill>
-                        <a:srgbClr val="FFFFFF"/>
-                      </a:solidFill>
-                      <a:prstDash val="solid"/>
-                    </a:lnR>
-                    <a:lnT w="31750" cap="flat" cmpd="sng" algn="ctr">
-                      <a:solidFill>
-                        <a:srgbClr val="263445"/>
-                      </a:solidFill>
-                      <a:prstDash val="solid"/>
-                    </a:lnT>
-                    <a:lnB w="19050" cap="flat" cmpd="sng" algn="ctr">
-                      <a:solidFill>
-                        <a:srgbClr val="FFFFFF"/>
-                      </a:solidFill>
-                      <a:prstDash val="solid"/>
-                    </a:lnB>
-                    <a:solidFill>
-                      <a:srgbClr val="F3F6F9"/>
-                    </a:solidFill>
-                  </a:tcPr>
-                </a:tc>
-                <a:tc>
-                  <a:txBody>
-                    <a:bodyPr wrap="square"/>
-                    <a:lstStyle/>
-                    <a:p>
-                      <a:pPr algn="l"/>
-                      <a:r>
-                        <a:rPr sz="1600" b="0" i="0" lang="es-ES">
-                          <a:solidFill>
-                            <a:srgbClr val="5E6B78"/>
-                          </a:solidFill>
-                        </a:rPr>
-                        <a:t>[pendiente]</a:t>
-                      </a:r>
-                    </a:p>
-                  </a:txBody>
-                  <a:tcPr anchor="ctr" marL="38100" marR="38100" marT="25400" marB="25400">
-                    <a:lnL w="19050" cap="flat" cmpd="sng" algn="ctr">
-                      <a:solidFill>
-                        <a:srgbClr val="FFFFFF"/>
-                      </a:solidFill>
-                      <a:prstDash val="solid"/>
-                    </a:lnL>
-                    <a:lnR w="19050" cap="flat" cmpd="sng" algn="ctr">
-                      <a:solidFill>
-                        <a:srgbClr val="FFFFFF"/>
-                      </a:solidFill>
-                      <a:prstDash val="solid"/>
-                    </a:lnR>
-                    <a:lnT w="31750" cap="flat" cmpd="sng" algn="ctr">
-                      <a:solidFill>
-                        <a:srgbClr val="263445"/>
-                      </a:solidFill>
-                      <a:prstDash val="solid"/>
-                    </a:lnT>
-                    <a:lnB w="19050" cap="flat" cmpd="sng" algn="ctr">
-                      <a:solidFill>
-                        <a:srgbClr val="FFFFFF"/>
-                      </a:solidFill>
-                      <a:prstDash val="solid"/>
-                    </a:lnB>
-                    <a:solidFill>
-                      <a:srgbClr val="F3F6F9"/>
-                    </a:solidFill>
-                  </a:tcPr>
-                </a:tc>
-                <a:tc>
-                  <a:txBody>
-                    <a:bodyPr wrap="square"/>
-                    <a:lstStyle/>
-                    <a:p>
-                      <a:pPr algn="l"/>
-                      <a:r>
-                        <a:rPr sz="1600" b="0" i="0" lang="es-ES">
-                          <a:solidFill>
-                            <a:srgbClr val="5E6B78"/>
-                          </a:solidFill>
-                        </a:rPr>
-                        <a:t>[pendiente]</a:t>
-                      </a:r>
-                    </a:p>
-                  </a:txBody>
-                  <a:tcPr anchor="ctr" marL="38100" marR="38100" marT="25400" marB="25400">
-                    <a:lnL w="19050" cap="flat" cmpd="sng" algn="ctr">
-                      <a:solidFill>
-                        <a:srgbClr val="FFFFFF"/>
-                      </a:solidFill>
-                      <a:prstDash val="solid"/>
-                    </a:lnL>
-                    <a:lnR w="19050" cap="flat" cmpd="sng" algn="ctr">
-                      <a:solidFill>
-                        <a:srgbClr val="FFFFFF"/>
-                      </a:solidFill>
-                      <a:prstDash val="solid"/>
-                    </a:lnR>
-                    <a:lnT w="31750" cap="flat" cmpd="sng" algn="ctr">
-                      <a:solidFill>
-                        <a:srgbClr val="263445"/>
-                      </a:solidFill>
-                      <a:prstDash val="solid"/>
-                    </a:lnT>
-                    <a:lnB w="19050" cap="flat" cmpd="sng" algn="ctr">
-                      <a:solidFill>
-                        <a:srgbClr val="FFFFFF"/>
-                      </a:solidFill>
-                      <a:prstDash val="solid"/>
-                    </a:lnB>
-                    <a:solidFill>
-                      <a:srgbClr val="F3F6F9"/>
-                    </a:solidFill>
-                  </a:tcPr>
-                </a:tc>
-                <a:tc>
-                  <a:txBody>
-                    <a:bodyPr wrap="square"/>
-                    <a:lstStyle/>
-                    <a:p>
-                      <a:pPr algn="l"/>
-                      <a:r>
-                        <a:rPr sz="1600" b="0" i="0" lang="es-ES">
-                          <a:solidFill>
-                            <a:srgbClr val="5E6B78"/>
-                          </a:solidFill>
-                        </a:rPr>
-                        <a:t>[pendiente]</a:t>
-                      </a:r>
-                    </a:p>
-                  </a:txBody>
-                  <a:tcPr anchor="ctr" marL="38100" marR="38100" marT="25400" marB="25400">
-                    <a:lnL w="19050" cap="flat" cmpd="sng" algn="ctr">
-                      <a:solidFill>
-                        <a:srgbClr val="FFFFFF"/>
-                      </a:solidFill>
-                      <a:prstDash val="solid"/>
-                    </a:lnL>
-                    <a:lnR w="19050" cap="flat" cmpd="sng" algn="ctr">
-                      <a:solidFill>
-                        <a:srgbClr val="FFFFFF"/>
-                      </a:solidFill>
-                      <a:prstDash val="solid"/>
-                    </a:lnR>
-                    <a:lnT w="31750" cap="flat" cmpd="sng" algn="ctr">
-                      <a:solidFill>
-                        <a:srgbClr val="263445"/>
-                      </a:solidFill>
-                      <a:prstDash val="solid"/>
-                    </a:lnT>
-                    <a:lnB w="19050" cap="flat" cmpd="sng" algn="ctr">
-                      <a:solidFill>
-                        <a:srgbClr val="FFFFFF"/>
-                      </a:solidFill>
-                      <a:prstDash val="solid"/>
-                    </a:lnB>
-                    <a:solidFill>
-                      <a:srgbClr val="F3F6F9"/>
-                    </a:solidFill>
-                  </a:tcPr>
-                </a:tc>
-              </a:tr>
-              <a:tr h="304800">
-                <a:tc vMerge="1">
-                  <a:txBody>
-                    <a:bodyPr wrap="square"/>
-                    <a:lstStyle/>
-                    <a:p/>
-                  </a:txBody>
-                  <a:tcPr anchor="ctr" marL="38100" marR="38100" marT="25400" marB="25400">
-                    <a:lnL w="19050" cap="flat" cmpd="sng" algn="ctr">
-                      <a:solidFill>
-                        <a:srgbClr val="FFFFFF"/>
-                      </a:solidFill>
-                      <a:prstDash val="solid"/>
-                    </a:lnL>
-                    <a:lnR w="19050" cap="flat" cmpd="sng" algn="ctr">
-                      <a:solidFill>
-                        <a:srgbClr val="FFFFFF"/>
-                      </a:solidFill>
-                      <a:prstDash val="solid"/>
-                    </a:lnR>
-                    <a:lnT w="19050" cap="flat" cmpd="sng" algn="ctr">
-                      <a:solidFill>
-                        <a:srgbClr val="FFFFFF"/>
-                      </a:solidFill>
-                      <a:prstDash val="solid"/>
-                    </a:lnT>
-                    <a:lnB w="19050" cap="flat" cmpd="sng" algn="ctr">
-                      <a:solidFill>
-                        <a:srgbClr val="FFFFFF"/>
-                      </a:solidFill>
-                      <a:prstDash val="solid"/>
-                    </a:lnB>
-                    <a:solidFill>
-                      <a:srgbClr val="FFFFFF"/>
-                    </a:solidFill>
-                  </a:tcPr>
-                </a:tc>
-                <a:tc>
-                  <a:txBody>
-                    <a:bodyPr wrap="square"/>
-                    <a:lstStyle/>
-                    <a:p>
-                      <a:pPr algn="ctr"/>
-                      <a:r>
-                        <a:rPr sz="1600" b="0" i="0" lang="es-ES">
-                          <a:solidFill>
-                            <a:srgbClr val="263445"/>
-                          </a:solidFill>
-                        </a:rPr>
-                        <a:t>2</a:t>
-                      </a:r>
-                    </a:p>
-                  </a:txBody>
-                  <a:tcPr anchor="ctr" marL="38100" marR="38100" marT="25400" marB="25400">
-                    <a:lnL w="19050" cap="flat" cmpd="sng" algn="ctr">
-                      <a:solidFill>
-                        <a:srgbClr val="FFFFFF"/>
-                      </a:solidFill>
-                      <a:prstDash val="solid"/>
-                    </a:lnL>
-                    <a:lnR w="19050" cap="flat" cmpd="sng" algn="ctr">
-                      <a:solidFill>
-                        <a:srgbClr val="FFFFFF"/>
-                      </a:solidFill>
-                      <a:prstDash val="solid"/>
-                    </a:lnR>
-                    <a:lnT w="19050" cap="flat" cmpd="sng" algn="ctr">
-                      <a:solidFill>
-                        <a:srgbClr val="FFFFFF"/>
-                      </a:solidFill>
-                      <a:prstDash val="solid"/>
-                    </a:lnT>
-                    <a:lnB w="19050" cap="flat" cmpd="sng" algn="ctr">
-                      <a:solidFill>
-                        <a:srgbClr val="FFFFFF"/>
-                      </a:solidFill>
-                      <a:prstDash val="solid"/>
-                    </a:lnB>
-                    <a:solidFill>
-                      <a:srgbClr val="FFFFFF"/>
-                    </a:solidFill>
-                  </a:tcPr>
-                </a:tc>
-                <a:tc>
-                  <a:txBody>
-                    <a:bodyPr wrap="square"/>
-                    <a:lstStyle/>
-                    <a:p>
-                      <a:pPr algn="ctr"/>
-                      <a:r>
-                        <a:rPr sz="1600" b="0" i="0" lang="es-ES">
-                          <a:solidFill>
-                            <a:srgbClr val="5E6B78"/>
-                          </a:solidFill>
-                        </a:rPr>
-                        <a:t>[pendiente]</a:t>
-                      </a:r>
-                    </a:p>
-                  </a:txBody>
-                  <a:tcPr anchor="ctr" marL="38100" marR="38100" marT="25400" marB="25400">
-                    <a:lnL w="19050" cap="flat" cmpd="sng" algn="ctr">
-                      <a:solidFill>
-                        <a:srgbClr val="FFFFFF"/>
-                      </a:solidFill>
-                      <a:prstDash val="solid"/>
-                    </a:lnL>
-                    <a:lnR w="19050" cap="flat" cmpd="sng" algn="ctr">
-                      <a:solidFill>
-                        <a:srgbClr val="FFFFFF"/>
-                      </a:solidFill>
-                      <a:prstDash val="solid"/>
-                    </a:lnR>
-                    <a:lnT w="19050" cap="flat" cmpd="sng" algn="ctr">
-                      <a:solidFill>
-                        <a:srgbClr val="FFFFFF"/>
-                      </a:solidFill>
-                      <a:prstDash val="solid"/>
-                    </a:lnT>
-                    <a:lnB w="19050" cap="flat" cmpd="sng" algn="ctr">
-                      <a:solidFill>
-                        <a:srgbClr val="FFFFFF"/>
-                      </a:solidFill>
-                      <a:prstDash val="solid"/>
-                    </a:lnB>
-                    <a:solidFill>
-                      <a:srgbClr val="F3F6F9"/>
-                    </a:solidFill>
-                  </a:tcPr>
-                </a:tc>
-                <a:tc>
-                  <a:txBody>
-                    <a:bodyPr wrap="square"/>
-                    <a:lstStyle/>
-                    <a:p>
-                      <a:pPr algn="l"/>
-                      <a:r>
-                        <a:rPr sz="1600" b="0" i="0" lang="es-ES">
-                          <a:solidFill>
-                            <a:srgbClr val="5E6B78"/>
-                          </a:solidFill>
-                        </a:rPr>
-                        <a:t>[pendiente]</a:t>
-                      </a:r>
-                    </a:p>
-                  </a:txBody>
-                  <a:tcPr anchor="ctr" marL="38100" marR="38100" marT="25400" marB="25400">
-                    <a:lnL w="19050" cap="flat" cmpd="sng" algn="ctr">
-                      <a:solidFill>
-                        <a:srgbClr val="FFFFFF"/>
-                      </a:solidFill>
-                      <a:prstDash val="solid"/>
-                    </a:lnL>
-                    <a:lnR w="19050" cap="flat" cmpd="sng" algn="ctr">
-                      <a:solidFill>
-                        <a:srgbClr val="FFFFFF"/>
-                      </a:solidFill>
-                      <a:prstDash val="solid"/>
-                    </a:lnR>
-                    <a:lnT w="19050" cap="flat" cmpd="sng" algn="ctr">
-                      <a:solidFill>
-                        <a:srgbClr val="FFFFFF"/>
-                      </a:solidFill>
-                      <a:prstDash val="solid"/>
-                    </a:lnT>
-                    <a:lnB w="19050" cap="flat" cmpd="sng" algn="ctr">
-                      <a:solidFill>
-                        <a:srgbClr val="FFFFFF"/>
-                      </a:solidFill>
-                      <a:prstDash val="solid"/>
-                    </a:lnB>
-                    <a:solidFill>
-                      <a:srgbClr val="F3F6F9"/>
-                    </a:solidFill>
-                  </a:tcPr>
-                </a:tc>
-                <a:tc>
-                  <a:txBody>
-                    <a:bodyPr wrap="square"/>
-                    <a:lstStyle/>
-                    <a:p>
-                      <a:pPr algn="l"/>
-                      <a:r>
-                        <a:rPr sz="1600" b="0" i="0" lang="es-ES">
-                          <a:solidFill>
-                            <a:srgbClr val="5E6B78"/>
-                          </a:solidFill>
-                        </a:rPr>
-                        <a:t>[pendiente]</a:t>
-                      </a:r>
-                    </a:p>
-                  </a:txBody>
-                  <a:tcPr anchor="ctr" marL="38100" marR="38100" marT="25400" marB="25400">
-                    <a:lnL w="19050" cap="flat" cmpd="sng" algn="ctr">
-                      <a:solidFill>
-                        <a:srgbClr val="FFFFFF"/>
-                      </a:solidFill>
-                      <a:prstDash val="solid"/>
-                    </a:lnL>
-                    <a:lnR w="19050" cap="flat" cmpd="sng" algn="ctr">
-                      <a:solidFill>
-                        <a:srgbClr val="FFFFFF"/>
-                      </a:solidFill>
-                      <a:prstDash val="solid"/>
-                    </a:lnR>
-                    <a:lnT w="19050" cap="flat" cmpd="sng" algn="ctr">
-                      <a:solidFill>
-                        <a:srgbClr val="FFFFFF"/>
-                      </a:solidFill>
-                      <a:prstDash val="solid"/>
-                    </a:lnT>
-                    <a:lnB w="19050" cap="flat" cmpd="sng" algn="ctr">
-                      <a:solidFill>
-                        <a:srgbClr val="FFFFFF"/>
-                      </a:solidFill>
-                      <a:prstDash val="solid"/>
-                    </a:lnB>
-                    <a:solidFill>
-                      <a:srgbClr val="F3F6F9"/>
-                    </a:solidFill>
-                  </a:tcPr>
-                </a:tc>
-                <a:tc>
-                  <a:txBody>
-                    <a:bodyPr wrap="square"/>
-                    <a:lstStyle/>
-                    <a:p>
-                      <a:pPr algn="l"/>
-                      <a:r>
-                        <a:rPr sz="1600" b="0" i="0" lang="es-ES">
-                          <a:solidFill>
-                            <a:srgbClr val="5E6B78"/>
-                          </a:solidFill>
-                        </a:rPr>
-                        <a:t>[pendiente]</a:t>
-                      </a:r>
-                    </a:p>
-                  </a:txBody>
-                  <a:tcPr anchor="ctr" marL="38100" marR="38100" marT="25400" marB="25400">
-                    <a:lnL w="19050" cap="flat" cmpd="sng" algn="ctr">
-                      <a:solidFill>
-                        <a:srgbClr val="FFFFFF"/>
-                      </a:solidFill>
-                      <a:prstDash val="solid"/>
-                    </a:lnL>
-                    <a:lnR w="19050" cap="flat" cmpd="sng" algn="ctr">
-                      <a:solidFill>
-                        <a:srgbClr val="FFFFFF"/>
-                      </a:solidFill>
-                      <a:prstDash val="solid"/>
-                    </a:lnR>
-                    <a:lnT w="19050" cap="flat" cmpd="sng" algn="ctr">
-                      <a:solidFill>
-                        <a:srgbClr val="FFFFFF"/>
-                      </a:solidFill>
-                      <a:prstDash val="solid"/>
-                    </a:lnT>
-                    <a:lnB w="19050" cap="flat" cmpd="sng" algn="ctr">
-                      <a:solidFill>
-                        <a:srgbClr val="FFFFFF"/>
-                      </a:solidFill>
-                      <a:prstDash val="solid"/>
-                    </a:lnB>
-                    <a:solidFill>
-                      <a:srgbClr val="F3F6F9"/>
-                    </a:solidFill>
-                  </a:tcPr>
-                </a:tc>
-              </a:tr>
-              <a:tr h="304800">
-                <a:tc vMerge="1">
-                  <a:txBody>
-                    <a:bodyPr wrap="square"/>
-                    <a:lstStyle/>
-                    <a:p/>
-                  </a:txBody>
-                  <a:tcPr anchor="ctr" marL="38100" marR="38100" marT="25400" marB="25400">
-                    <a:lnL w="19050" cap="flat" cmpd="sng" algn="ctr">
-                      <a:solidFill>
-                        <a:srgbClr val="FFFFFF"/>
-                      </a:solidFill>
-                      <a:prstDash val="solid"/>
-                    </a:lnL>
-                    <a:lnR w="19050" cap="flat" cmpd="sng" algn="ctr">
-                      <a:solidFill>
-                        <a:srgbClr val="FFFFFF"/>
-                      </a:solidFill>
-                      <a:prstDash val="solid"/>
-                    </a:lnR>
-                    <a:lnT w="19050" cap="flat" cmpd="sng" algn="ctr">
-                      <a:solidFill>
-                        <a:srgbClr val="FFFFFF"/>
-                      </a:solidFill>
-                      <a:prstDash val="solid"/>
-                    </a:lnT>
-                    <a:lnB w="19050" cap="flat" cmpd="sng" algn="ctr">
-                      <a:solidFill>
-                        <a:srgbClr val="FFFFFF"/>
-                      </a:solidFill>
-                      <a:prstDash val="solid"/>
-                    </a:lnB>
-                    <a:solidFill>
-                      <a:srgbClr val="FFFFFF"/>
-                    </a:solidFill>
-                  </a:tcPr>
-                </a:tc>
-                <a:tc>
-                  <a:txBody>
-                    <a:bodyPr wrap="square"/>
-                    <a:lstStyle/>
-                    <a:p>
-                      <a:pPr algn="ctr"/>
-                      <a:r>
-                        <a:rPr sz="1600" b="0" i="0" lang="es-ES">
-                          <a:solidFill>
-                            <a:srgbClr val="263445"/>
-                          </a:solidFill>
-                        </a:rPr>
-                        <a:t>3</a:t>
-                      </a:r>
-                    </a:p>
-                  </a:txBody>
-                  <a:tcPr anchor="ctr" marL="38100" marR="38100" marT="25400" marB="25400">
-                    <a:lnL w="19050" cap="flat" cmpd="sng" algn="ctr">
-                      <a:solidFill>
-                        <a:srgbClr val="FFFFFF"/>
-                      </a:solidFill>
-                      <a:prstDash val="solid"/>
-                    </a:lnL>
-                    <a:lnR w="19050" cap="flat" cmpd="sng" algn="ctr">
-                      <a:solidFill>
-                        <a:srgbClr val="FFFFFF"/>
-                      </a:solidFill>
-                      <a:prstDash val="solid"/>
-                    </a:lnR>
-                    <a:lnT w="19050" cap="flat" cmpd="sng" algn="ctr">
-                      <a:solidFill>
-                        <a:srgbClr val="FFFFFF"/>
-                      </a:solidFill>
-                      <a:prstDash val="solid"/>
-                    </a:lnT>
-                    <a:lnB w="19050" cap="flat" cmpd="sng" algn="ctr">
-                      <a:solidFill>
-                        <a:srgbClr val="FFFFFF"/>
-                      </a:solidFill>
-                      <a:prstDash val="solid"/>
-                    </a:lnB>
-                    <a:solidFill>
-                      <a:srgbClr val="FFFFFF"/>
-                    </a:solidFill>
-                  </a:tcPr>
-                </a:tc>
-                <a:tc>
-                  <a:txBody>
-                    <a:bodyPr wrap="square"/>
-                    <a:lstStyle/>
-                    <a:p>
-                      <a:pPr algn="ctr"/>
-                      <a:r>
-                        <a:rPr sz="1600" b="0" i="0" lang="es-ES">
-                          <a:solidFill>
-                            <a:srgbClr val="5E6B78"/>
-                          </a:solidFill>
-                        </a:rPr>
-                        <a:t>[pendiente]</a:t>
-                      </a:r>
-                    </a:p>
-                  </a:txBody>
-                  <a:tcPr anchor="ctr" marL="38100" marR="38100" marT="25400" marB="25400">
-                    <a:lnL w="19050" cap="flat" cmpd="sng" algn="ctr">
-                      <a:solidFill>
-                        <a:srgbClr val="FFFFFF"/>
-                      </a:solidFill>
-                      <a:prstDash val="solid"/>
-                    </a:lnL>
-                    <a:lnR w="19050" cap="flat" cmpd="sng" algn="ctr">
-                      <a:solidFill>
-                        <a:srgbClr val="FFFFFF"/>
-                      </a:solidFill>
-                      <a:prstDash val="solid"/>
-                    </a:lnR>
-                    <a:lnT w="19050" cap="flat" cmpd="sng" algn="ctr">
-                      <a:solidFill>
-                        <a:srgbClr val="FFFFFF"/>
-                      </a:solidFill>
-                      <a:prstDash val="solid"/>
-                    </a:lnT>
-                    <a:lnB w="19050" cap="flat" cmpd="sng" algn="ctr">
-                      <a:solidFill>
-                        <a:srgbClr val="FFFFFF"/>
-                      </a:solidFill>
-                      <a:prstDash val="solid"/>
-                    </a:lnB>
-                    <a:solidFill>
-                      <a:srgbClr val="F3F6F9"/>
-                    </a:solidFill>
-                  </a:tcPr>
-                </a:tc>
-                <a:tc>
-                  <a:txBody>
-                    <a:bodyPr wrap="square"/>
-                    <a:lstStyle/>
-                    <a:p>
-                      <a:pPr algn="l"/>
-                      <a:r>
-                        <a:rPr sz="1600" b="0" i="0" lang="es-ES">
-                          <a:solidFill>
-                            <a:srgbClr val="5E6B78"/>
-                          </a:solidFill>
-                        </a:rPr>
-                        <a:t>[pendiente]</a:t>
-                      </a:r>
-                    </a:p>
-                  </a:txBody>
-                  <a:tcPr anchor="ctr" marL="38100" marR="38100" marT="25400" marB="25400">
-                    <a:lnL w="19050" cap="flat" cmpd="sng" algn="ctr">
-                      <a:solidFill>
-                        <a:srgbClr val="FFFFFF"/>
-                      </a:solidFill>
-                      <a:prstDash val="solid"/>
-                    </a:lnL>
-                    <a:lnR w="19050" cap="flat" cmpd="sng" algn="ctr">
-                      <a:solidFill>
-                        <a:srgbClr val="FFFFFF"/>
-                      </a:solidFill>
-                      <a:prstDash val="solid"/>
-                    </a:lnR>
-                    <a:lnT w="19050" cap="flat" cmpd="sng" algn="ctr">
-                      <a:solidFill>
-                        <a:srgbClr val="FFFFFF"/>
-                      </a:solidFill>
-                      <a:prstDash val="solid"/>
-                    </a:lnT>
-                    <a:lnB w="19050" cap="flat" cmpd="sng" algn="ctr">
-                      <a:solidFill>
-                        <a:srgbClr val="FFFFFF"/>
-                      </a:solidFill>
-                      <a:prstDash val="solid"/>
-                    </a:lnB>
-                    <a:solidFill>
-                      <a:srgbClr val="F3F6F9"/>
-                    </a:solidFill>
-                  </a:tcPr>
-                </a:tc>
-                <a:tc>
-                  <a:txBody>
-                    <a:bodyPr wrap="square"/>
-                    <a:lstStyle/>
-                    <a:p>
-                      <a:pPr algn="l"/>
-                      <a:r>
-                        <a:rPr sz="1600" b="0" i="0" lang="es-ES">
-                          <a:solidFill>
-                            <a:srgbClr val="5E6B78"/>
-                          </a:solidFill>
-                        </a:rPr>
-                        <a:t>[pendiente]</a:t>
-                      </a:r>
-                    </a:p>
-                  </a:txBody>
-                  <a:tcPr anchor="ctr" marL="38100" marR="38100" marT="25400" marB="25400">
-                    <a:lnL w="19050" cap="flat" cmpd="sng" algn="ctr">
-                      <a:solidFill>
-                        <a:srgbClr val="FFFFFF"/>
-                      </a:solidFill>
-                      <a:prstDash val="solid"/>
-                    </a:lnL>
-                    <a:lnR w="19050" cap="flat" cmpd="sng" algn="ctr">
-                      <a:solidFill>
-                        <a:srgbClr val="FFFFFF"/>
-                      </a:solidFill>
-                      <a:prstDash val="solid"/>
-                    </a:lnR>
-                    <a:lnT w="19050" cap="flat" cmpd="sng" algn="ctr">
-                      <a:solidFill>
-                        <a:srgbClr val="FFFFFF"/>
-                      </a:solidFill>
-                      <a:prstDash val="solid"/>
-                    </a:lnT>
-                    <a:lnB w="19050" cap="flat" cmpd="sng" algn="ctr">
-                      <a:solidFill>
-                        <a:srgbClr val="FFFFFF"/>
-                      </a:solidFill>
-                      <a:prstDash val="solid"/>
-                    </a:lnB>
-                    <a:solidFill>
-                      <a:srgbClr val="F3F6F9"/>
-                    </a:solidFill>
-                  </a:tcPr>
-                </a:tc>
-                <a:tc>
-                  <a:txBody>
-                    <a:bodyPr wrap="square"/>
-                    <a:lstStyle/>
-                    <a:p>
-                      <a:pPr algn="l"/>
-                      <a:r>
-                        <a:rPr sz="1600" b="0" i="0" lang="es-ES">
-                          <a:solidFill>
-                            <a:srgbClr val="5E6B78"/>
-                          </a:solidFill>
-                        </a:rPr>
-                        <a:t>[pendiente]</a:t>
-                      </a:r>
-                    </a:p>
-                  </a:txBody>
-                  <a:tcPr anchor="ctr" marL="38100" marR="38100" marT="25400" marB="25400">
-                    <a:lnL w="19050" cap="flat" cmpd="sng" algn="ctr">
-                      <a:solidFill>
-                        <a:srgbClr val="FFFFFF"/>
-                      </a:solidFill>
-                      <a:prstDash val="solid"/>
-                    </a:lnL>
-                    <a:lnR w="19050" cap="flat" cmpd="sng" algn="ctr">
-                      <a:solidFill>
-                        <a:srgbClr val="FFFFFF"/>
-                      </a:solidFill>
-                      <a:prstDash val="solid"/>
-                    </a:lnR>
-                    <a:lnT w="19050" cap="flat" cmpd="sng" algn="ctr">
-                      <a:solidFill>
-                        <a:srgbClr val="FFFFFF"/>
-                      </a:solidFill>
-                      <a:prstDash val="solid"/>
-                    </a:lnT>
-                    <a:lnB w="19050" cap="flat" cmpd="sng" algn="ctr">
-                      <a:solidFill>
-                        <a:srgbClr val="FFFFFF"/>
-                      </a:solidFill>
-                      <a:prstDash val="solid"/>
-                    </a:lnB>
-                    <a:solidFill>
-                      <a:srgbClr val="F3F6F9"/>
-                    </a:solidFill>
-                  </a:tcPr>
-                </a:tc>
-              </a:tr>
-              <a:tr h="304800">
-                <a:tc rowSpan="3">
-                  <a:txBody>
-                    <a:bodyPr wrap="square"/>
-                    <a:lstStyle/>
-                    <a:p>
-                      <a:pPr algn="l"/>
-                      <a:r>
-                        <a:rPr sz="1600" b="1" i="0" lang="es-ES">
-                          <a:solidFill>
-                            <a:srgbClr val="263445"/>
-                          </a:solidFill>
-                        </a:rPr>
-                        <a:t>ChatGPT</a:t>
-                      </a:r>
-                    </a:p>
-                  </a:txBody>
-                  <a:tcPr anchor="ctr" marL="38100" marR="38100" marT="25400" marB="25400">
-                    <a:lnL w="19050" cap="flat" cmpd="sng" algn="ctr">
-                      <a:solidFill>
-                        <a:srgbClr val="FFFFFF"/>
-                      </a:solidFill>
-                      <a:prstDash val="solid"/>
-                    </a:lnL>
-                    <a:lnR w="19050" cap="flat" cmpd="sng" algn="ctr">
-                      <a:solidFill>
-                        <a:srgbClr val="FFFFFF"/>
-                      </a:solidFill>
-                      <a:prstDash val="solid"/>
-                    </a:lnR>
-                    <a:lnT w="31750" cap="flat" cmpd="sng" algn="ctr">
-                      <a:solidFill>
-                        <a:srgbClr val="263445"/>
-                      </a:solidFill>
-                      <a:prstDash val="solid"/>
-                    </a:lnT>
-                    <a:lnB w="19050" cap="flat" cmpd="sng" algn="ctr">
-                      <a:solidFill>
-                        <a:srgbClr val="FFFFFF"/>
-                      </a:solidFill>
-                      <a:prstDash val="solid"/>
-                    </a:lnB>
-                    <a:solidFill>
-                      <a:srgbClr val="FFFFFF"/>
-                    </a:solidFill>
-                  </a:tcPr>
-                </a:tc>
-                <a:tc>
-                  <a:txBody>
-                    <a:bodyPr wrap="square"/>
-                    <a:lstStyle/>
-                    <a:p>
-                      <a:pPr algn="ctr"/>
-                      <a:r>
-                        <a:rPr sz="1600" b="0" i="0" lang="es-ES">
-                          <a:solidFill>
-                            <a:srgbClr val="263445"/>
-                          </a:solidFill>
-                        </a:rPr>
-                        <a:t>1</a:t>
-                      </a:r>
-                    </a:p>
-                  </a:txBody>
-                  <a:tcPr anchor="ctr" marL="38100" marR="38100" marT="25400" marB="25400">
-                    <a:lnL w="19050" cap="flat" cmpd="sng" algn="ctr">
-                      <a:solidFill>
-                        <a:srgbClr val="FFFFFF"/>
-                      </a:solidFill>
-                      <a:prstDash val="solid"/>
-                    </a:lnL>
-                    <a:lnR w="19050" cap="flat" cmpd="sng" algn="ctr">
-                      <a:solidFill>
-                        <a:srgbClr val="FFFFFF"/>
-                      </a:solidFill>
-                      <a:prstDash val="solid"/>
-                    </a:lnR>
-                    <a:lnT w="31750" cap="flat" cmpd="sng" algn="ctr">
-                      <a:solidFill>
-                        <a:srgbClr val="263445"/>
-                      </a:solidFill>
-                      <a:prstDash val="solid"/>
-                    </a:lnT>
-                    <a:lnB w="19050" cap="flat" cmpd="sng" algn="ctr">
-                      <a:solidFill>
-                        <a:srgbClr val="FFFFFF"/>
-                      </a:solidFill>
-                      <a:prstDash val="solid"/>
-                    </a:lnB>
-                    <a:solidFill>
-                      <a:srgbClr val="FFFFFF"/>
-                    </a:solidFill>
-                  </a:tcPr>
-                </a:tc>
-                <a:tc>
-                  <a:txBody>
-                    <a:bodyPr wrap="square"/>
-                    <a:lstStyle/>
-                    <a:p>
-                      <a:pPr algn="ctr"/>
-                      <a:r>
-                        <a:rPr sz="1600" b="0" i="0" lang="es-ES">
-                          <a:solidFill>
-                            <a:srgbClr val="5E6B78"/>
-                          </a:solidFill>
-                        </a:rPr>
-                        <a:t>[pendiente]</a:t>
-                      </a:r>
-                    </a:p>
-                  </a:txBody>
-                  <a:tcPr anchor="ctr" marL="38100" marR="38100" marT="25400" marB="25400">
-                    <a:lnL w="19050" cap="flat" cmpd="sng" algn="ctr">
-                      <a:solidFill>
-                        <a:srgbClr val="FFFFFF"/>
-                      </a:solidFill>
-                      <a:prstDash val="solid"/>
-                    </a:lnL>
-                    <a:lnR w="19050" cap="flat" cmpd="sng" algn="ctr">
-                      <a:solidFill>
-                        <a:srgbClr val="FFFFFF"/>
-                      </a:solidFill>
-                      <a:prstDash val="solid"/>
-                    </a:lnR>
-                    <a:lnT w="31750" cap="flat" cmpd="sng" algn="ctr">
-                      <a:solidFill>
-                        <a:srgbClr val="263445"/>
-                      </a:solidFill>
-                      <a:prstDash val="solid"/>
-                    </a:lnT>
-                    <a:lnB w="19050" cap="flat" cmpd="sng" algn="ctr">
-                      <a:solidFill>
-                        <a:srgbClr val="FFFFFF"/>
-                      </a:solidFill>
-                      <a:prstDash val="solid"/>
-                    </a:lnB>
-                    <a:solidFill>
-                      <a:srgbClr val="F3F6F9"/>
-                    </a:solidFill>
-                  </a:tcPr>
-                </a:tc>
-                <a:tc>
-                  <a:txBody>
-                    <a:bodyPr wrap="square"/>
-                    <a:lstStyle/>
-                    <a:p>
-                      <a:pPr algn="l"/>
-                      <a:r>
-                        <a:rPr sz="1600" b="0" i="0" lang="es-ES">
-                          <a:solidFill>
-                            <a:srgbClr val="5E6B78"/>
-                          </a:solidFill>
-                        </a:rPr>
-                        <a:t>[pendiente]</a:t>
-                      </a:r>
-                    </a:p>
-                  </a:txBody>
-                  <a:tcPr anchor="ctr" marL="38100" marR="38100" marT="25400" marB="25400">
-                    <a:lnL w="19050" cap="flat" cmpd="sng" algn="ctr">
-                      <a:solidFill>
-                        <a:srgbClr val="FFFFFF"/>
-                      </a:solidFill>
-                      <a:prstDash val="solid"/>
-                    </a:lnL>
-                    <a:lnR w="19050" cap="flat" cmpd="sng" algn="ctr">
-                      <a:solidFill>
-                        <a:srgbClr val="FFFFFF"/>
-                      </a:solidFill>
-                      <a:prstDash val="solid"/>
-                    </a:lnR>
-                    <a:lnT w="31750" cap="flat" cmpd="sng" algn="ctr">
-                      <a:solidFill>
-                        <a:srgbClr val="263445"/>
-                      </a:solidFill>
-                      <a:prstDash val="solid"/>
-                    </a:lnT>
-                    <a:lnB w="19050" cap="flat" cmpd="sng" algn="ctr">
-                      <a:solidFill>
-                        <a:srgbClr val="FFFFFF"/>
-                      </a:solidFill>
-                      <a:prstDash val="solid"/>
-                    </a:lnB>
-                    <a:solidFill>
-                      <a:srgbClr val="F3F6F9"/>
-                    </a:solidFill>
-                  </a:tcPr>
-                </a:tc>
-                <a:tc>
-                  <a:txBody>
-                    <a:bodyPr wrap="square"/>
-                    <a:lstStyle/>
-                    <a:p>
-                      <a:pPr algn="l"/>
-                      <a:r>
-                        <a:rPr sz="1600" b="0" i="0" lang="es-ES">
-                          <a:solidFill>
-                            <a:srgbClr val="5E6B78"/>
-                          </a:solidFill>
-                        </a:rPr>
-                        <a:t>[pendiente]</a:t>
-                      </a:r>
-                    </a:p>
-                  </a:txBody>
-                  <a:tcPr anchor="ctr" marL="38100" marR="38100" marT="25400" marB="25400">
-                    <a:lnL w="19050" cap="flat" cmpd="sng" algn="ctr">
-                      <a:solidFill>
-                        <a:srgbClr val="FFFFFF"/>
-                      </a:solidFill>
-                      <a:prstDash val="solid"/>
-                    </a:lnL>
-                    <a:lnR w="19050" cap="flat" cmpd="sng" algn="ctr">
-                      <a:solidFill>
-                        <a:srgbClr val="FFFFFF"/>
-                      </a:solidFill>
-                      <a:prstDash val="solid"/>
-                    </a:lnR>
-                    <a:lnT w="31750" cap="flat" cmpd="sng" algn="ctr">
-                      <a:solidFill>
-                        <a:srgbClr val="263445"/>
-                      </a:solidFill>
-                      <a:prstDash val="solid"/>
-                    </a:lnT>
-                    <a:lnB w="19050" cap="flat" cmpd="sng" algn="ctr">
-                      <a:solidFill>
-                        <a:srgbClr val="FFFFFF"/>
-                      </a:solidFill>
-                      <a:prstDash val="solid"/>
-                    </a:lnB>
-                    <a:solidFill>
-                      <a:srgbClr val="F3F6F9"/>
-                    </a:solidFill>
-                  </a:tcPr>
-                </a:tc>
-                <a:tc>
-                  <a:txBody>
-                    <a:bodyPr wrap="square"/>
-                    <a:lstStyle/>
-                    <a:p>
-                      <a:pPr algn="l"/>
-                      <a:r>
-                        <a:rPr sz="1600" b="0" i="0" lang="es-ES">
-                          <a:solidFill>
-                            <a:srgbClr val="5E6B78"/>
-                          </a:solidFill>
-                        </a:rPr>
-                        <a:t>[pendiente]</a:t>
-                      </a:r>
-                    </a:p>
-                  </a:txBody>
-                  <a:tcPr anchor="ctr" marL="38100" marR="38100" marT="25400" marB="25400">
-                    <a:lnL w="19050" cap="flat" cmpd="sng" algn="ctr">
-                      <a:solidFill>
-                        <a:srgbClr val="FFFFFF"/>
-                      </a:solidFill>
-                      <a:prstDash val="solid"/>
-                    </a:lnL>
-                    <a:lnR w="19050" cap="flat" cmpd="sng" algn="ctr">
-                      <a:solidFill>
-                        <a:srgbClr val="FFFFFF"/>
-                      </a:solidFill>
-                      <a:prstDash val="solid"/>
-                    </a:lnR>
-                    <a:lnT w="31750" cap="flat" cmpd="sng" algn="ctr">
-                      <a:solidFill>
-                        <a:srgbClr val="263445"/>
-                      </a:solidFill>
-                      <a:prstDash val="solid"/>
-                    </a:lnT>
-                    <a:lnB w="19050" cap="flat" cmpd="sng" algn="ctr">
-                      <a:solidFill>
-                        <a:srgbClr val="FFFFFF"/>
-                      </a:solidFill>
-                      <a:prstDash val="solid"/>
-                    </a:lnB>
-                    <a:solidFill>
-                      <a:srgbClr val="F3F6F9"/>
-                    </a:solidFill>
-                  </a:tcPr>
-                </a:tc>
-              </a:tr>
-              <a:tr h="304800">
-                <a:tc vMerge="1">
-                  <a:txBody>
-                    <a:bodyPr wrap="square"/>
-                    <a:lstStyle/>
-                    <a:p/>
-                  </a:txBody>
-                  <a:tcPr anchor="ctr" marL="38100" marR="38100" marT="25400" marB="25400">
-                    <a:lnL w="19050" cap="flat" cmpd="sng" algn="ctr">
-                      <a:solidFill>
-                        <a:srgbClr val="FFFFFF"/>
-                      </a:solidFill>
-                      <a:prstDash val="solid"/>
-                    </a:lnL>
-                    <a:lnR w="19050" cap="flat" cmpd="sng" algn="ctr">
-                      <a:solidFill>
-                        <a:srgbClr val="FFFFFF"/>
-                      </a:solidFill>
-                      <a:prstDash val="solid"/>
-                    </a:lnR>
-                    <a:lnT w="19050" cap="flat" cmpd="sng" algn="ctr">
-                      <a:solidFill>
-                        <a:srgbClr val="FFFFFF"/>
-                      </a:solidFill>
-                      <a:prstDash val="solid"/>
-                    </a:lnT>
-                    <a:lnB w="19050" cap="flat" cmpd="sng" algn="ctr">
-                      <a:solidFill>
-                        <a:srgbClr val="FFFFFF"/>
-                      </a:solidFill>
-                      <a:prstDash val="solid"/>
-                    </a:lnB>
-                    <a:solidFill>
-                      <a:srgbClr val="FFFFFF"/>
-                    </a:solidFill>
-                  </a:tcPr>
-                </a:tc>
-                <a:tc>
-                  <a:txBody>
-                    <a:bodyPr wrap="square"/>
-                    <a:lstStyle/>
-                    <a:p>
-                      <a:pPr algn="ctr"/>
-                      <a:r>
-                        <a:rPr sz="1600" b="0" i="0" lang="es-ES">
-                          <a:solidFill>
-                            <a:srgbClr val="263445"/>
-                          </a:solidFill>
-                        </a:rPr>
-                        <a:t>2</a:t>
-                      </a:r>
-                    </a:p>
-                  </a:txBody>
-                  <a:tcPr anchor="ctr" marL="38100" marR="38100" marT="25400" marB="25400">
-                    <a:lnL w="19050" cap="flat" cmpd="sng" algn="ctr">
-                      <a:solidFill>
-                        <a:srgbClr val="FFFFFF"/>
-                      </a:solidFill>
-                      <a:prstDash val="solid"/>
-                    </a:lnL>
-                    <a:lnR w="19050" cap="flat" cmpd="sng" algn="ctr">
-                      <a:solidFill>
-                        <a:srgbClr val="FFFFFF"/>
-                      </a:solidFill>
-                      <a:prstDash val="solid"/>
-                    </a:lnR>
-                    <a:lnT w="19050" cap="flat" cmpd="sng" algn="ctr">
-                      <a:solidFill>
-                        <a:srgbClr val="FFFFFF"/>
-                      </a:solidFill>
-                      <a:prstDash val="solid"/>
-                    </a:lnT>
-                    <a:lnB w="19050" cap="flat" cmpd="sng" algn="ctr">
-                      <a:solidFill>
-                        <a:srgbClr val="FFFFFF"/>
-                      </a:solidFill>
-                      <a:prstDash val="solid"/>
-                    </a:lnB>
-                    <a:solidFill>
-                      <a:srgbClr val="FFFFFF"/>
-                    </a:solidFill>
-                  </a:tcPr>
-                </a:tc>
-                <a:tc>
-                  <a:txBody>
-                    <a:bodyPr wrap="square"/>
-                    <a:lstStyle/>
-                    <a:p>
-                      <a:pPr algn="ctr"/>
-                      <a:r>
-                        <a:rPr sz="1600" b="0" i="0" lang="es-ES">
-                          <a:solidFill>
-                            <a:srgbClr val="5E6B78"/>
-                          </a:solidFill>
-                        </a:rPr>
-                        <a:t>[pendiente]</a:t>
-                      </a:r>
-                    </a:p>
-                  </a:txBody>
-                  <a:tcPr anchor="ctr" marL="38100" marR="38100" marT="25400" marB="25400">
-                    <a:lnL w="19050" cap="flat" cmpd="sng" algn="ctr">
-                      <a:solidFill>
-                        <a:srgbClr val="FFFFFF"/>
-                      </a:solidFill>
-                      <a:prstDash val="solid"/>
-                    </a:lnL>
-                    <a:lnR w="19050" cap="flat" cmpd="sng" algn="ctr">
-                      <a:solidFill>
-                        <a:srgbClr val="FFFFFF"/>
-                      </a:solidFill>
-                      <a:prstDash val="solid"/>
-                    </a:lnR>
-                    <a:lnT w="19050" cap="flat" cmpd="sng" algn="ctr">
-                      <a:solidFill>
-                        <a:srgbClr val="FFFFFF"/>
-                      </a:solidFill>
-                      <a:prstDash val="solid"/>
-                    </a:lnT>
-                    <a:lnB w="19050" cap="flat" cmpd="sng" algn="ctr">
-                      <a:solidFill>
-                        <a:srgbClr val="FFFFFF"/>
-                      </a:solidFill>
-                      <a:prstDash val="solid"/>
-                    </a:lnB>
-                    <a:solidFill>
-                      <a:srgbClr val="F3F6F9"/>
-                    </a:solidFill>
-                  </a:tcPr>
-                </a:tc>
-                <a:tc>
-                  <a:txBody>
-                    <a:bodyPr wrap="square"/>
-                    <a:lstStyle/>
-                    <a:p>
-                      <a:pPr algn="l"/>
-                      <a:r>
-                        <a:rPr sz="1600" b="0" i="0" lang="es-ES">
-                          <a:solidFill>
-                            <a:srgbClr val="5E6B78"/>
-                          </a:solidFill>
-                        </a:rPr>
-                        <a:t>[pendiente]</a:t>
-                      </a:r>
-                    </a:p>
-                  </a:txBody>
-                  <a:tcPr anchor="ctr" marL="38100" marR="38100" marT="25400" marB="25400">
-                    <a:lnL w="19050" cap="flat" cmpd="sng" algn="ctr">
-                      <a:solidFill>
-                        <a:srgbClr val="FFFFFF"/>
-                      </a:solidFill>
-                      <a:prstDash val="solid"/>
-                    </a:lnL>
-                    <a:lnR w="19050" cap="flat" cmpd="sng" algn="ctr">
-                      <a:solidFill>
-                        <a:srgbClr val="FFFFFF"/>
-                      </a:solidFill>
-                      <a:prstDash val="solid"/>
-                    </a:lnR>
-                    <a:lnT w="19050" cap="flat" cmpd="sng" algn="ctr">
-                      <a:solidFill>
-                        <a:srgbClr val="FFFFFF"/>
-                      </a:solidFill>
-                      <a:prstDash val="solid"/>
-                    </a:lnT>
-                    <a:lnB w="19050" cap="flat" cmpd="sng" algn="ctr">
-                      <a:solidFill>
-                        <a:srgbClr val="FFFFFF"/>
-                      </a:solidFill>
-                      <a:prstDash val="solid"/>
-                    </a:lnB>
-                    <a:solidFill>
-                      <a:srgbClr val="F3F6F9"/>
-                    </a:solidFill>
-                  </a:tcPr>
-                </a:tc>
-                <a:tc>
-                  <a:txBody>
-                    <a:bodyPr wrap="square"/>
-                    <a:lstStyle/>
-                    <a:p>
-                      <a:pPr algn="l"/>
-                      <a:r>
-                        <a:rPr sz="1600" b="0" i="0" lang="es-ES">
-                          <a:solidFill>
-                            <a:srgbClr val="5E6B78"/>
-                          </a:solidFill>
-                        </a:rPr>
-                        <a:t>[pendiente]</a:t>
-                      </a:r>
-                    </a:p>
-                  </a:txBody>
-                  <a:tcPr anchor="ctr" marL="38100" marR="38100" marT="25400" marB="25400">
-                    <a:lnL w="19050" cap="flat" cmpd="sng" algn="ctr">
-                      <a:solidFill>
-                        <a:srgbClr val="FFFFFF"/>
-                      </a:solidFill>
-                      <a:prstDash val="solid"/>
-                    </a:lnL>
-                    <a:lnR w="19050" cap="flat" cmpd="sng" algn="ctr">
-                      <a:solidFill>
-                        <a:srgbClr val="FFFFFF"/>
-                      </a:solidFill>
-                      <a:prstDash val="solid"/>
-                    </a:lnR>
-                    <a:lnT w="19050" cap="flat" cmpd="sng" algn="ctr">
-                      <a:solidFill>
-                        <a:srgbClr val="FFFFFF"/>
-                      </a:solidFill>
-                      <a:prstDash val="solid"/>
-                    </a:lnT>
-                    <a:lnB w="19050" cap="flat" cmpd="sng" algn="ctr">
-                      <a:solidFill>
-                        <a:srgbClr val="FFFFFF"/>
-                      </a:solidFill>
-                      <a:prstDash val="solid"/>
-                    </a:lnB>
-                    <a:solidFill>
-                      <a:srgbClr val="F3F6F9"/>
-                    </a:solidFill>
-                  </a:tcPr>
-                </a:tc>
-                <a:tc>
-                  <a:txBody>
-                    <a:bodyPr wrap="square"/>
-                    <a:lstStyle/>
-                    <a:p>
-                      <a:pPr algn="l"/>
-                      <a:r>
-                        <a:rPr sz="1600" b="0" i="0" lang="es-ES">
-                          <a:solidFill>
-                            <a:srgbClr val="5E6B78"/>
-                          </a:solidFill>
-                        </a:rPr>
-                        <a:t>[pendiente]</a:t>
-                      </a:r>
-                    </a:p>
-                  </a:txBody>
-                  <a:tcPr anchor="ctr" marL="38100" marR="38100" marT="25400" marB="25400">
-                    <a:lnL w="19050" cap="flat" cmpd="sng" algn="ctr">
-                      <a:solidFill>
-                        <a:srgbClr val="FFFFFF"/>
-                      </a:solidFill>
-                      <a:prstDash val="solid"/>
-                    </a:lnL>
-                    <a:lnR w="19050" cap="flat" cmpd="sng" algn="ctr">
-                      <a:solidFill>
-                        <a:srgbClr val="FFFFFF"/>
-                      </a:solidFill>
-                      <a:prstDash val="solid"/>
-                    </a:lnR>
-                    <a:lnT w="19050" cap="flat" cmpd="sng" algn="ctr">
-                      <a:solidFill>
-                        <a:srgbClr val="FFFFFF"/>
-                      </a:solidFill>
-                      <a:prstDash val="solid"/>
-                    </a:lnT>
-                    <a:lnB w="19050" cap="flat" cmpd="sng" algn="ctr">
-                      <a:solidFill>
-                        <a:srgbClr val="FFFFFF"/>
-                      </a:solidFill>
-                      <a:prstDash val="solid"/>
-                    </a:lnB>
-                    <a:solidFill>
-                      <a:srgbClr val="F3F6F9"/>
-                    </a:solidFill>
-                  </a:tcPr>
-                </a:tc>
-              </a:tr>
-              <a:tr h="304800">
-                <a:tc vMerge="1">
-                  <a:txBody>
-                    <a:bodyPr wrap="square"/>
-                    <a:lstStyle/>
-                    <a:p/>
-                  </a:txBody>
-                  <a:tcPr anchor="ctr" marL="38100" marR="38100" marT="25400" marB="25400">
-                    <a:lnL w="19050" cap="flat" cmpd="sng" algn="ctr">
-                      <a:solidFill>
-                        <a:srgbClr val="FFFFFF"/>
-                      </a:solidFill>
-                      <a:prstDash val="solid"/>
-                    </a:lnL>
-                    <a:lnR w="19050" cap="flat" cmpd="sng" algn="ctr">
-                      <a:solidFill>
-                        <a:srgbClr val="FFFFFF"/>
-                      </a:solidFill>
-                      <a:prstDash val="solid"/>
-                    </a:lnR>
-                    <a:lnT w="19050" cap="flat" cmpd="sng" algn="ctr">
-                      <a:solidFill>
-                        <a:srgbClr val="FFFFFF"/>
-                      </a:solidFill>
-                      <a:prstDash val="solid"/>
-                    </a:lnT>
-                    <a:lnB w="19050" cap="flat" cmpd="sng" algn="ctr">
-                      <a:solidFill>
-                        <a:srgbClr val="FFFFFF"/>
-                      </a:solidFill>
-                      <a:prstDash val="solid"/>
-                    </a:lnB>
-                    <a:solidFill>
-                      <a:srgbClr val="FFFFFF"/>
-                    </a:solidFill>
-                  </a:tcPr>
-                </a:tc>
-                <a:tc>
-                  <a:txBody>
-                    <a:bodyPr wrap="square"/>
-                    <a:lstStyle/>
-                    <a:p>
-                      <a:pPr algn="ctr"/>
-                      <a:r>
-                        <a:rPr sz="1600" b="0" i="0" lang="es-ES">
-                          <a:solidFill>
-                            <a:srgbClr val="263445"/>
-                          </a:solidFill>
-                        </a:rPr>
-                        <a:t>3</a:t>
-                      </a:r>
-                    </a:p>
-                  </a:txBody>
-                  <a:tcPr anchor="ctr" marL="38100" marR="38100" marT="25400" marB="25400">
-                    <a:lnL w="19050" cap="flat" cmpd="sng" algn="ctr">
-                      <a:solidFill>
-                        <a:srgbClr val="FFFFFF"/>
-                      </a:solidFill>
-                      <a:prstDash val="solid"/>
-                    </a:lnL>
-                    <a:lnR w="19050" cap="flat" cmpd="sng" algn="ctr">
-                      <a:solidFill>
-                        <a:srgbClr val="FFFFFF"/>
-                      </a:solidFill>
-                      <a:prstDash val="solid"/>
-                    </a:lnR>
-                    <a:lnT w="19050" cap="flat" cmpd="sng" algn="ctr">
-                      <a:solidFill>
-                        <a:srgbClr val="FFFFFF"/>
-                      </a:solidFill>
-                      <a:prstDash val="solid"/>
-                    </a:lnT>
-                    <a:lnB w="19050" cap="flat" cmpd="sng" algn="ctr">
-                      <a:solidFill>
-                        <a:srgbClr val="FFFFFF"/>
-                      </a:solidFill>
-                      <a:prstDash val="solid"/>
-                    </a:lnB>
-                    <a:solidFill>
-                      <a:srgbClr val="FFFFFF"/>
-                    </a:solidFill>
-                  </a:tcPr>
-                </a:tc>
-                <a:tc>
-                  <a:txBody>
-                    <a:bodyPr wrap="square"/>
-                    <a:lstStyle/>
-                    <a:p>
-                      <a:pPr algn="ctr"/>
-                      <a:r>
-                        <a:rPr sz="1600" b="0" i="0" lang="es-ES">
-                          <a:solidFill>
-                            <a:srgbClr val="5E6B78"/>
-                          </a:solidFill>
-                        </a:rPr>
-                        <a:t>[pendiente]</a:t>
-                      </a:r>
-                    </a:p>
-                  </a:txBody>
-                  <a:tcPr anchor="ctr" marL="38100" marR="38100" marT="25400" marB="25400">
-                    <a:lnL w="19050" cap="flat" cmpd="sng" algn="ctr">
-                      <a:solidFill>
-                        <a:srgbClr val="FFFFFF"/>
-                      </a:solidFill>
-                      <a:prstDash val="solid"/>
-                    </a:lnL>
-                    <a:lnR w="19050" cap="flat" cmpd="sng" algn="ctr">
-                      <a:solidFill>
-                        <a:srgbClr val="FFFFFF"/>
-                      </a:solidFill>
-                      <a:prstDash val="solid"/>
-                    </a:lnR>
-                    <a:lnT w="19050" cap="flat" cmpd="sng" algn="ctr">
-                      <a:solidFill>
-                        <a:srgbClr val="FFFFFF"/>
-                      </a:solidFill>
-                      <a:prstDash val="solid"/>
-                    </a:lnT>
-                    <a:lnB w="19050" cap="flat" cmpd="sng" algn="ctr">
-                      <a:solidFill>
-                        <a:srgbClr val="FFFFFF"/>
-                      </a:solidFill>
-                      <a:prstDash val="solid"/>
-                    </a:lnB>
-                    <a:solidFill>
-                      <a:srgbClr val="F3F6F9"/>
-                    </a:solidFill>
-                  </a:tcPr>
-                </a:tc>
-                <a:tc>
-                  <a:txBody>
-                    <a:bodyPr wrap="square"/>
-                    <a:lstStyle/>
-                    <a:p>
-                      <a:pPr algn="l"/>
-                      <a:r>
-                        <a:rPr sz="1600" b="0" i="0" lang="es-ES">
-                          <a:solidFill>
-                            <a:srgbClr val="5E6B78"/>
-                          </a:solidFill>
-                        </a:rPr>
-                        <a:t>[pendiente]</a:t>
-                      </a:r>
-                    </a:p>
-                  </a:txBody>
-                  <a:tcPr anchor="ctr" marL="38100" marR="38100" marT="25400" marB="25400">
-                    <a:lnL w="19050" cap="flat" cmpd="sng" algn="ctr">
-                      <a:solidFill>
-                        <a:srgbClr val="FFFFFF"/>
-                      </a:solidFill>
-                      <a:prstDash val="solid"/>
-                    </a:lnL>
-                    <a:lnR w="19050" cap="flat" cmpd="sng" algn="ctr">
-                      <a:solidFill>
-                        <a:srgbClr val="FFFFFF"/>
-                      </a:solidFill>
-                      <a:prstDash val="solid"/>
-                    </a:lnR>
-                    <a:lnT w="19050" cap="flat" cmpd="sng" algn="ctr">
-                      <a:solidFill>
-                        <a:srgbClr val="FFFFFF"/>
-                      </a:solidFill>
-                      <a:prstDash val="solid"/>
-                    </a:lnT>
-                    <a:lnB w="19050" cap="flat" cmpd="sng" algn="ctr">
-                      <a:solidFill>
-                        <a:srgbClr val="FFFFFF"/>
-                      </a:solidFill>
-                      <a:prstDash val="solid"/>
-                    </a:lnB>
-                    <a:solidFill>
-                      <a:srgbClr val="F3F6F9"/>
-                    </a:solidFill>
-                  </a:tcPr>
-                </a:tc>
-                <a:tc>
-                  <a:txBody>
-                    <a:bodyPr wrap="square"/>
-                    <a:lstStyle/>
-                    <a:p>
-                      <a:pPr algn="l"/>
-                      <a:r>
-                        <a:rPr sz="1600" b="0" i="0" lang="es-ES">
-                          <a:solidFill>
-                            <a:srgbClr val="5E6B78"/>
-                          </a:solidFill>
-                        </a:rPr>
-                        <a:t>[pendiente]</a:t>
-                      </a:r>
-                    </a:p>
-                  </a:txBody>
-                  <a:tcPr anchor="ctr" marL="38100" marR="38100" marT="25400" marB="25400">
-                    <a:lnL w="19050" cap="flat" cmpd="sng" algn="ctr">
-                      <a:solidFill>
-                        <a:srgbClr val="FFFFFF"/>
-                      </a:solidFill>
-                      <a:prstDash val="solid"/>
-                    </a:lnL>
-                    <a:lnR w="19050" cap="flat" cmpd="sng" algn="ctr">
-                      <a:solidFill>
-                        <a:srgbClr val="FFFFFF"/>
-                      </a:solidFill>
-                      <a:prstDash val="solid"/>
-                    </a:lnR>
-                    <a:lnT w="19050" cap="flat" cmpd="sng" algn="ctr">
-                      <a:solidFill>
-                        <a:srgbClr val="FFFFFF"/>
-                      </a:solidFill>
-                      <a:prstDash val="solid"/>
-                    </a:lnT>
-                    <a:lnB w="19050" cap="flat" cmpd="sng" algn="ctr">
-                      <a:solidFill>
-                        <a:srgbClr val="FFFFFF"/>
-                      </a:solidFill>
-                      <a:prstDash val="solid"/>
-                    </a:lnB>
-                    <a:solidFill>
-                      <a:srgbClr val="F3F6F9"/>
-                    </a:solidFill>
-                  </a:tcPr>
-                </a:tc>
-                <a:tc>
-                  <a:txBody>
-                    <a:bodyPr wrap="square"/>
-                    <a:lstStyle/>
-                    <a:p>
-                      <a:pPr algn="l"/>
-                      <a:r>
-                        <a:rPr sz="1600" b="0" i="0" lang="es-ES">
-                          <a:solidFill>
-                            <a:srgbClr val="5E6B78"/>
-                          </a:solidFill>
-                        </a:rPr>
-                        <a:t>[pendiente]</a:t>
-                      </a:r>
-                    </a:p>
-                  </a:txBody>
-                  <a:tcPr anchor="ctr" marL="38100" marR="38100" marT="25400" marB="25400">
-                    <a:lnL w="19050" cap="flat" cmpd="sng" algn="ctr">
-                      <a:solidFill>
-                        <a:srgbClr val="FFFFFF"/>
-                      </a:solidFill>
-                      <a:prstDash val="solid"/>
-                    </a:lnL>
-                    <a:lnR w="19050" cap="flat" cmpd="sng" algn="ctr">
-                      <a:solidFill>
-                        <a:srgbClr val="FFFFFF"/>
-                      </a:solidFill>
-                      <a:prstDash val="solid"/>
-                    </a:lnR>
-                    <a:lnT w="19050" cap="flat" cmpd="sng" algn="ctr">
-                      <a:solidFill>
-                        <a:srgbClr val="FFFFFF"/>
-                      </a:solidFill>
-                      <a:prstDash val="solid"/>
-                    </a:lnT>
-                    <a:lnB w="19050" cap="flat" cmpd="sng" algn="ctr">
-                      <a:solidFill>
-                        <a:srgbClr val="FFFFFF"/>
-                      </a:solidFill>
-                      <a:prstDash val="solid"/>
-                    </a:lnB>
-                    <a:solidFill>
-                      <a:srgbClr val="F3F6F9"/>
-                    </a:solidFill>
-                  </a:tcPr>
-                </a:tc>
-              </a:tr>
-            </a:tbl>
-          </a:graphicData>
-        </a:graphic>
-      </p:graphicFrame>
-      <p:sp>
-        <p:nvSpPr>
-          <p:cNvPr id="7" name="Franja"/>
-          <p:cNvSpPr/>
-          <p:nvPr/>
-        </p:nvSpPr>
-        <p:spPr>
-          <a:xfrm>
-            <a:off x="508000" y="5676900"/>
-            <a:ext cx="11176000" cy="444500"/>
-          </a:xfrm>
-          <a:prstGeom prst="roundRect">
-            <a:avLst>
-              <a:gd name="adj" fmla="val 22857"/>
-            </a:avLst>
-          </a:prstGeom>
-          <a:solidFill>
-            <a:srgbClr val="263445"/>
-          </a:solidFill>
-          <a:ln>
-            <a:noFill/>
-          </a:ln>
-        </p:spPr>
-        <p:txBody>
-          <a:bodyPr rtlCol="0" anchor="ctr" wrap="square" lIns="101600" tIns="0" rIns="101600" bIns="0">
-            <a:noAutofit/>
-          </a:bodyPr>
-          <a:lstStyle/>
-          <a:p>
-            <a:pPr algn="ctr"/>
-            <a:r>
-              <a:rPr sz="2200" b="1" i="0" lang="es-ES">
-                <a:solidFill>
-                  <a:srgbClr val="FFFFFF"/>
-                </a:solidFill>
-              </a:rPr>
-              <a:t>Dosis recomendada: 750 mg/12 h en las 9 respuestas · lo que cambia es el juicio que la rodea</a:t>
-            </a:r>
-          </a:p>
-        </p:txBody>
-      </p:sp>
-      <p:sp>
-        <p:nvSpPr>
-          <p:cNvPr id="8" name="Fuente"/>
+            <a:pPr algn="r">
+              <a:lnSpc>
+                <a:spcPct val="80000"/>
+              </a:lnSpc>
+            </a:pPr>
+            <a:r>
+              <a:rPr sz="7200" b="1" i="0" lang="es-ES">
+                <a:solidFill>
+                  <a:srgbClr val="2B7D3D"/>
+                </a:solidFill>
+              </a:rPr>
+              <a:t>8/9</a:t>
+            </a:r>
+          </a:p>
+        </p:txBody>
+      </p:sp>
+      <p:sp>
+        <p:nvSpPr>
+          <p:cNvPr id="18" name="Texto 2"/>
           <p:cNvSpPr txBox="1"/>
           <p:nvPr/>
         </p:nvSpPr>
         <p:spPr>
           <a:xfrm>
-            <a:off x="508000" y="6337300"/>
-            <a:ext cx="11176000" cy="241300"/>
+            <a:off x="6024118" y="2838450"/>
+            <a:ext cx="5660136" cy="342900"/>
           </a:xfrm>
           <a:prstGeom prst="rect">
             <a:avLst/>
@@ -4615,6 +2185,1067 @@
           </a:bodyPr>
           <a:lstStyle/>
           <a:p>
+            <a:pPr algn="l">
+              <a:lnSpc>
+                <a:spcPct val="95000"/>
+              </a:lnSpc>
+            </a:pPr>
+            <a:r>
+              <a:rPr sz="2200" b="0" i="0" lang="es-ES">
+                <a:solidFill>
+                  <a:srgbClr val="263445"/>
+                </a:solidFill>
+              </a:rPr>
+              <a:t>AUC</a:t>
+            </a:r>
+            <a:r>
+              <a:rPr sz="2200" b="0" i="0" lang="es-ES" baseline="-25000">
+                <a:solidFill>
+                  <a:srgbClr val="263445"/>
+                </a:solidFill>
+              </a:rPr>
+              <a:t>24</a:t>
+            </a:r>
+            <a:r>
+              <a:rPr sz="2200" b="0" i="0" lang="es-ES">
+                <a:solidFill>
+                  <a:srgbClr val="263445"/>
+                </a:solidFill>
+              </a:rPr>
+              <a:t> actual correcto</a:t>
+            </a:r>
+          </a:p>
+        </p:txBody>
+      </p:sp>
+      <p:sp>
+        <p:nvSpPr>
+          <p:cNvPr id="19" name="Segmento 2.1"/>
+          <p:cNvSpPr/>
+          <p:nvPr/>
+        </p:nvSpPr>
+        <p:spPr>
+          <a:xfrm>
+            <a:off x="6024118" y="3270250"/>
+            <a:ext cx="572460" cy="165100"/>
+          </a:xfrm>
+          <a:prstGeom prst="roundRect">
+            <a:avLst>
+              <a:gd name="adj" fmla="val 23076"/>
+            </a:avLst>
+          </a:prstGeom>
+          <a:solidFill>
+            <a:srgbClr val="5BB46C"/>
+          </a:solidFill>
+          <a:ln>
+            <a:noFill/>
+          </a:ln>
+        </p:spPr>
+        <p:txBody>
+          <a:bodyPr rtlCol="0" anchor="ctr"/>
+          <a:lstStyle/>
+          <a:p>
+            <a:pPr algn="ctr"/>
+          </a:p>
+        </p:txBody>
+      </p:sp>
+      <p:sp>
+        <p:nvSpPr>
+          <p:cNvPr id="20" name="Segmento 2.2"/>
+          <p:cNvSpPr/>
+          <p:nvPr/>
+        </p:nvSpPr>
+        <p:spPr>
+          <a:xfrm>
+            <a:off x="6660078" y="3270250"/>
+            <a:ext cx="572460" cy="165100"/>
+          </a:xfrm>
+          <a:prstGeom prst="roundRect">
+            <a:avLst>
+              <a:gd name="adj" fmla="val 23076"/>
+            </a:avLst>
+          </a:prstGeom>
+          <a:solidFill>
+            <a:srgbClr val="5BB46C"/>
+          </a:solidFill>
+          <a:ln>
+            <a:noFill/>
+          </a:ln>
+        </p:spPr>
+        <p:txBody>
+          <a:bodyPr rtlCol="0" anchor="ctr"/>
+          <a:lstStyle/>
+          <a:p>
+            <a:pPr algn="ctr"/>
+          </a:p>
+        </p:txBody>
+      </p:sp>
+      <p:sp>
+        <p:nvSpPr>
+          <p:cNvPr id="21" name="Segmento 2.3"/>
+          <p:cNvSpPr/>
+          <p:nvPr/>
+        </p:nvSpPr>
+        <p:spPr>
+          <a:xfrm>
+            <a:off x="7296037" y="3270250"/>
+            <a:ext cx="572460" cy="165100"/>
+          </a:xfrm>
+          <a:prstGeom prst="roundRect">
+            <a:avLst>
+              <a:gd name="adj" fmla="val 23076"/>
+            </a:avLst>
+          </a:prstGeom>
+          <a:solidFill>
+            <a:srgbClr val="5BB46C"/>
+          </a:solidFill>
+          <a:ln>
+            <a:noFill/>
+          </a:ln>
+        </p:spPr>
+        <p:txBody>
+          <a:bodyPr rtlCol="0" anchor="ctr"/>
+          <a:lstStyle/>
+          <a:p>
+            <a:pPr algn="ctr"/>
+          </a:p>
+        </p:txBody>
+      </p:sp>
+      <p:sp>
+        <p:nvSpPr>
+          <p:cNvPr id="22" name="Segmento 2.4"/>
+          <p:cNvSpPr/>
+          <p:nvPr/>
+        </p:nvSpPr>
+        <p:spPr>
+          <a:xfrm>
+            <a:off x="7931997" y="3270250"/>
+            <a:ext cx="572460" cy="165100"/>
+          </a:xfrm>
+          <a:prstGeom prst="roundRect">
+            <a:avLst>
+              <a:gd name="adj" fmla="val 23076"/>
+            </a:avLst>
+          </a:prstGeom>
+          <a:solidFill>
+            <a:srgbClr val="5BB46C"/>
+          </a:solidFill>
+          <a:ln>
+            <a:noFill/>
+          </a:ln>
+        </p:spPr>
+        <p:txBody>
+          <a:bodyPr rtlCol="0" anchor="ctr"/>
+          <a:lstStyle/>
+          <a:p>
+            <a:pPr algn="ctr"/>
+          </a:p>
+        </p:txBody>
+      </p:sp>
+      <p:sp>
+        <p:nvSpPr>
+          <p:cNvPr id="23" name="Segmento 2.5"/>
+          <p:cNvSpPr/>
+          <p:nvPr/>
+        </p:nvSpPr>
+        <p:spPr>
+          <a:xfrm>
+            <a:off x="8567956" y="3270250"/>
+            <a:ext cx="572460" cy="165100"/>
+          </a:xfrm>
+          <a:prstGeom prst="roundRect">
+            <a:avLst>
+              <a:gd name="adj" fmla="val 23076"/>
+            </a:avLst>
+          </a:prstGeom>
+          <a:solidFill>
+            <a:srgbClr val="5BB46C"/>
+          </a:solidFill>
+          <a:ln>
+            <a:noFill/>
+          </a:ln>
+        </p:spPr>
+        <p:txBody>
+          <a:bodyPr rtlCol="0" anchor="ctr"/>
+          <a:lstStyle/>
+          <a:p>
+            <a:pPr algn="ctr"/>
+          </a:p>
+        </p:txBody>
+      </p:sp>
+      <p:sp>
+        <p:nvSpPr>
+          <p:cNvPr id="24" name="Segmento 2.6"/>
+          <p:cNvSpPr/>
+          <p:nvPr/>
+        </p:nvSpPr>
+        <p:spPr>
+          <a:xfrm>
+            <a:off x="9203916" y="3270250"/>
+            <a:ext cx="572460" cy="165100"/>
+          </a:xfrm>
+          <a:prstGeom prst="roundRect">
+            <a:avLst>
+              <a:gd name="adj" fmla="val 23076"/>
+            </a:avLst>
+          </a:prstGeom>
+          <a:solidFill>
+            <a:srgbClr val="5BB46C"/>
+          </a:solidFill>
+          <a:ln>
+            <a:noFill/>
+          </a:ln>
+        </p:spPr>
+        <p:txBody>
+          <a:bodyPr rtlCol="0" anchor="ctr"/>
+          <a:lstStyle/>
+          <a:p>
+            <a:pPr algn="ctr"/>
+          </a:p>
+        </p:txBody>
+      </p:sp>
+      <p:sp>
+        <p:nvSpPr>
+          <p:cNvPr id="25" name="Segmento 2.7"/>
+          <p:cNvSpPr/>
+          <p:nvPr/>
+        </p:nvSpPr>
+        <p:spPr>
+          <a:xfrm>
+            <a:off x="9839875" y="3270250"/>
+            <a:ext cx="572460" cy="165100"/>
+          </a:xfrm>
+          <a:prstGeom prst="roundRect">
+            <a:avLst>
+              <a:gd name="adj" fmla="val 23076"/>
+            </a:avLst>
+          </a:prstGeom>
+          <a:solidFill>
+            <a:srgbClr val="5BB46C"/>
+          </a:solidFill>
+          <a:ln>
+            <a:noFill/>
+          </a:ln>
+        </p:spPr>
+        <p:txBody>
+          <a:bodyPr rtlCol="0" anchor="ctr"/>
+          <a:lstStyle/>
+          <a:p>
+            <a:pPr algn="ctr"/>
+          </a:p>
+        </p:txBody>
+      </p:sp>
+      <p:sp>
+        <p:nvSpPr>
+          <p:cNvPr id="26" name="Segmento 2.8"/>
+          <p:cNvSpPr/>
+          <p:nvPr/>
+        </p:nvSpPr>
+        <p:spPr>
+          <a:xfrm>
+            <a:off x="10475835" y="3270250"/>
+            <a:ext cx="572460" cy="165100"/>
+          </a:xfrm>
+          <a:prstGeom prst="roundRect">
+            <a:avLst>
+              <a:gd name="adj" fmla="val 23076"/>
+            </a:avLst>
+          </a:prstGeom>
+          <a:solidFill>
+            <a:srgbClr val="5BB46C"/>
+          </a:solidFill>
+          <a:ln>
+            <a:noFill/>
+          </a:ln>
+        </p:spPr>
+        <p:txBody>
+          <a:bodyPr rtlCol="0" anchor="ctr"/>
+          <a:lstStyle/>
+          <a:p>
+            <a:pPr algn="ctr"/>
+          </a:p>
+        </p:txBody>
+      </p:sp>
+      <p:sp>
+        <p:nvSpPr>
+          <p:cNvPr id="27" name="Segmento 2.9"/>
+          <p:cNvSpPr/>
+          <p:nvPr/>
+        </p:nvSpPr>
+        <p:spPr>
+          <a:xfrm>
+            <a:off x="11111794" y="3270250"/>
+            <a:ext cx="572460" cy="165100"/>
+          </a:xfrm>
+          <a:prstGeom prst="roundRect">
+            <a:avLst>
+              <a:gd name="adj" fmla="val 23076"/>
+            </a:avLst>
+          </a:prstGeom>
+          <a:solidFill>
+            <a:srgbClr val="FFFFFF"/>
+          </a:solidFill>
+          <a:ln w="19050">
+            <a:solidFill>
+              <a:srgbClr val="C9D2DB"/>
+            </a:solidFill>
+          </a:ln>
+        </p:spPr>
+        <p:txBody>
+          <a:bodyPr rtlCol="0" anchor="ctr"/>
+          <a:lstStyle/>
+          <a:p>
+            <a:pPr algn="ctr"/>
+          </a:p>
+        </p:txBody>
+      </p:sp>
+      <p:sp>
+        <p:nvSpPr>
+          <p:cNvPr id="28" name="Cifra 3"/>
+          <p:cNvSpPr txBox="1"/>
+          <p:nvPr/>
+        </p:nvSpPr>
+        <p:spPr>
+          <a:xfrm>
+            <a:off x="4284218" y="3632200"/>
+            <a:ext cx="1587500" cy="990600"/>
+          </a:xfrm>
+          <a:prstGeom prst="rect">
+            <a:avLst/>
+          </a:prstGeom>
+          <a:noFill/>
+        </p:spPr>
+        <p:txBody>
+          <a:bodyPr wrap="square" lIns="0" tIns="0" rIns="0" bIns="0" anchor="ctr">
+            <a:noAutofit/>
+          </a:bodyPr>
+          <a:lstStyle/>
+          <a:p>
+            <a:pPr algn="r">
+              <a:lnSpc>
+                <a:spcPct val="80000"/>
+              </a:lnSpc>
+            </a:pPr>
+            <a:r>
+              <a:rPr sz="7200" b="1" i="0" lang="es-ES">
+                <a:solidFill>
+                  <a:srgbClr val="2B7D3D"/>
+                </a:solidFill>
+              </a:rPr>
+              <a:t>7/9</a:t>
+            </a:r>
+          </a:p>
+        </p:txBody>
+      </p:sp>
+      <p:sp>
+        <p:nvSpPr>
+          <p:cNvPr id="29" name="Texto 3"/>
+          <p:cNvSpPr txBox="1"/>
+          <p:nvPr/>
+        </p:nvSpPr>
+        <p:spPr>
+          <a:xfrm>
+            <a:off x="6024118" y="3829050"/>
+            <a:ext cx="5660136" cy="342900"/>
+          </a:xfrm>
+          <a:prstGeom prst="rect">
+            <a:avLst/>
+          </a:prstGeom>
+          <a:noFill/>
+        </p:spPr>
+        <p:txBody>
+          <a:bodyPr wrap="square" lIns="0" tIns="0" rIns="0" bIns="0" anchor="b">
+            <a:noAutofit/>
+          </a:bodyPr>
+          <a:lstStyle/>
+          <a:p>
+            <a:pPr algn="l">
+              <a:lnSpc>
+                <a:spcPct val="95000"/>
+              </a:lnSpc>
+            </a:pPr>
+            <a:r>
+              <a:rPr sz="2200" b="0" i="0" lang="es-ES">
+                <a:solidFill>
+                  <a:srgbClr val="263445"/>
+                </a:solidFill>
+              </a:rPr>
+              <a:t>no omitieron la dosis de las 20:00</a:t>
+            </a:r>
+          </a:p>
+        </p:txBody>
+      </p:sp>
+      <p:sp>
+        <p:nvSpPr>
+          <p:cNvPr id="30" name="Segmento 3.1"/>
+          <p:cNvSpPr/>
+          <p:nvPr/>
+        </p:nvSpPr>
+        <p:spPr>
+          <a:xfrm>
+            <a:off x="6024118" y="4260850"/>
+            <a:ext cx="572460" cy="165100"/>
+          </a:xfrm>
+          <a:prstGeom prst="roundRect">
+            <a:avLst>
+              <a:gd name="adj" fmla="val 23076"/>
+            </a:avLst>
+          </a:prstGeom>
+          <a:solidFill>
+            <a:srgbClr val="5BB46C"/>
+          </a:solidFill>
+          <a:ln>
+            <a:noFill/>
+          </a:ln>
+        </p:spPr>
+        <p:txBody>
+          <a:bodyPr rtlCol="0" anchor="ctr"/>
+          <a:lstStyle/>
+          <a:p>
+            <a:pPr algn="ctr"/>
+          </a:p>
+        </p:txBody>
+      </p:sp>
+      <p:sp>
+        <p:nvSpPr>
+          <p:cNvPr id="31" name="Segmento 3.2"/>
+          <p:cNvSpPr/>
+          <p:nvPr/>
+        </p:nvSpPr>
+        <p:spPr>
+          <a:xfrm>
+            <a:off x="6660078" y="4260850"/>
+            <a:ext cx="572460" cy="165100"/>
+          </a:xfrm>
+          <a:prstGeom prst="roundRect">
+            <a:avLst>
+              <a:gd name="adj" fmla="val 23076"/>
+            </a:avLst>
+          </a:prstGeom>
+          <a:solidFill>
+            <a:srgbClr val="5BB46C"/>
+          </a:solidFill>
+          <a:ln>
+            <a:noFill/>
+          </a:ln>
+        </p:spPr>
+        <p:txBody>
+          <a:bodyPr rtlCol="0" anchor="ctr"/>
+          <a:lstStyle/>
+          <a:p>
+            <a:pPr algn="ctr"/>
+          </a:p>
+        </p:txBody>
+      </p:sp>
+      <p:sp>
+        <p:nvSpPr>
+          <p:cNvPr id="32" name="Segmento 3.3"/>
+          <p:cNvSpPr/>
+          <p:nvPr/>
+        </p:nvSpPr>
+        <p:spPr>
+          <a:xfrm>
+            <a:off x="7296037" y="4260850"/>
+            <a:ext cx="572460" cy="165100"/>
+          </a:xfrm>
+          <a:prstGeom prst="roundRect">
+            <a:avLst>
+              <a:gd name="adj" fmla="val 23076"/>
+            </a:avLst>
+          </a:prstGeom>
+          <a:solidFill>
+            <a:srgbClr val="5BB46C"/>
+          </a:solidFill>
+          <a:ln>
+            <a:noFill/>
+          </a:ln>
+        </p:spPr>
+        <p:txBody>
+          <a:bodyPr rtlCol="0" anchor="ctr"/>
+          <a:lstStyle/>
+          <a:p>
+            <a:pPr algn="ctr"/>
+          </a:p>
+        </p:txBody>
+      </p:sp>
+      <p:sp>
+        <p:nvSpPr>
+          <p:cNvPr id="33" name="Segmento 3.4"/>
+          <p:cNvSpPr/>
+          <p:nvPr/>
+        </p:nvSpPr>
+        <p:spPr>
+          <a:xfrm>
+            <a:off x="7931997" y="4260850"/>
+            <a:ext cx="572460" cy="165100"/>
+          </a:xfrm>
+          <a:prstGeom prst="roundRect">
+            <a:avLst>
+              <a:gd name="adj" fmla="val 23076"/>
+            </a:avLst>
+          </a:prstGeom>
+          <a:solidFill>
+            <a:srgbClr val="5BB46C"/>
+          </a:solidFill>
+          <a:ln>
+            <a:noFill/>
+          </a:ln>
+        </p:spPr>
+        <p:txBody>
+          <a:bodyPr rtlCol="0" anchor="ctr"/>
+          <a:lstStyle/>
+          <a:p>
+            <a:pPr algn="ctr"/>
+          </a:p>
+        </p:txBody>
+      </p:sp>
+      <p:sp>
+        <p:nvSpPr>
+          <p:cNvPr id="34" name="Segmento 3.5"/>
+          <p:cNvSpPr/>
+          <p:nvPr/>
+        </p:nvSpPr>
+        <p:spPr>
+          <a:xfrm>
+            <a:off x="8567956" y="4260850"/>
+            <a:ext cx="572460" cy="165100"/>
+          </a:xfrm>
+          <a:prstGeom prst="roundRect">
+            <a:avLst>
+              <a:gd name="adj" fmla="val 23076"/>
+            </a:avLst>
+          </a:prstGeom>
+          <a:solidFill>
+            <a:srgbClr val="5BB46C"/>
+          </a:solidFill>
+          <a:ln>
+            <a:noFill/>
+          </a:ln>
+        </p:spPr>
+        <p:txBody>
+          <a:bodyPr rtlCol="0" anchor="ctr"/>
+          <a:lstStyle/>
+          <a:p>
+            <a:pPr algn="ctr"/>
+          </a:p>
+        </p:txBody>
+      </p:sp>
+      <p:sp>
+        <p:nvSpPr>
+          <p:cNvPr id="35" name="Segmento 3.6"/>
+          <p:cNvSpPr/>
+          <p:nvPr/>
+        </p:nvSpPr>
+        <p:spPr>
+          <a:xfrm>
+            <a:off x="9203916" y="4260850"/>
+            <a:ext cx="572460" cy="165100"/>
+          </a:xfrm>
+          <a:prstGeom prst="roundRect">
+            <a:avLst>
+              <a:gd name="adj" fmla="val 23076"/>
+            </a:avLst>
+          </a:prstGeom>
+          <a:solidFill>
+            <a:srgbClr val="5BB46C"/>
+          </a:solidFill>
+          <a:ln>
+            <a:noFill/>
+          </a:ln>
+        </p:spPr>
+        <p:txBody>
+          <a:bodyPr rtlCol="0" anchor="ctr"/>
+          <a:lstStyle/>
+          <a:p>
+            <a:pPr algn="ctr"/>
+          </a:p>
+        </p:txBody>
+      </p:sp>
+      <p:sp>
+        <p:nvSpPr>
+          <p:cNvPr id="36" name="Segmento 3.7"/>
+          <p:cNvSpPr/>
+          <p:nvPr/>
+        </p:nvSpPr>
+        <p:spPr>
+          <a:xfrm>
+            <a:off x="9839875" y="4260850"/>
+            <a:ext cx="572460" cy="165100"/>
+          </a:xfrm>
+          <a:prstGeom prst="roundRect">
+            <a:avLst>
+              <a:gd name="adj" fmla="val 23076"/>
+            </a:avLst>
+          </a:prstGeom>
+          <a:solidFill>
+            <a:srgbClr val="5BB46C"/>
+          </a:solidFill>
+          <a:ln>
+            <a:noFill/>
+          </a:ln>
+        </p:spPr>
+        <p:txBody>
+          <a:bodyPr rtlCol="0" anchor="ctr"/>
+          <a:lstStyle/>
+          <a:p>
+            <a:pPr algn="ctr"/>
+          </a:p>
+        </p:txBody>
+      </p:sp>
+      <p:sp>
+        <p:nvSpPr>
+          <p:cNvPr id="37" name="Segmento 3.8"/>
+          <p:cNvSpPr/>
+          <p:nvPr/>
+        </p:nvSpPr>
+        <p:spPr>
+          <a:xfrm>
+            <a:off x="10475835" y="4260850"/>
+            <a:ext cx="572460" cy="165100"/>
+          </a:xfrm>
+          <a:prstGeom prst="roundRect">
+            <a:avLst>
+              <a:gd name="adj" fmla="val 23076"/>
+            </a:avLst>
+          </a:prstGeom>
+          <a:solidFill>
+            <a:srgbClr val="FFFFFF"/>
+          </a:solidFill>
+          <a:ln w="19050">
+            <a:solidFill>
+              <a:srgbClr val="C9D2DB"/>
+            </a:solidFill>
+          </a:ln>
+        </p:spPr>
+        <p:txBody>
+          <a:bodyPr rtlCol="0" anchor="ctr"/>
+          <a:lstStyle/>
+          <a:p>
+            <a:pPr algn="ctr"/>
+          </a:p>
+        </p:txBody>
+      </p:sp>
+      <p:sp>
+        <p:nvSpPr>
+          <p:cNvPr id="38" name="Segmento 3.9"/>
+          <p:cNvSpPr/>
+          <p:nvPr/>
+        </p:nvSpPr>
+        <p:spPr>
+          <a:xfrm>
+            <a:off x="11111794" y="4260850"/>
+            <a:ext cx="572460" cy="165100"/>
+          </a:xfrm>
+          <a:prstGeom prst="roundRect">
+            <a:avLst>
+              <a:gd name="adj" fmla="val 23076"/>
+            </a:avLst>
+          </a:prstGeom>
+          <a:solidFill>
+            <a:srgbClr val="FFFFFF"/>
+          </a:solidFill>
+          <a:ln w="19050">
+            <a:solidFill>
+              <a:srgbClr val="C9D2DB"/>
+            </a:solidFill>
+          </a:ln>
+        </p:spPr>
+        <p:txBody>
+          <a:bodyPr rtlCol="0" anchor="ctr"/>
+          <a:lstStyle/>
+          <a:p>
+            <a:pPr algn="ctr"/>
+          </a:p>
+        </p:txBody>
+      </p:sp>
+      <p:sp>
+        <p:nvSpPr>
+          <p:cNvPr id="39" name="Cifra 4"/>
+          <p:cNvSpPr txBox="1"/>
+          <p:nvPr/>
+        </p:nvSpPr>
+        <p:spPr>
+          <a:xfrm>
+            <a:off x="4284218" y="4927600"/>
+            <a:ext cx="1587500" cy="1016000"/>
+          </a:xfrm>
+          <a:prstGeom prst="rect">
+            <a:avLst/>
+          </a:prstGeom>
+          <a:noFill/>
+        </p:spPr>
+        <p:txBody>
+          <a:bodyPr wrap="square" lIns="0" tIns="0" rIns="0" bIns="0" anchor="ctr">
+            <a:noAutofit/>
+          </a:bodyPr>
+          <a:lstStyle/>
+          <a:p>
+            <a:pPr algn="r">
+              <a:lnSpc>
+                <a:spcPct val="80000"/>
+              </a:lnSpc>
+            </a:pPr>
+            <a:r>
+              <a:rPr sz="7200" b="1" i="0" lang="es-ES">
+                <a:solidFill>
+                  <a:srgbClr val="D42A3B"/>
+                </a:solidFill>
+              </a:rPr>
+              <a:t>3/9</a:t>
+            </a:r>
+          </a:p>
+        </p:txBody>
+      </p:sp>
+      <p:sp>
+        <p:nvSpPr>
+          <p:cNvPr id="40" name="Texto 4"/>
+          <p:cNvSpPr txBox="1"/>
+          <p:nvPr/>
+        </p:nvSpPr>
+        <p:spPr>
+          <a:xfrm>
+            <a:off x="6024118" y="4965700"/>
+            <a:ext cx="5660136" cy="685800"/>
+          </a:xfrm>
+          <a:prstGeom prst="rect">
+            <a:avLst/>
+          </a:prstGeom>
+          <a:noFill/>
+        </p:spPr>
+        <p:txBody>
+          <a:bodyPr wrap="square" lIns="0" tIns="0" rIns="0" bIns="0" anchor="b">
+            <a:noAutofit/>
+          </a:bodyPr>
+          <a:lstStyle/>
+          <a:p>
+            <a:pPr algn="l">
+              <a:lnSpc>
+                <a:spcPct val="95000"/>
+              </a:lnSpc>
+            </a:pPr>
+            <a:r>
+              <a:rPr sz="2200" b="0" i="0" lang="es-ES">
+                <a:solidFill>
+                  <a:srgbClr val="263445"/>
+                </a:solidFill>
+              </a:rPr>
+              <a:t>respetaron la velocidad de perfusión de la ficha técnica (≤ 10 mg/min)</a:t>
+            </a:r>
+          </a:p>
+        </p:txBody>
+      </p:sp>
+      <p:sp>
+        <p:nvSpPr>
+          <p:cNvPr id="41" name="Segmento 4.1"/>
+          <p:cNvSpPr/>
+          <p:nvPr/>
+        </p:nvSpPr>
+        <p:spPr>
+          <a:xfrm>
+            <a:off x="6024118" y="5740400"/>
+            <a:ext cx="572460" cy="165100"/>
+          </a:xfrm>
+          <a:prstGeom prst="roundRect">
+            <a:avLst>
+              <a:gd name="adj" fmla="val 23076"/>
+            </a:avLst>
+          </a:prstGeom>
+          <a:solidFill>
+            <a:srgbClr val="D42A3B"/>
+          </a:solidFill>
+          <a:ln>
+            <a:noFill/>
+          </a:ln>
+        </p:spPr>
+        <p:txBody>
+          <a:bodyPr rtlCol="0" anchor="ctr"/>
+          <a:lstStyle/>
+          <a:p>
+            <a:pPr algn="ctr"/>
+          </a:p>
+        </p:txBody>
+      </p:sp>
+      <p:sp>
+        <p:nvSpPr>
+          <p:cNvPr id="42" name="Segmento 4.2"/>
+          <p:cNvSpPr/>
+          <p:nvPr/>
+        </p:nvSpPr>
+        <p:spPr>
+          <a:xfrm>
+            <a:off x="6660078" y="5740400"/>
+            <a:ext cx="572460" cy="165100"/>
+          </a:xfrm>
+          <a:prstGeom prst="roundRect">
+            <a:avLst>
+              <a:gd name="adj" fmla="val 23076"/>
+            </a:avLst>
+          </a:prstGeom>
+          <a:solidFill>
+            <a:srgbClr val="D42A3B"/>
+          </a:solidFill>
+          <a:ln>
+            <a:noFill/>
+          </a:ln>
+        </p:spPr>
+        <p:txBody>
+          <a:bodyPr rtlCol="0" anchor="ctr"/>
+          <a:lstStyle/>
+          <a:p>
+            <a:pPr algn="ctr"/>
+          </a:p>
+        </p:txBody>
+      </p:sp>
+      <p:sp>
+        <p:nvSpPr>
+          <p:cNvPr id="43" name="Segmento 4.3"/>
+          <p:cNvSpPr/>
+          <p:nvPr/>
+        </p:nvSpPr>
+        <p:spPr>
+          <a:xfrm>
+            <a:off x="7296037" y="5740400"/>
+            <a:ext cx="572460" cy="165100"/>
+          </a:xfrm>
+          <a:prstGeom prst="roundRect">
+            <a:avLst>
+              <a:gd name="adj" fmla="val 23076"/>
+            </a:avLst>
+          </a:prstGeom>
+          <a:solidFill>
+            <a:srgbClr val="D42A3B"/>
+          </a:solidFill>
+          <a:ln>
+            <a:noFill/>
+          </a:ln>
+        </p:spPr>
+        <p:txBody>
+          <a:bodyPr rtlCol="0" anchor="ctr"/>
+          <a:lstStyle/>
+          <a:p>
+            <a:pPr algn="ctr"/>
+          </a:p>
+        </p:txBody>
+      </p:sp>
+      <p:sp>
+        <p:nvSpPr>
+          <p:cNvPr id="44" name="Segmento 4.4"/>
+          <p:cNvSpPr/>
+          <p:nvPr/>
+        </p:nvSpPr>
+        <p:spPr>
+          <a:xfrm>
+            <a:off x="7931997" y="5740400"/>
+            <a:ext cx="572460" cy="165100"/>
+          </a:xfrm>
+          <a:prstGeom prst="roundRect">
+            <a:avLst>
+              <a:gd name="adj" fmla="val 23076"/>
+            </a:avLst>
+          </a:prstGeom>
+          <a:solidFill>
+            <a:srgbClr val="FFFFFF"/>
+          </a:solidFill>
+          <a:ln w="19050">
+            <a:solidFill>
+              <a:srgbClr val="C9D2DB"/>
+            </a:solidFill>
+          </a:ln>
+        </p:spPr>
+        <p:txBody>
+          <a:bodyPr rtlCol="0" anchor="ctr"/>
+          <a:lstStyle/>
+          <a:p>
+            <a:pPr algn="ctr"/>
+          </a:p>
+        </p:txBody>
+      </p:sp>
+      <p:sp>
+        <p:nvSpPr>
+          <p:cNvPr id="45" name="Segmento 4.5"/>
+          <p:cNvSpPr/>
+          <p:nvPr/>
+        </p:nvSpPr>
+        <p:spPr>
+          <a:xfrm>
+            <a:off x="8567956" y="5740400"/>
+            <a:ext cx="572460" cy="165100"/>
+          </a:xfrm>
+          <a:prstGeom prst="roundRect">
+            <a:avLst>
+              <a:gd name="adj" fmla="val 23076"/>
+            </a:avLst>
+          </a:prstGeom>
+          <a:solidFill>
+            <a:srgbClr val="FFFFFF"/>
+          </a:solidFill>
+          <a:ln w="19050">
+            <a:solidFill>
+              <a:srgbClr val="C9D2DB"/>
+            </a:solidFill>
+          </a:ln>
+        </p:spPr>
+        <p:txBody>
+          <a:bodyPr rtlCol="0" anchor="ctr"/>
+          <a:lstStyle/>
+          <a:p>
+            <a:pPr algn="ctr"/>
+          </a:p>
+        </p:txBody>
+      </p:sp>
+      <p:sp>
+        <p:nvSpPr>
+          <p:cNvPr id="46" name="Segmento 4.6"/>
+          <p:cNvSpPr/>
+          <p:nvPr/>
+        </p:nvSpPr>
+        <p:spPr>
+          <a:xfrm>
+            <a:off x="9203916" y="5740400"/>
+            <a:ext cx="572460" cy="165100"/>
+          </a:xfrm>
+          <a:prstGeom prst="roundRect">
+            <a:avLst>
+              <a:gd name="adj" fmla="val 23076"/>
+            </a:avLst>
+          </a:prstGeom>
+          <a:solidFill>
+            <a:srgbClr val="FFFFFF"/>
+          </a:solidFill>
+          <a:ln w="19050">
+            <a:solidFill>
+              <a:srgbClr val="C9D2DB"/>
+            </a:solidFill>
+          </a:ln>
+        </p:spPr>
+        <p:txBody>
+          <a:bodyPr rtlCol="0" anchor="ctr"/>
+          <a:lstStyle/>
+          <a:p>
+            <a:pPr algn="ctr"/>
+          </a:p>
+        </p:txBody>
+      </p:sp>
+      <p:sp>
+        <p:nvSpPr>
+          <p:cNvPr id="47" name="Segmento 4.7"/>
+          <p:cNvSpPr/>
+          <p:nvPr/>
+        </p:nvSpPr>
+        <p:spPr>
+          <a:xfrm>
+            <a:off x="9839875" y="5740400"/>
+            <a:ext cx="572460" cy="165100"/>
+          </a:xfrm>
+          <a:prstGeom prst="roundRect">
+            <a:avLst>
+              <a:gd name="adj" fmla="val 23076"/>
+            </a:avLst>
+          </a:prstGeom>
+          <a:solidFill>
+            <a:srgbClr val="FFFFFF"/>
+          </a:solidFill>
+          <a:ln w="19050">
+            <a:solidFill>
+              <a:srgbClr val="C9D2DB"/>
+            </a:solidFill>
+          </a:ln>
+        </p:spPr>
+        <p:txBody>
+          <a:bodyPr rtlCol="0" anchor="ctr"/>
+          <a:lstStyle/>
+          <a:p>
+            <a:pPr algn="ctr"/>
+          </a:p>
+        </p:txBody>
+      </p:sp>
+      <p:sp>
+        <p:nvSpPr>
+          <p:cNvPr id="48" name="Segmento 4.8"/>
+          <p:cNvSpPr/>
+          <p:nvPr/>
+        </p:nvSpPr>
+        <p:spPr>
+          <a:xfrm>
+            <a:off x="10475835" y="5740400"/>
+            <a:ext cx="572460" cy="165100"/>
+          </a:xfrm>
+          <a:prstGeom prst="roundRect">
+            <a:avLst>
+              <a:gd name="adj" fmla="val 23076"/>
+            </a:avLst>
+          </a:prstGeom>
+          <a:solidFill>
+            <a:srgbClr val="FFFFFF"/>
+          </a:solidFill>
+          <a:ln w="19050">
+            <a:solidFill>
+              <a:srgbClr val="C9D2DB"/>
+            </a:solidFill>
+          </a:ln>
+        </p:spPr>
+        <p:txBody>
+          <a:bodyPr rtlCol="0" anchor="ctr"/>
+          <a:lstStyle/>
+          <a:p>
+            <a:pPr algn="ctr"/>
+          </a:p>
+        </p:txBody>
+      </p:sp>
+      <p:sp>
+        <p:nvSpPr>
+          <p:cNvPr id="49" name="Segmento 4.9"/>
+          <p:cNvSpPr/>
+          <p:nvPr/>
+        </p:nvSpPr>
+        <p:spPr>
+          <a:xfrm>
+            <a:off x="11111794" y="5740400"/>
+            <a:ext cx="572460" cy="165100"/>
+          </a:xfrm>
+          <a:prstGeom prst="roundRect">
+            <a:avLst>
+              <a:gd name="adj" fmla="val 23076"/>
+            </a:avLst>
+          </a:prstGeom>
+          <a:solidFill>
+            <a:srgbClr val="FFFFFF"/>
+          </a:solidFill>
+          <a:ln w="19050">
+            <a:solidFill>
+              <a:srgbClr val="C9D2DB"/>
+            </a:solidFill>
+          </a:ln>
+        </p:spPr>
+        <p:txBody>
+          <a:bodyPr rtlCol="0" anchor="ctr"/>
+          <a:lstStyle/>
+          <a:p>
+            <a:pPr algn="ctr"/>
+          </a:p>
+        </p:txBody>
+      </p:sp>
+      <p:sp>
+        <p:nvSpPr>
+          <p:cNvPr id="50" name="Fuente"/>
+          <p:cNvSpPr txBox="1"/>
+          <p:nvPr/>
+        </p:nvSpPr>
+        <p:spPr>
+          <a:xfrm>
+            <a:off x="508000" y="6223000"/>
+            <a:ext cx="11176000" cy="355600"/>
+          </a:xfrm>
+          <a:prstGeom prst="rect">
+            <a:avLst/>
+          </a:prstGeom>
+          <a:noFill/>
+        </p:spPr>
+        <p:txBody>
+          <a:bodyPr wrap="square" lIns="0" tIns="0" rIns="0" bIns="0" anchor="b">
+            <a:noAutofit/>
+          </a:bodyPr>
+          <a:lstStyle/>
+          <a:p>
             <a:pPr algn="l"/>
             <a:r>
               <a:rPr sz="1200" b="0" i="0" lang="es-ES">
@@ -4622,7 +3253,7 @@
                   <a:srgbClr val="5E6B78"/>
                 </a:solidFill>
               </a:rPr>
-              <a:t>Elaboración propia · Gemini [versión], Claude [versión], ChatGPT [versión] · octubre de 2026 · Caso simulado (CL 3 L/h, V 60 L)</a:t>
+              <a:t>Elaboración propia · Gemini [versión], ChatGPT [versión], Claude [versión] · octubre de 2026 · Caso simulado (CL 3 L/h, V 60 L) · Ficha técnica vancomicina, AEMPS, apartado 4.2.2</a:t>
             </a:r>
           </a:p>
         </p:txBody>

</xml_diff>